<commit_message>
T75: align poster A-E annotations and compact green header
</commit_message>
<xml_diff>
--- a/outputs/01a11dd5-cc80-7b52-9b9e-86da4e08d924/poster-123/Poster_123.pptx
+++ b/outputs/01a11dd5-cc80-7b52-9b9e-86da4e08d924/poster-123/Poster_123.pptx
@@ -2,13 +2,13 @@
 <file path=ppt/presentation.xml><?xml version="1.0" encoding="utf-8"?>
 <p:presentation xmlns:p="http://schemas.openxmlformats.org/presentationml/2006/main">
   <p:sldMasterIdLst>
-    <p:sldMasterId xmlns:r="http://schemas.openxmlformats.org/officeDocument/2006/relationships" id="2147483648" r:id="R2bf54e9e3f0a46bf"/>
+    <p:sldMasterId xmlns:r="http://schemas.openxmlformats.org/officeDocument/2006/relationships" id="2147483648" r:id="R27f46aa886224b8a"/>
   </p:sldMasterIdLst>
   <p:notesMasterIdLst>
-    <p:notesMasterId xmlns:r="http://schemas.openxmlformats.org/officeDocument/2006/relationships" r:id="R5fa2b0d9c1a147e6"/>
+    <p:notesMasterId xmlns:r="http://schemas.openxmlformats.org/officeDocument/2006/relationships" r:id="R444b162b4d2a4b15"/>
   </p:notesMasterIdLst>
   <p:sldIdLst>
-    <p:sldId xmlns:r="http://schemas.openxmlformats.org/officeDocument/2006/relationships" id="256" r:id="R657a5427e4894338"/>
+    <p:sldId xmlns:r="http://schemas.openxmlformats.org/officeDocument/2006/relationships" id="256" r:id="R9df1b40a96bc4b55"/>
   </p:sldIdLst>
   <p:sldSz cx="21816000" cy="30708000"/>
   <p:notesSz cx="6858000" cy="9144000"/>
@@ -652,7 +652,7 @@
   </p:cSld>
   <p:clrMap bg1="lt1" tx1="dk1" bg2="lt2" tx2="dk2" accent1="accent1" accent2="accent2" accent3="accent3" accent4="accent4" accent5="accent5" accent6="accent6" hlink="hlink" folHlink="folHlink"/>
   <p:sldLayoutIdLst>
-    <p:sldLayoutId xmlns:r="http://schemas.openxmlformats.org/officeDocument/2006/relationships" id="2147483649" r:id="Rbfafc48b54c2415b"/>
+    <p:sldLayoutId xmlns:r="http://schemas.openxmlformats.org/officeDocument/2006/relationships" id="2147483649" r:id="R375e040772a74b1e"/>
   </p:sldLayoutIdLst>
   <p:hf sldNum="0" hdr="0" ftr="0" dt="0"/>
   <p:txStyles>
@@ -2297,16 +2297,16 @@
       </p:grpSpPr>
       <p:cxnSp>
         <p:nvCxnSpPr>
-          <p:cNvPr id="50" name="">
+          <p:cNvPr id="55" name="">
             <a:extLst xmlns:a="http://schemas.openxmlformats.org/drawingml/2006/main">
               <a:ext uri="{FF2B5EF4-FFF2-40B4-BE49-F238E27FC236}">
-                <a16:creationId xmlns:a16="http://schemas.microsoft.com/office/drawing/2014/main" id="{4DA622F3-A8B5-45EF-BDC3-4E823830739B}"/>
+                <a16:creationId xmlns:a16="http://schemas.microsoft.com/office/drawing/2014/main" id="{3981E599-38C2-49AD-9E26-96C73D76B458}"/>
               </a:ext>
             </a:extLst>
           </p:cNvPr>
           <p:cNvCxnSpPr>
-            <a:stCxn xmlns:a="http://schemas.openxmlformats.org/drawingml/2006/main" id="41" idx="3"/>
-            <a:endCxn xmlns:a="http://schemas.openxmlformats.org/drawingml/2006/main" id="44" idx="1"/>
+            <a:stCxn xmlns:a="http://schemas.openxmlformats.org/drawingml/2006/main" id="46" idx="3"/>
+            <a:endCxn xmlns:a="http://schemas.openxmlformats.org/drawingml/2006/main" id="49" idx="1"/>
           </p:cNvCxnSpPr>
           <p:nvPr/>
         </p:nvCxnSpPr>
@@ -2329,16 +2329,16 @@
       </p:cxnSp>
       <p:cxnSp>
         <p:nvCxnSpPr>
-          <p:cNvPr id="49" name="">
+          <p:cNvPr id="54" name="">
             <a:extLst xmlns:a="http://schemas.openxmlformats.org/drawingml/2006/main">
               <a:ext uri="{FF2B5EF4-FFF2-40B4-BE49-F238E27FC236}">
-                <a16:creationId xmlns:a16="http://schemas.microsoft.com/office/drawing/2014/main" id="{D66C4DB1-DD6A-413F-BB21-AA4D7B3F5665}"/>
+                <a16:creationId xmlns:a16="http://schemas.microsoft.com/office/drawing/2014/main" id="{77B1D8D7-A45D-43E2-A978-C37D4C0582E3}"/>
               </a:ext>
             </a:extLst>
           </p:cNvPr>
           <p:cNvCxnSpPr>
-            <a:stCxn xmlns:a="http://schemas.openxmlformats.org/drawingml/2006/main" id="38" idx="3"/>
-            <a:endCxn xmlns:a="http://schemas.openxmlformats.org/drawingml/2006/main" id="41" idx="1"/>
+            <a:stCxn xmlns:a="http://schemas.openxmlformats.org/drawingml/2006/main" id="43" idx="3"/>
+            <a:endCxn xmlns:a="http://schemas.openxmlformats.org/drawingml/2006/main" id="46" idx="1"/>
           </p:cNvCxnSpPr>
           <p:nvPr/>
         </p:nvCxnSpPr>
@@ -2361,16 +2361,16 @@
       </p:cxnSp>
       <p:cxnSp>
         <p:nvCxnSpPr>
-          <p:cNvPr id="48" name="">
+          <p:cNvPr id="53" name="">
             <a:extLst xmlns:a="http://schemas.openxmlformats.org/drawingml/2006/main">
               <a:ext uri="{FF2B5EF4-FFF2-40B4-BE49-F238E27FC236}">
-                <a16:creationId xmlns:a16="http://schemas.microsoft.com/office/drawing/2014/main" id="{345B6579-E75B-4B0D-AE60-96CB22692A9A}"/>
+                <a16:creationId xmlns:a16="http://schemas.microsoft.com/office/drawing/2014/main" id="{E1D72129-E858-43D0-8238-018F90666C37}"/>
               </a:ext>
             </a:extLst>
           </p:cNvPr>
           <p:cNvCxnSpPr>
-            <a:stCxn xmlns:a="http://schemas.openxmlformats.org/drawingml/2006/main" id="35" idx="3"/>
-            <a:endCxn xmlns:a="http://schemas.openxmlformats.org/drawingml/2006/main" id="38" idx="1"/>
+            <a:stCxn xmlns:a="http://schemas.openxmlformats.org/drawingml/2006/main" id="40" idx="3"/>
+            <a:endCxn xmlns:a="http://schemas.openxmlformats.org/drawingml/2006/main" id="43" idx="1"/>
           </p:cNvCxnSpPr>
           <p:nvPr/>
         </p:nvCxnSpPr>
@@ -2393,16 +2393,16 @@
       </p:cxnSp>
       <p:cxnSp>
         <p:nvCxnSpPr>
-          <p:cNvPr id="47" name="">
+          <p:cNvPr id="52" name="">
             <a:extLst xmlns:a="http://schemas.openxmlformats.org/drawingml/2006/main">
               <a:ext uri="{FF2B5EF4-FFF2-40B4-BE49-F238E27FC236}">
-                <a16:creationId xmlns:a16="http://schemas.microsoft.com/office/drawing/2014/main" id="{DE8EA407-C18B-47CD-898D-16F1D270D8B5}"/>
+                <a16:creationId xmlns:a16="http://schemas.microsoft.com/office/drawing/2014/main" id="{4E5321A5-4BCB-4A86-801C-C08C9A2E1115}"/>
               </a:ext>
             </a:extLst>
           </p:cNvPr>
           <p:cNvCxnSpPr>
-            <a:stCxn xmlns:a="http://schemas.openxmlformats.org/drawingml/2006/main" id="32" idx="3"/>
-            <a:endCxn xmlns:a="http://schemas.openxmlformats.org/drawingml/2006/main" id="35" idx="1"/>
+            <a:stCxn xmlns:a="http://schemas.openxmlformats.org/drawingml/2006/main" id="37" idx="3"/>
+            <a:endCxn xmlns:a="http://schemas.openxmlformats.org/drawingml/2006/main" id="40" idx="1"/>
           </p:cNvCxnSpPr>
           <p:nvPr/>
         </p:nvCxnSpPr>
@@ -2428,7 +2428,7 @@
           <p:cNvPr id="2" name="Shape 0">
             <a:extLst xmlns:a="http://schemas.openxmlformats.org/drawingml/2006/main">
               <a:ext uri="{FF2B5EF4-FFF2-40B4-BE49-F238E27FC236}">
-                <a16:creationId xmlns:a16="http://schemas.microsoft.com/office/drawing/2014/main" id="{A5B7F514-BF66-4F9A-B0BD-21CEA7F7C6C1}"/>
+                <a16:creationId xmlns:a16="http://schemas.microsoft.com/office/drawing/2014/main" id="{8603DC4E-BFF3-4EF6-8F69-0F478C12D2F6}"/>
               </a:ext>
             </a:extLst>
           </p:cNvPr>
@@ -2440,7 +2440,7 @@
         <p:spPr>
           <a:xfrm xmlns:a="http://schemas.openxmlformats.org/drawingml/2006/main">
             <a:off x="0" y="0"/>
-            <a:ext cx="21816000" cy="4370832"/>
+            <a:ext cx="21816000" cy="3996000"/>
           </a:xfrm>
           <a:prstGeom xmlns:a="http://schemas.openxmlformats.org/drawingml/2006/main" prst="rect">
             <a:avLst/>
@@ -2455,7 +2455,7 @@
           <p:cNvPr id="3" name="Image 0">
             <a:extLst xmlns:a="http://schemas.openxmlformats.org/drawingml/2006/main">
               <a:ext uri="{FF2B5EF4-FFF2-40B4-BE49-F238E27FC236}">
-                <a16:creationId xmlns:a16="http://schemas.microsoft.com/office/drawing/2014/main" id="{1016EB36-F477-4CE0-8479-656417312A55}"/>
+                <a16:creationId xmlns:a16="http://schemas.microsoft.com/office/drawing/2014/main" id="{DB56F96D-AEDA-454E-8277-56CB4BD643CF}"/>
               </a:ext>
             </a:extLst>
           </p:cNvPr>
@@ -2465,7 +2465,7 @@
           <p:nvPr/>
         </p:nvPicPr>
         <p:blipFill>
-          <a:blip xmlns:r="http://schemas.openxmlformats.org/officeDocument/2006/relationships" xmlns:a="http://schemas.openxmlformats.org/drawingml/2006/main" r:embed="Rea3839af255a4300"/>
+          <a:blip xmlns:r="http://schemas.openxmlformats.org/officeDocument/2006/relationships" xmlns:a="http://schemas.openxmlformats.org/drawingml/2006/main" r:embed="R833ebd392d1240fe"/>
           <a:stretch xmlns:a="http://schemas.openxmlformats.org/drawingml/2006/main">
             <a:fillRect l="0" t="0" r="0" b="0"/>
           </a:stretch>
@@ -2482,10 +2482,10 @@
       </p:pic>
       <p:sp>
         <p:nvSpPr>
-          <p:cNvPr id="4" name="Text 1">
+          <p:cNvPr id="4" name="Header project number">
             <a:extLst xmlns:a="http://schemas.openxmlformats.org/drawingml/2006/main">
               <a:ext uri="{FF2B5EF4-FFF2-40B4-BE49-F238E27FC236}">
-                <a16:creationId xmlns:a16="http://schemas.microsoft.com/office/drawing/2014/main" id="{D8CCFC7B-942F-49B5-A901-9ADCD0E3B7CB}"/>
+                <a16:creationId xmlns:a16="http://schemas.microsoft.com/office/drawing/2014/main" id="{83363B27-6357-40EE-9CB8-35726DAF8A4E}"/>
               </a:ext>
             </a:extLst>
           </p:cNvPr>
@@ -2496,85 +2496,68 @@
         </p:nvSpPr>
         <p:spPr>
           <a:xfrm xmlns:a="http://schemas.openxmlformats.org/drawingml/2006/main">
-            <a:off x="10888920" y="658368"/>
-            <a:ext cx="10058400" cy="1234440"/>
+            <a:off x="10889172" y="540000"/>
+            <a:ext cx="10058400" cy="432000"/>
           </a:xfrm>
           <a:prstGeom xmlns:a="http://schemas.openxmlformats.org/drawingml/2006/main" prst="rect">
             <a:avLst/>
           </a:prstGeom>
           <a:noFill xmlns:a="http://schemas.openxmlformats.org/drawingml/2006/main"/>
+          <a:ln xmlns:a="http://schemas.openxmlformats.org/drawingml/2006/main" w="0">
+            <a:noFill/>
+          </a:ln>
         </p:spPr>
         <p:txBody>
-          <a:bodyPr xmlns:a="http://schemas.openxmlformats.org/drawingml/2006/main" wrap="square" lIns="0" tIns="0" rIns="0" bIns="0" anchor="t"/>
-          <a:lstStyle xmlns:a="http://schemas.openxmlformats.org/drawingml/2006/main"/>
-          <a:p xmlns:a="http://schemas.openxmlformats.org/drawingml/2006/main">
-            <a:pPr marL="0" indent="0" algn="r">
+          <a:bodyPr xmlns:a="http://schemas.openxmlformats.org/drawingml/2006/main" wrap="square" lIns="0" tIns="0" rIns="0" bIns="0" anchor="t">
+            <a:noAutofit/>
+          </a:bodyPr>
+          <a:lstStyle xmlns:a="http://schemas.openxmlformats.org/drawingml/2006/main">
+            <a:defPPr algn="r">
+              <a:defRPr sz="2800" b="1" i="0">
+                <a:solidFill>
+                  <a:srgbClr val="F2C14E"/>
+                </a:solidFill>
+                <a:latin typeface="Calibri"/>
+                <a:ea typeface="Calibri"/>
+                <a:cs typeface="Calibri"/>
+              </a:defRPr>
+            </a:defPPr>
+          </a:lstStyle>
+          <a:p xmlns:a="http://schemas.openxmlformats.org/drawingml/2006/main">
+            <a:pPr algn="r">
               <a:lnSpc>
-                <a:spcPct val="95000"/>
+                <a:spcPct val="108000"/>
               </a:lnSpc>
               <a:buNone/>
-            </a:pPr>
-            <a:r>
-              <a:rPr sz="3200" b="1">
+              <a:defRPr sz="2800" b="1" i="0">
                 <a:solidFill>
                   <a:srgbClr val="F2C14E"/>
                 </a:solidFill>
                 <a:latin typeface="Calibri"/>
                 <a:ea typeface="Calibri"/>
                 <a:cs typeface="Calibri"/>
+              </a:defRPr>
+            </a:pPr>
+            <a:r>
+              <a:rPr sz="2800" b="1" i="0">
+                <a:solidFill>
+                  <a:srgbClr val="F2C14E"/>
+                </a:solidFill>
+                <a:latin typeface="Calibri"/>
+                <a:ea typeface="Calibri"/>
+                <a:cs typeface="Calibri"/>
               </a:rPr>
               <a:t>Part IV Project #123</a:t>
             </a:r>
-            <a:endParaRPr sz="3200"/>
-          </a:p>
-          <a:p xmlns:a="http://schemas.openxmlformats.org/drawingml/2006/main">
-            <a:pPr marL="0" indent="0" algn="r">
-              <a:lnSpc>
-                <a:spcPct val="95000"/>
-              </a:lnSpc>
-              <a:buNone/>
-            </a:pPr>
-            <a:r>
-              <a:rPr sz="2600">
-                <a:solidFill>
-                  <a:srgbClr val="E6EFE9"/>
-                </a:solidFill>
-                <a:latin typeface="Calibri"/>
-                <a:ea typeface="Calibri"/>
-                <a:cs typeface="Calibri"/>
-              </a:rPr>
-              <a:t>Department of Electrical, Computer,</a:t>
-            </a:r>
-            <a:endParaRPr sz="3200"/>
-          </a:p>
-          <a:p xmlns:a="http://schemas.openxmlformats.org/drawingml/2006/main">
-            <a:pPr marL="0" indent="0" algn="r">
-              <a:lnSpc>
-                <a:spcPct val="95000"/>
-              </a:lnSpc>
-              <a:buNone/>
-            </a:pPr>
-            <a:r>
-              <a:rPr sz="2600">
-                <a:solidFill>
-                  <a:srgbClr val="E6EFE9"/>
-                </a:solidFill>
-                <a:latin typeface="Calibri"/>
-                <a:ea typeface="Calibri"/>
-                <a:cs typeface="Calibri"/>
-              </a:rPr>
-              <a:t>and Software Engineering</a:t>
-            </a:r>
-            <a:endParaRPr sz="3200"/>
           </a:p>
         </p:txBody>
       </p:sp>
       <p:sp>
         <p:nvSpPr>
-          <p:cNvPr id="5" name="Text 2">
+          <p:cNvPr id="5" name="Header department">
             <a:extLst xmlns:a="http://schemas.openxmlformats.org/drawingml/2006/main">
               <a:ext uri="{FF2B5EF4-FFF2-40B4-BE49-F238E27FC236}">
-                <a16:creationId xmlns:a16="http://schemas.microsoft.com/office/drawing/2014/main" id="{6E7F33AC-3D7C-41A5-BFB9-4B18E60E6C3F}"/>
+                <a16:creationId xmlns:a16="http://schemas.microsoft.com/office/drawing/2014/main" id="{D26F411B-CA1D-4906-B224-B1798F463C82}"/>
               </a:ext>
             </a:extLst>
           </p:cNvPr>
@@ -2585,42 +2568,95 @@
         </p:nvSpPr>
         <p:spPr>
           <a:xfrm xmlns:a="http://schemas.openxmlformats.org/drawingml/2006/main">
-            <a:off x="868680" y="1783080"/>
-            <a:ext cx="20078640" cy="1261872"/>
+            <a:off x="10889172" y="1044000"/>
+            <a:ext cx="10058400" cy="720000"/>
           </a:xfrm>
           <a:prstGeom xmlns:a="http://schemas.openxmlformats.org/drawingml/2006/main" prst="rect">
             <a:avLst/>
           </a:prstGeom>
           <a:noFill xmlns:a="http://schemas.openxmlformats.org/drawingml/2006/main"/>
+          <a:ln xmlns:a="http://schemas.openxmlformats.org/drawingml/2006/main" w="0">
+            <a:noFill/>
+          </a:ln>
         </p:spPr>
         <p:txBody>
-          <a:bodyPr xmlns:a="http://schemas.openxmlformats.org/drawingml/2006/main" wrap="square" lIns="0" tIns="0" rIns="0" bIns="0" anchor="t"/>
-          <a:lstStyle xmlns:a="http://schemas.openxmlformats.org/drawingml/2006/main"/>
-          <a:p xmlns:a="http://schemas.openxmlformats.org/drawingml/2006/main">
-            <a:pPr marL="0" indent="0">
+          <a:bodyPr xmlns:a="http://schemas.openxmlformats.org/drawingml/2006/main" wrap="square" lIns="0" tIns="0" rIns="0" bIns="0" anchor="t">
+            <a:noAutofit/>
+          </a:bodyPr>
+          <a:lstStyle xmlns:a="http://schemas.openxmlformats.org/drawingml/2006/main">
+            <a:defPPr algn="r">
+              <a:defRPr sz="2200" b="0" i="0">
+                <a:solidFill>
+                  <a:srgbClr val="E6EFE9"/>
+                </a:solidFill>
+                <a:latin typeface="Calibri"/>
+                <a:ea typeface="Calibri"/>
+                <a:cs typeface="Calibri"/>
+              </a:defRPr>
+            </a:defPPr>
+          </a:lstStyle>
+          <a:p xmlns:a="http://schemas.openxmlformats.org/drawingml/2006/main">
+            <a:pPr algn="r">
+              <a:lnSpc>
+                <a:spcPct val="108000"/>
+              </a:lnSpc>
               <a:buNone/>
-            </a:pPr>
-            <a:r>
-              <a:rPr sz="9400" b="1">
-                <a:solidFill>
-                  <a:srgbClr val="FFFFFF"/>
-                </a:solidFill>
-                <a:latin typeface="Cambria"/>
-                <a:ea typeface="Cambria"/>
-                <a:cs typeface="Cambria"/>
-              </a:rPr>
-              <a:t>AI-Based Virtual Parliament</a:t>
-            </a:r>
-            <a:endParaRPr sz="9400"/>
+              <a:defRPr sz="2200" b="0" i="0">
+                <a:solidFill>
+                  <a:srgbClr val="E6EFE9"/>
+                </a:solidFill>
+                <a:latin typeface="Calibri"/>
+                <a:ea typeface="Calibri"/>
+                <a:cs typeface="Calibri"/>
+              </a:defRPr>
+            </a:pPr>
+            <a:r>
+              <a:rPr sz="2200" b="0" i="0">
+                <a:solidFill>
+                  <a:srgbClr val="E6EFE9"/>
+                </a:solidFill>
+                <a:latin typeface="Calibri"/>
+                <a:ea typeface="Calibri"/>
+                <a:cs typeface="Calibri"/>
+              </a:rPr>
+              <a:t>Department of Electrical, Computer,</a:t>
+            </a:r>
+          </a:p>
+          <a:p xmlns:a="http://schemas.openxmlformats.org/drawingml/2006/main">
+            <a:pPr algn="r">
+              <a:lnSpc>
+                <a:spcPct val="108000"/>
+              </a:lnSpc>
+              <a:buNone/>
+              <a:defRPr sz="2200" b="0" i="0">
+                <a:solidFill>
+                  <a:srgbClr val="E6EFE9"/>
+                </a:solidFill>
+                <a:latin typeface="Calibri"/>
+                <a:ea typeface="Calibri"/>
+                <a:cs typeface="Calibri"/>
+              </a:defRPr>
+            </a:pPr>
+            <a:r>
+              <a:rPr sz="2200" b="0" i="0">
+                <a:solidFill>
+                  <a:srgbClr val="E6EFE9"/>
+                </a:solidFill>
+                <a:latin typeface="Calibri"/>
+                <a:ea typeface="Calibri"/>
+                <a:cs typeface="Calibri"/>
+              </a:rPr>
+              <a:t>and Software Engineering</a:t>
+            </a:r>
           </a:p>
         </p:txBody>
       </p:sp>
       <p:sp>
         <p:nvSpPr>
-          <p:cNvPr id="6" name="Text 3">
+          <p:cNvPr id="6" name="Header title">
             <a:extLst xmlns:a="http://schemas.openxmlformats.org/drawingml/2006/main">
               <a:ext uri="{FF2B5EF4-FFF2-40B4-BE49-F238E27FC236}">
-                <a16:creationId xmlns:a16="http://schemas.microsoft.com/office/drawing/2014/main" id="{6AA9864A-9595-4D4C-B91C-532746ACE060}"/>
+                <a16:creationId xmlns:a16="http://schemas.microsoft.com/office/drawing/2014/main" id="{CC0F31FF-C0D9-4F8F-ABDA-6EE60FDD0B92}"/>
               </a:ext>
             </a:extLst>
           </p:cNvPr>
@@ -2631,42 +2667,68 @@
         </p:nvSpPr>
         <p:spPr>
           <a:xfrm xmlns:a="http://schemas.openxmlformats.org/drawingml/2006/main">
-            <a:off x="868680" y="3090672"/>
-            <a:ext cx="20078640" cy="621792"/>
+            <a:off x="868680" y="1692000"/>
+            <a:ext cx="20078640" cy="1152000"/>
           </a:xfrm>
           <a:prstGeom xmlns:a="http://schemas.openxmlformats.org/drawingml/2006/main" prst="rect">
             <a:avLst/>
           </a:prstGeom>
           <a:noFill xmlns:a="http://schemas.openxmlformats.org/drawingml/2006/main"/>
+          <a:ln xmlns:a="http://schemas.openxmlformats.org/drawingml/2006/main" w="0">
+            <a:noFill/>
+          </a:ln>
         </p:spPr>
         <p:txBody>
-          <a:bodyPr xmlns:a="http://schemas.openxmlformats.org/drawingml/2006/main" wrap="square" lIns="0" tIns="0" rIns="0" bIns="0" anchor="t"/>
-          <a:lstStyle xmlns:a="http://schemas.openxmlformats.org/drawingml/2006/main"/>
-          <a:p xmlns:a="http://schemas.openxmlformats.org/drawingml/2006/main">
-            <a:pPr marL="0" indent="0">
+          <a:bodyPr xmlns:a="http://schemas.openxmlformats.org/drawingml/2006/main" wrap="square" lIns="0" tIns="0" rIns="0" bIns="0" anchor="t">
+            <a:noAutofit/>
+          </a:bodyPr>
+          <a:lstStyle xmlns:a="http://schemas.openxmlformats.org/drawingml/2006/main">
+            <a:defPPr algn="l">
+              <a:defRPr sz="8400" b="1" i="0">
+                <a:solidFill>
+                  <a:srgbClr val="FFFFFF"/>
+                </a:solidFill>
+                <a:latin typeface="Cambria"/>
+                <a:ea typeface="Cambria"/>
+                <a:cs typeface="Cambria"/>
+              </a:defRPr>
+            </a:defPPr>
+          </a:lstStyle>
+          <a:p xmlns:a="http://schemas.openxmlformats.org/drawingml/2006/main">
+            <a:pPr algn="l">
+              <a:lnSpc>
+                <a:spcPct val="108000"/>
+              </a:lnSpc>
               <a:buNone/>
-            </a:pPr>
-            <a:r>
-              <a:rPr sz="4400" i="1">
-                <a:solidFill>
-                  <a:srgbClr val="F2C14E"/>
-                </a:solidFill>
-                <a:latin typeface="Cambria"/>
-                <a:ea typeface="Cambria"/>
-                <a:cs typeface="Cambria"/>
-              </a:rPr>
-              <a:t>Does more Hansard grounding improve AI debate?</a:t>
-            </a:r>
-            <a:endParaRPr sz="4400"/>
+              <a:defRPr sz="8400" b="1" i="0">
+                <a:solidFill>
+                  <a:srgbClr val="FFFFFF"/>
+                </a:solidFill>
+                <a:latin typeface="Cambria"/>
+                <a:ea typeface="Cambria"/>
+                <a:cs typeface="Cambria"/>
+              </a:defRPr>
+            </a:pPr>
+            <a:r>
+              <a:rPr sz="8400" b="1" i="0">
+                <a:solidFill>
+                  <a:srgbClr val="FFFFFF"/>
+                </a:solidFill>
+                <a:latin typeface="Cambria"/>
+                <a:ea typeface="Cambria"/>
+                <a:cs typeface="Cambria"/>
+              </a:rPr>
+              <a:t>AI-Based Virtual Parliament</a:t>
+            </a:r>
           </a:p>
         </p:txBody>
       </p:sp>
       <p:sp>
         <p:nvSpPr>
-          <p:cNvPr id="7" name="Text 4">
+          <p:cNvPr id="7" name="Header research question">
             <a:extLst xmlns:a="http://schemas.openxmlformats.org/drawingml/2006/main">
               <a:ext uri="{FF2B5EF4-FFF2-40B4-BE49-F238E27FC236}">
-                <a16:creationId xmlns:a16="http://schemas.microsoft.com/office/drawing/2014/main" id="{23363BC4-A9CE-48EB-8715-1F14B6BA609C}"/>
+                <a16:creationId xmlns:a16="http://schemas.microsoft.com/office/drawing/2014/main" id="{7E0CD887-6481-4FC3-B793-3E9705AB3581}"/>
               </a:ext>
             </a:extLst>
           </p:cNvPr>
@@ -2677,53 +2739,68 @@
         </p:nvSpPr>
         <p:spPr>
           <a:xfrm xmlns:a="http://schemas.openxmlformats.org/drawingml/2006/main">
-            <a:off x="868680" y="3730752"/>
-            <a:ext cx="20078640" cy="475488"/>
+            <a:off x="868680" y="2844000"/>
+            <a:ext cx="20078640" cy="540000"/>
           </a:xfrm>
           <a:prstGeom xmlns:a="http://schemas.openxmlformats.org/drawingml/2006/main" prst="rect">
             <a:avLst/>
           </a:prstGeom>
           <a:noFill xmlns:a="http://schemas.openxmlformats.org/drawingml/2006/main"/>
+          <a:ln xmlns:a="http://schemas.openxmlformats.org/drawingml/2006/main" w="0">
+            <a:noFill/>
+          </a:ln>
         </p:spPr>
         <p:txBody>
-          <a:bodyPr xmlns:a="http://schemas.openxmlformats.org/drawingml/2006/main" wrap="square" lIns="0" tIns="0" rIns="0" bIns="0" anchor="t"/>
-          <a:lstStyle xmlns:a="http://schemas.openxmlformats.org/drawingml/2006/main"/>
-          <a:p xmlns:a="http://schemas.openxmlformats.org/drawingml/2006/main">
-            <a:pPr marL="0" indent="0">
+          <a:bodyPr xmlns:a="http://schemas.openxmlformats.org/drawingml/2006/main" wrap="square" lIns="0" tIns="0" rIns="0" bIns="0" anchor="t">
+            <a:noAutofit/>
+          </a:bodyPr>
+          <a:lstStyle xmlns:a="http://schemas.openxmlformats.org/drawingml/2006/main">
+            <a:defPPr algn="l">
+              <a:defRPr sz="3600" b="0" i="1">
+                <a:solidFill>
+                  <a:srgbClr val="F2C14E"/>
+                </a:solidFill>
+                <a:latin typeface="Cambria"/>
+                <a:ea typeface="Cambria"/>
+                <a:cs typeface="Cambria"/>
+              </a:defRPr>
+            </a:defPPr>
+          </a:lstStyle>
+          <a:p xmlns:a="http://schemas.openxmlformats.org/drawingml/2006/main">
+            <a:pPr algn="l">
+              <a:lnSpc>
+                <a:spcPct val="108000"/>
+              </a:lnSpc>
               <a:buNone/>
-            </a:pPr>
-            <a:r>
-              <a:rPr sz="3600" b="1">
-                <a:solidFill>
-                  <a:srgbClr val="FFFFFF"/>
-                </a:solidFill>
-                <a:latin typeface="Calibri"/>
-                <a:ea typeface="Calibri"/>
-                <a:cs typeface="Calibri"/>
-              </a:rPr>
-              <a:t>Albert Sun &amp; Kieran Joe</a:t>
-            </a:r>
-            <a:r>
-              <a:rPr sz="3600">
-                <a:solidFill>
-                  <a:srgbClr val="FFFFFF"/>
-                </a:solidFill>
-                <a:latin typeface="Calibri"/>
-                <a:ea typeface="Calibri"/>
-                <a:cs typeface="Calibri"/>
-              </a:rPr>
-              <a:t>   ·   Supervisor: Dr Joerg Wicker</a:t>
-            </a:r>
-            <a:endParaRPr sz="3600"/>
+              <a:defRPr sz="3600" b="0" i="1">
+                <a:solidFill>
+                  <a:srgbClr val="F2C14E"/>
+                </a:solidFill>
+                <a:latin typeface="Cambria"/>
+                <a:ea typeface="Cambria"/>
+                <a:cs typeface="Cambria"/>
+              </a:defRPr>
+            </a:pPr>
+            <a:r>
+              <a:rPr sz="3600" b="0" i="1">
+                <a:solidFill>
+                  <a:srgbClr val="F2C14E"/>
+                </a:solidFill>
+                <a:latin typeface="Cambria"/>
+                <a:ea typeface="Cambria"/>
+                <a:cs typeface="Cambria"/>
+              </a:rPr>
+              <a:t>Does more Hansard grounding improve AI debate?</a:t>
+            </a:r>
           </a:p>
         </p:txBody>
       </p:sp>
       <p:sp>
         <p:nvSpPr>
-          <p:cNvPr id="8" name="Project overview">
+          <p:cNvPr id="8" name="Header authors">
             <a:extLst xmlns:a="http://schemas.openxmlformats.org/drawingml/2006/main">
               <a:ext uri="{FF2B5EF4-FFF2-40B4-BE49-F238E27FC236}">
-                <a16:creationId xmlns:a16="http://schemas.microsoft.com/office/drawing/2014/main" id="{A3DD3CBA-56E5-4CC4-985B-619B479A68DB}"/>
+                <a16:creationId xmlns:a16="http://schemas.microsoft.com/office/drawing/2014/main" id="{3EA05631-0FD8-4D05-A5C9-40B0D09D459C}"/>
               </a:ext>
             </a:extLst>
           </p:cNvPr>
@@ -2734,8 +2811,8 @@
         </p:nvSpPr>
         <p:spPr>
           <a:xfrm xmlns:a="http://schemas.openxmlformats.org/drawingml/2006/main">
-            <a:off x="868680" y="4680000"/>
-            <a:ext cx="20078640" cy="1008000"/>
+            <a:off x="868680" y="3456000"/>
+            <a:ext cx="20078640" cy="432000"/>
           </a:xfrm>
           <a:prstGeom xmlns:a="http://schemas.openxmlformats.org/drawingml/2006/main" prst="rect">
             <a:avLst/>
@@ -2751,9 +2828,9 @@
           </a:bodyPr>
           <a:lstStyle xmlns:a="http://schemas.openxmlformats.org/drawingml/2006/main">
             <a:defPPr algn="l">
-              <a:defRPr sz="3300" b="0" i="0">
-                <a:solidFill>
-                  <a:srgbClr val="1F2A24"/>
+              <a:defRPr sz="2800" b="0" i="0">
+                <a:solidFill>
+                  <a:srgbClr val="FFFFFF"/>
                 </a:solidFill>
                 <a:latin typeface="Calibri"/>
                 <a:ea typeface="Calibri"/>
@@ -2767,35 +2844,46 @@
                 <a:spcPct val="108000"/>
               </a:lnSpc>
               <a:buNone/>
-              <a:defRPr sz="3300" b="0" i="0">
-                <a:solidFill>
-                  <a:srgbClr val="1F2A24"/>
-                </a:solidFill>
-                <a:latin typeface="Calibri"/>
-                <a:ea typeface="Calibri"/>
-                <a:cs typeface="Calibri"/>
-              </a:defRPr>
-            </a:pPr>
-            <a:r>
-              <a:rPr sz="3300" b="0" i="0">
-                <a:solidFill>
-                  <a:srgbClr val="1F2A24"/>
-                </a:solidFill>
-                <a:latin typeface="Calibri"/>
-                <a:ea typeface="Calibri"/>
-                <a:cs typeface="Calibri"/>
-              </a:rPr>
-              <a:t>We built a virtual New Zealand Parliament to study how language models debate. We tested whether more Hansard excerpts, drawn from real parliamentary speeches, improve debate quality.</a:t>
+              <a:defRPr sz="2800" b="0" i="0">
+                <a:solidFill>
+                  <a:srgbClr val="FFFFFF"/>
+                </a:solidFill>
+                <a:latin typeface="Calibri"/>
+                <a:ea typeface="Calibri"/>
+                <a:cs typeface="Calibri"/>
+              </a:defRPr>
+            </a:pPr>
+            <a:r>
+              <a:rPr sz="2800" b="1" i="0">
+                <a:solidFill>
+                  <a:srgbClr val="FFFFFF"/>
+                </a:solidFill>
+                <a:latin typeface="Calibri"/>
+                <a:ea typeface="Calibri"/>
+                <a:cs typeface="Calibri"/>
+              </a:rPr>
+              <a:t>Albert Sun &amp; Kieran Joe</a:t>
+            </a:r>
+            <a:r>
+              <a:rPr sz="2800" b="0" i="0">
+                <a:solidFill>
+                  <a:srgbClr val="FFFFFF"/>
+                </a:solidFill>
+                <a:latin typeface="Calibri"/>
+                <a:ea typeface="Calibri"/>
+                <a:cs typeface="Calibri"/>
+              </a:rPr>
+              <a:t>   ·   Supervisor: Dr Joerg Wicker</a:t>
             </a:r>
           </a:p>
         </p:txBody>
       </p:sp>
       <p:sp>
         <p:nvSpPr>
-          <p:cNvPr id="9" name="Section 1 number">
+          <p:cNvPr id="9" name="Project overview">
             <a:extLst xmlns:a="http://schemas.openxmlformats.org/drawingml/2006/main">
               <a:ext uri="{FF2B5EF4-FFF2-40B4-BE49-F238E27FC236}">
-                <a16:creationId xmlns:a16="http://schemas.microsoft.com/office/drawing/2014/main" id="{29B58222-2B81-43AF-AB3B-A07A27F22E7A}"/>
+                <a16:creationId xmlns:a16="http://schemas.microsoft.com/office/drawing/2014/main" id="{C9391CE4-783D-4D43-A498-2867AE544909}"/>
               </a:ext>
             </a:extLst>
           </p:cNvPr>
@@ -2806,65 +2894,68 @@
         </p:nvSpPr>
         <p:spPr>
           <a:xfrm xmlns:a="http://schemas.openxmlformats.org/drawingml/2006/main">
-            <a:off x="868680" y="5940000"/>
-            <a:ext cx="712800" cy="712800"/>
+            <a:off x="868680" y="4248000"/>
+            <a:ext cx="20078640" cy="936000"/>
           </a:xfrm>
-          <a:prstGeom xmlns:a="http://schemas.openxmlformats.org/drawingml/2006/main" prst="ellipse">
-            <a:avLst/>
-          </a:prstGeom>
-          <a:solidFill xmlns:a="http://schemas.openxmlformats.org/drawingml/2006/main">
-            <a:srgbClr val="C9971C"/>
-          </a:solidFill>
+          <a:prstGeom xmlns:a="http://schemas.openxmlformats.org/drawingml/2006/main" prst="rect">
+            <a:avLst/>
+          </a:prstGeom>
+          <a:noFill xmlns:a="http://schemas.openxmlformats.org/drawingml/2006/main"/>
           <a:ln xmlns:a="http://schemas.openxmlformats.org/drawingml/2006/main" w="0">
             <a:noFill/>
-            <a:prstDash val="solid"/>
           </a:ln>
         </p:spPr>
         <p:txBody>
-          <a:bodyPr xmlns:a="http://schemas.openxmlformats.org/drawingml/2006/main" lIns="0" tIns="0" rIns="0" bIns="0" anchor="ctr"/>
+          <a:bodyPr xmlns:a="http://schemas.openxmlformats.org/drawingml/2006/main" wrap="square" lIns="0" tIns="0" rIns="0" bIns="0" anchor="t">
+            <a:noAutofit/>
+          </a:bodyPr>
           <a:lstStyle xmlns:a="http://schemas.openxmlformats.org/drawingml/2006/main">
-            <a:defPPr algn="ctr">
-              <a:defRPr sz="3700" b="1">
-                <a:solidFill>
-                  <a:srgbClr val="FFFFFF"/>
-                </a:solidFill>
-                <a:latin typeface="Cambria"/>
-                <a:ea typeface="Cambria"/>
-                <a:cs typeface="Cambria"/>
+            <a:defPPr algn="l">
+              <a:defRPr sz="3200" b="0" i="0">
+                <a:solidFill>
+                  <a:srgbClr val="1F2A24"/>
+                </a:solidFill>
+                <a:latin typeface="Calibri"/>
+                <a:ea typeface="Calibri"/>
+                <a:cs typeface="Calibri"/>
               </a:defRPr>
             </a:defPPr>
           </a:lstStyle>
           <a:p xmlns:a="http://schemas.openxmlformats.org/drawingml/2006/main">
-            <a:pPr algn="ctr">
-              <a:defRPr sz="3700" b="1">
-                <a:solidFill>
-                  <a:srgbClr val="FFFFFF"/>
-                </a:solidFill>
-                <a:latin typeface="Cambria"/>
-                <a:ea typeface="Cambria"/>
-                <a:cs typeface="Cambria"/>
-              </a:defRPr>
-            </a:pPr>
-            <a:r>
-              <a:rPr sz="3700" b="1">
-                <a:solidFill>
-                  <a:srgbClr val="FFFFFF"/>
-                </a:solidFill>
-                <a:latin typeface="Cambria"/>
-                <a:ea typeface="Cambria"/>
-                <a:cs typeface="Cambria"/>
-              </a:rPr>
-              <a:t>1</a:t>
+            <a:pPr algn="l">
+              <a:lnSpc>
+                <a:spcPct val="108000"/>
+              </a:lnSpc>
+              <a:buNone/>
+              <a:defRPr sz="3200" b="0" i="0">
+                <a:solidFill>
+                  <a:srgbClr val="1F2A24"/>
+                </a:solidFill>
+                <a:latin typeface="Calibri"/>
+                <a:ea typeface="Calibri"/>
+                <a:cs typeface="Calibri"/>
+              </a:defRPr>
+            </a:pPr>
+            <a:r>
+              <a:rPr sz="3200" b="0" i="0">
+                <a:solidFill>
+                  <a:srgbClr val="1F2A24"/>
+                </a:solidFill>
+                <a:latin typeface="Calibri"/>
+                <a:ea typeface="Calibri"/>
+                <a:cs typeface="Calibri"/>
+              </a:rPr>
+              <a:t>We built a virtual New Zealand Parliament to study how language models debate. We tested whether more Hansard excerpts, drawn from real parliamentary speeches, improve debate quality.</a:t>
             </a:r>
           </a:p>
         </p:txBody>
       </p:sp>
       <p:sp>
         <p:nvSpPr>
-          <p:cNvPr id="10" name="Section 1 title">
+          <p:cNvPr id="10" name="Section 1 number">
             <a:extLst xmlns:a="http://schemas.openxmlformats.org/drawingml/2006/main">
               <a:ext uri="{FF2B5EF4-FFF2-40B4-BE49-F238E27FC236}">
-                <a16:creationId xmlns:a16="http://schemas.microsoft.com/office/drawing/2014/main" id="{4A4B24CB-349B-421D-A98E-22DD152A23BE}"/>
+                <a16:creationId xmlns:a16="http://schemas.microsoft.com/office/drawing/2014/main" id="{41794EF1-B8E4-4D29-8F56-421F1EEFDB1C}"/>
               </a:ext>
             </a:extLst>
           </p:cNvPr>
@@ -2875,26 +2966,27 @@
         </p:nvSpPr>
         <p:spPr>
           <a:xfrm xmlns:a="http://schemas.openxmlformats.org/drawingml/2006/main">
-            <a:off x="1836000" y="5886000"/>
-            <a:ext cx="19080000" cy="900000"/>
+            <a:off x="868680" y="5400000"/>
+            <a:ext cx="712800" cy="712800"/>
           </a:xfrm>
-          <a:prstGeom xmlns:a="http://schemas.openxmlformats.org/drawingml/2006/main" prst="rect">
-            <a:avLst/>
-          </a:prstGeom>
-          <a:noFill xmlns:a="http://schemas.openxmlformats.org/drawingml/2006/main"/>
+          <a:prstGeom xmlns:a="http://schemas.openxmlformats.org/drawingml/2006/main" prst="ellipse">
+            <a:avLst/>
+          </a:prstGeom>
+          <a:solidFill xmlns:a="http://schemas.openxmlformats.org/drawingml/2006/main">
+            <a:srgbClr val="C9971C"/>
+          </a:solidFill>
           <a:ln xmlns:a="http://schemas.openxmlformats.org/drawingml/2006/main" w="0">
             <a:noFill/>
+            <a:prstDash val="solid"/>
           </a:ln>
         </p:spPr>
         <p:txBody>
-          <a:bodyPr xmlns:a="http://schemas.openxmlformats.org/drawingml/2006/main" wrap="square" lIns="0" tIns="0" rIns="0" bIns="0" anchor="t">
-            <a:noAutofit/>
-          </a:bodyPr>
+          <a:bodyPr xmlns:a="http://schemas.openxmlformats.org/drawingml/2006/main" lIns="0" tIns="0" rIns="0" bIns="0" anchor="ctr"/>
           <a:lstStyle xmlns:a="http://schemas.openxmlformats.org/drawingml/2006/main">
-            <a:defPPr algn="l">
-              <a:defRPr sz="5300" b="1" i="0">
-                <a:solidFill>
-                  <a:srgbClr val="1F4D36"/>
+            <a:defPPr algn="ctr">
+              <a:defRPr sz="3700" b="1">
+                <a:solidFill>
+                  <a:srgbClr val="FFFFFF"/>
                 </a:solidFill>
                 <a:latin typeface="Cambria"/>
                 <a:ea typeface="Cambria"/>
@@ -2903,40 +2995,36 @@
             </a:defPPr>
           </a:lstStyle>
           <a:p xmlns:a="http://schemas.openxmlformats.org/drawingml/2006/main">
-            <a:pPr algn="l">
-              <a:lnSpc>
-                <a:spcPct val="108000"/>
-              </a:lnSpc>
-              <a:buNone/>
-              <a:defRPr sz="5300" b="1" i="0">
-                <a:solidFill>
-                  <a:srgbClr val="1F4D36"/>
-                </a:solidFill>
-                <a:latin typeface="Cambria"/>
-                <a:ea typeface="Cambria"/>
-                <a:cs typeface="Cambria"/>
-              </a:defRPr>
-            </a:pPr>
-            <a:r>
-              <a:rPr sz="5300" b="1" i="0">
-                <a:solidFill>
-                  <a:srgbClr val="1F4D36"/>
-                </a:solidFill>
-                <a:latin typeface="Cambria"/>
-                <a:ea typeface="Cambria"/>
-                <a:cs typeface="Cambria"/>
-              </a:rPr>
-              <a:t>One platform, three interfaces</a:t>
+            <a:pPr algn="ctr">
+              <a:defRPr sz="3700" b="1">
+                <a:solidFill>
+                  <a:srgbClr val="FFFFFF"/>
+                </a:solidFill>
+                <a:latin typeface="Cambria"/>
+                <a:ea typeface="Cambria"/>
+                <a:cs typeface="Cambria"/>
+              </a:defRPr>
+            </a:pPr>
+            <a:r>
+              <a:rPr sz="3700" b="1">
+                <a:solidFill>
+                  <a:srgbClr val="FFFFFF"/>
+                </a:solidFill>
+                <a:latin typeface="Cambria"/>
+                <a:ea typeface="Cambria"/>
+                <a:cs typeface="Cambria"/>
+              </a:rPr>
+              <a:t>1</a:t>
             </a:r>
           </a:p>
         </p:txBody>
       </p:sp>
       <p:sp>
         <p:nvSpPr>
-          <p:cNvPr id="11" name="Screenshot border">
+          <p:cNvPr id="11" name="Section 1 title">
             <a:extLst xmlns:a="http://schemas.openxmlformats.org/drawingml/2006/main">
               <a:ext uri="{FF2B5EF4-FFF2-40B4-BE49-F238E27FC236}">
-                <a16:creationId xmlns:a16="http://schemas.microsoft.com/office/drawing/2014/main" id="{7902646E-25D6-4F03-B946-0598AE74864F}"/>
+                <a16:creationId xmlns:a16="http://schemas.microsoft.com/office/drawing/2014/main" id="{080D8C03-3FFC-41B2-A4A0-4786B599A873}"/>
               </a:ext>
             </a:extLst>
           </p:cNvPr>
@@ -2947,8 +3035,80 @@
         </p:nvSpPr>
         <p:spPr>
           <a:xfrm xmlns:a="http://schemas.openxmlformats.org/drawingml/2006/main">
-            <a:off x="846000" y="6998400"/>
-            <a:ext cx="10483200" cy="5572800"/>
+            <a:off x="1836000" y="5346000"/>
+            <a:ext cx="19080000" cy="900000"/>
+          </a:xfrm>
+          <a:prstGeom xmlns:a="http://schemas.openxmlformats.org/drawingml/2006/main" prst="rect">
+            <a:avLst/>
+          </a:prstGeom>
+          <a:noFill xmlns:a="http://schemas.openxmlformats.org/drawingml/2006/main"/>
+          <a:ln xmlns:a="http://schemas.openxmlformats.org/drawingml/2006/main" w="0">
+            <a:noFill/>
+          </a:ln>
+        </p:spPr>
+        <p:txBody>
+          <a:bodyPr xmlns:a="http://schemas.openxmlformats.org/drawingml/2006/main" wrap="square" lIns="0" tIns="0" rIns="0" bIns="0" anchor="t">
+            <a:noAutofit/>
+          </a:bodyPr>
+          <a:lstStyle xmlns:a="http://schemas.openxmlformats.org/drawingml/2006/main">
+            <a:defPPr algn="l">
+              <a:defRPr sz="5300" b="1" i="0">
+                <a:solidFill>
+                  <a:srgbClr val="1F4D36"/>
+                </a:solidFill>
+                <a:latin typeface="Cambria"/>
+                <a:ea typeface="Cambria"/>
+                <a:cs typeface="Cambria"/>
+              </a:defRPr>
+            </a:defPPr>
+          </a:lstStyle>
+          <a:p xmlns:a="http://schemas.openxmlformats.org/drawingml/2006/main">
+            <a:pPr algn="l">
+              <a:lnSpc>
+                <a:spcPct val="108000"/>
+              </a:lnSpc>
+              <a:buNone/>
+              <a:defRPr sz="5300" b="1" i="0">
+                <a:solidFill>
+                  <a:srgbClr val="1F4D36"/>
+                </a:solidFill>
+                <a:latin typeface="Cambria"/>
+                <a:ea typeface="Cambria"/>
+                <a:cs typeface="Cambria"/>
+              </a:defRPr>
+            </a:pPr>
+            <a:r>
+              <a:rPr sz="5300" b="1" i="0">
+                <a:solidFill>
+                  <a:srgbClr val="1F4D36"/>
+                </a:solidFill>
+                <a:latin typeface="Cambria"/>
+                <a:ea typeface="Cambria"/>
+                <a:cs typeface="Cambria"/>
+              </a:rPr>
+              <a:t>One platform, three interfaces</a:t>
+            </a:r>
+          </a:p>
+        </p:txBody>
+      </p:sp>
+      <p:sp>
+        <p:nvSpPr>
+          <p:cNvPr id="12" name="Screenshot border">
+            <a:extLst xmlns:a="http://schemas.openxmlformats.org/drawingml/2006/main">
+              <a:ext uri="{FF2B5EF4-FFF2-40B4-BE49-F238E27FC236}">
+                <a16:creationId xmlns:a16="http://schemas.microsoft.com/office/drawing/2014/main" id="{6467FE11-4251-4544-86BA-1717467903F3}"/>
+              </a:ext>
+            </a:extLst>
+          </p:cNvPr>
+          <p:cNvSpPr>
+            <a:spLocks xmlns:a="http://schemas.openxmlformats.org/drawingml/2006/main" noGrp="1"/>
+          </p:cNvSpPr>
+          <p:nvPr/>
+        </p:nvSpPr>
+        <p:spPr>
+          <a:xfrm xmlns:a="http://schemas.openxmlformats.org/drawingml/2006/main">
+            <a:off x="846000" y="6278400"/>
+            <a:ext cx="11203200" cy="5954400"/>
           </a:xfrm>
           <a:prstGeom xmlns:a="http://schemas.openxmlformats.org/drawingml/2006/main" prst="rect">
             <a:avLst/>
@@ -2966,10 +3126,10 @@
       </p:sp>
       <p:pic>
         <p:nvPicPr>
-          <p:cNvPr id="12" name="">
+          <p:cNvPr id="13" name="">
             <a:extLst xmlns:a="http://schemas.openxmlformats.org/drawingml/2006/main">
               <a:ext uri="{FF2B5EF4-FFF2-40B4-BE49-F238E27FC236}">
-                <a16:creationId xmlns:a16="http://schemas.microsoft.com/office/drawing/2014/main" id="{A409A76D-DCD7-489C-88D2-F51CD52BA8BF}"/>
+                <a16:creationId xmlns:a16="http://schemas.microsoft.com/office/drawing/2014/main" id="{B811F2D2-5E2A-4456-9222-BCBF63559BEB}"/>
               </a:ext>
             </a:extLst>
           </p:cNvPr>
@@ -2979,13 +3139,13 @@
           <p:nvPr/>
         </p:nvPicPr>
         <p:blipFill>
-          <a:blip xmlns:r="http://schemas.openxmlformats.org/officeDocument/2006/relationships" xmlns:a="http://schemas.openxmlformats.org/drawingml/2006/main" r:embed="R30124ee819b14ed1"/>
+          <a:blip xmlns:r="http://schemas.openxmlformats.org/officeDocument/2006/relationships" xmlns:a="http://schemas.openxmlformats.org/drawingml/2006/main" r:embed="R1b34d6af41274e32"/>
           <a:stretch xmlns:a="http://schemas.openxmlformats.org/drawingml/2006/main"/>
         </p:blipFill>
         <p:spPr>
           <a:xfrm xmlns:a="http://schemas.openxmlformats.org/drawingml/2006/main">
-            <a:off x="873710" y="7020000"/>
-            <a:ext cx="10429941" cy="5528160"/>
+            <a:off x="868974" y="6300000"/>
+            <a:ext cx="11159412" cy="5914800"/>
           </a:xfrm>
           <a:prstGeom xmlns:a="http://schemas.openxmlformats.org/drawingml/2006/main" prst="rect">
             <a:avLst/>
@@ -2994,10 +3154,10 @@
       </p:pic>
       <p:sp>
         <p:nvSpPr>
-          <p:cNvPr id="13" name="Callout A">
+          <p:cNvPr id="14" name="Callout A">
             <a:extLst xmlns:a="http://schemas.openxmlformats.org/drawingml/2006/main">
               <a:ext uri="{FF2B5EF4-FFF2-40B4-BE49-F238E27FC236}">
-                <a16:creationId xmlns:a16="http://schemas.microsoft.com/office/drawing/2014/main" id="{90194C72-8E6D-4428-8143-2EBBA2EB45C1}"/>
+                <a16:creationId xmlns:a16="http://schemas.microsoft.com/office/drawing/2014/main" id="{610022AB-1B11-4C68-AD77-88D9A044C175}"/>
               </a:ext>
             </a:extLst>
           </p:cNvPr>
@@ -3008,7 +3168,7 @@
         </p:nvSpPr>
         <p:spPr>
           <a:xfrm xmlns:a="http://schemas.openxmlformats.org/drawingml/2006/main">
-            <a:off x="2592000" y="7920000"/>
+            <a:off x="2700000" y="7261200"/>
             <a:ext cx="540000" cy="540000"/>
           </a:xfrm>
           <a:prstGeom xmlns:a="http://schemas.openxmlformats.org/drawingml/2006/main" prst="ellipse">
@@ -3065,10 +3225,10 @@
       </p:sp>
       <p:sp>
         <p:nvSpPr>
-          <p:cNvPr id="14" name="Callout B">
+          <p:cNvPr id="15" name="Callout B">
             <a:extLst xmlns:a="http://schemas.openxmlformats.org/drawingml/2006/main">
               <a:ext uri="{FF2B5EF4-FFF2-40B4-BE49-F238E27FC236}">
-                <a16:creationId xmlns:a16="http://schemas.microsoft.com/office/drawing/2014/main" id="{B961D3CE-0586-4C3D-A418-038016EFAC66}"/>
+                <a16:creationId xmlns:a16="http://schemas.microsoft.com/office/drawing/2014/main" id="{E6266498-4474-4391-B744-C8CD82A70F8B}"/>
               </a:ext>
             </a:extLst>
           </p:cNvPr>
@@ -3079,7 +3239,7 @@
         </p:nvSpPr>
         <p:spPr>
           <a:xfrm xmlns:a="http://schemas.openxmlformats.org/drawingml/2006/main">
-            <a:off x="3456000" y="8784000"/>
+            <a:off x="3636000" y="8186400"/>
             <a:ext cx="540000" cy="540000"/>
           </a:xfrm>
           <a:prstGeom xmlns:a="http://schemas.openxmlformats.org/drawingml/2006/main" prst="ellipse">
@@ -3136,10 +3296,10 @@
       </p:sp>
       <p:sp>
         <p:nvSpPr>
-          <p:cNvPr id="15" name="Callout C">
+          <p:cNvPr id="16" name="Callout C">
             <a:extLst xmlns:a="http://schemas.openxmlformats.org/drawingml/2006/main">
               <a:ext uri="{FF2B5EF4-FFF2-40B4-BE49-F238E27FC236}">
-                <a16:creationId xmlns:a16="http://schemas.microsoft.com/office/drawing/2014/main" id="{AC67C36B-B237-4090-A44D-D84A8843FE7E}"/>
+                <a16:creationId xmlns:a16="http://schemas.microsoft.com/office/drawing/2014/main" id="{7E90276F-544A-4257-9C94-A4C9AE980CC2}"/>
               </a:ext>
             </a:extLst>
           </p:cNvPr>
@@ -3150,7 +3310,7 @@
         </p:nvSpPr>
         <p:spPr>
           <a:xfrm xmlns:a="http://schemas.openxmlformats.org/drawingml/2006/main">
-            <a:off x="10656000" y="7164000"/>
+            <a:off x="11332800" y="6454800"/>
             <a:ext cx="540000" cy="540000"/>
           </a:xfrm>
           <a:prstGeom xmlns:a="http://schemas.openxmlformats.org/drawingml/2006/main" prst="ellipse">
@@ -3207,10 +3367,10 @@
       </p:sp>
       <p:sp>
         <p:nvSpPr>
-          <p:cNvPr id="16" name="Callout D">
+          <p:cNvPr id="17" name="Callout D">
             <a:extLst xmlns:a="http://schemas.openxmlformats.org/drawingml/2006/main">
               <a:ext uri="{FF2B5EF4-FFF2-40B4-BE49-F238E27FC236}">
-                <a16:creationId xmlns:a16="http://schemas.microsoft.com/office/drawing/2014/main" id="{3EF40AF1-F819-4927-AE10-AE844CB098C5}"/>
+                <a16:creationId xmlns:a16="http://schemas.microsoft.com/office/drawing/2014/main" id="{E6FF74B3-31A3-46AA-BE47-AF7F32B86F89}"/>
               </a:ext>
             </a:extLst>
           </p:cNvPr>
@@ -3221,7 +3381,7 @@
         </p:nvSpPr>
         <p:spPr>
           <a:xfrm xmlns:a="http://schemas.openxmlformats.org/drawingml/2006/main">
-            <a:off x="6624000" y="7056000"/>
+            <a:off x="2700000" y="10224000"/>
             <a:ext cx="540000" cy="540000"/>
           </a:xfrm>
           <a:prstGeom xmlns:a="http://schemas.openxmlformats.org/drawingml/2006/main" prst="ellipse">
@@ -3278,10 +3438,10 @@
       </p:sp>
       <p:sp>
         <p:nvSpPr>
-          <p:cNvPr id="17" name="Callout A">
+          <p:cNvPr id="18" name="Callout E">
             <a:extLst xmlns:a="http://schemas.openxmlformats.org/drawingml/2006/main">
               <a:ext uri="{FF2B5EF4-FFF2-40B4-BE49-F238E27FC236}">
-                <a16:creationId xmlns:a16="http://schemas.microsoft.com/office/drawing/2014/main" id="{93090F0D-444E-4698-BA39-16CDF4661CA8}"/>
+                <a16:creationId xmlns:a16="http://schemas.microsoft.com/office/drawing/2014/main" id="{7945F291-C2CD-49CF-AACC-A8A9F9973335}"/>
               </a:ext>
             </a:extLst>
           </p:cNvPr>
@@ -3292,8 +3452,8 @@
         </p:nvSpPr>
         <p:spPr>
           <a:xfrm xmlns:a="http://schemas.openxmlformats.org/drawingml/2006/main">
-            <a:off x="11664000" y="7020000"/>
-            <a:ext cx="594000" cy="594000"/>
+            <a:off x="7020000" y="6426000"/>
+            <a:ext cx="540000" cy="540000"/>
           </a:xfrm>
           <a:prstGeom xmlns:a="http://schemas.openxmlformats.org/drawingml/2006/main" prst="ellipse">
             <a:avLst/>
@@ -3342,17 +3502,17 @@
                 <a:ea typeface="Cambria"/>
                 <a:cs typeface="Cambria"/>
               </a:rPr>
-              <a:t>A</a:t>
+              <a:t>E</a:t>
             </a:r>
           </a:p>
         </p:txBody>
       </p:sp>
       <p:sp>
         <p:nvSpPr>
-          <p:cNvPr id="18" name="Callout A heading">
+          <p:cNvPr id="19" name="Callout A">
             <a:extLst xmlns:a="http://schemas.openxmlformats.org/drawingml/2006/main">
               <a:ext uri="{FF2B5EF4-FFF2-40B4-BE49-F238E27FC236}">
-                <a16:creationId xmlns:a16="http://schemas.microsoft.com/office/drawing/2014/main" id="{AACC33C9-097D-4B42-BA52-EA467FDE17AA}"/>
+                <a16:creationId xmlns:a16="http://schemas.microsoft.com/office/drawing/2014/main" id="{662378C9-2F83-4E19-A62D-24D9FD2DC7BE}"/>
               </a:ext>
             </a:extLst>
           </p:cNvPr>
@@ -3363,151 +3523,7 @@
         </p:nvSpPr>
         <p:spPr>
           <a:xfrm xmlns:a="http://schemas.openxmlformats.org/drawingml/2006/main">
-            <a:off x="12528000" y="6984000"/>
-            <a:ext cx="8419320" cy="540000"/>
-          </a:xfrm>
-          <a:prstGeom xmlns:a="http://schemas.openxmlformats.org/drawingml/2006/main" prst="rect">
-            <a:avLst/>
-          </a:prstGeom>
-          <a:noFill xmlns:a="http://schemas.openxmlformats.org/drawingml/2006/main"/>
-          <a:ln xmlns:a="http://schemas.openxmlformats.org/drawingml/2006/main" w="0">
-            <a:noFill/>
-          </a:ln>
-        </p:spPr>
-        <p:txBody>
-          <a:bodyPr xmlns:a="http://schemas.openxmlformats.org/drawingml/2006/main" wrap="square" lIns="0" tIns="0" rIns="0" bIns="0" anchor="t">
-            <a:noAutofit/>
-          </a:bodyPr>
-          <a:lstStyle xmlns:a="http://schemas.openxmlformats.org/drawingml/2006/main">
-            <a:defPPr algn="l">
-              <a:defRPr sz="3000" b="1" i="0">
-                <a:solidFill>
-                  <a:srgbClr val="1F2A24"/>
-                </a:solidFill>
-                <a:latin typeface="Cambria"/>
-                <a:ea typeface="Cambria"/>
-                <a:cs typeface="Cambria"/>
-              </a:defRPr>
-            </a:defPPr>
-          </a:lstStyle>
-          <a:p xmlns:a="http://schemas.openxmlformats.org/drawingml/2006/main">
-            <a:pPr algn="l">
-              <a:lnSpc>
-                <a:spcPct val="108000"/>
-              </a:lnSpc>
-              <a:buNone/>
-              <a:defRPr sz="3000" b="1" i="0">
-                <a:solidFill>
-                  <a:srgbClr val="1F2A24"/>
-                </a:solidFill>
-                <a:latin typeface="Cambria"/>
-                <a:ea typeface="Cambria"/>
-                <a:cs typeface="Cambria"/>
-              </a:defRPr>
-            </a:pPr>
-            <a:r>
-              <a:rPr sz="3000" b="1" i="0">
-                <a:solidFill>
-                  <a:srgbClr val="1F2A24"/>
-                </a:solidFill>
-                <a:latin typeface="Cambria"/>
-                <a:ea typeface="Cambria"/>
-                <a:cs typeface="Cambria"/>
-              </a:rPr>
-              <a:t>Chamber and party agents</a:t>
-            </a:r>
-          </a:p>
-        </p:txBody>
-      </p:sp>
-      <p:sp>
-        <p:nvSpPr>
-          <p:cNvPr id="19" name="Callout A detail">
-            <a:extLst xmlns:a="http://schemas.openxmlformats.org/drawingml/2006/main">
-              <a:ext uri="{FF2B5EF4-FFF2-40B4-BE49-F238E27FC236}">
-                <a16:creationId xmlns:a16="http://schemas.microsoft.com/office/drawing/2014/main" id="{9EEBDB2C-EB5A-4884-9F93-6AF0C85A95C4}"/>
-              </a:ext>
-            </a:extLst>
-          </p:cNvPr>
-          <p:cNvSpPr>
-            <a:spLocks xmlns:a="http://schemas.openxmlformats.org/drawingml/2006/main" noGrp="1"/>
-          </p:cNvSpPr>
-          <p:nvPr/>
-        </p:nvSpPr>
-        <p:spPr>
-          <a:xfrm xmlns:a="http://schemas.openxmlformats.org/drawingml/2006/main">
-            <a:off x="12528000" y="7560000"/>
-            <a:ext cx="8419320" cy="1008000"/>
-          </a:xfrm>
-          <a:prstGeom xmlns:a="http://schemas.openxmlformats.org/drawingml/2006/main" prst="rect">
-            <a:avLst/>
-          </a:prstGeom>
-          <a:noFill xmlns:a="http://schemas.openxmlformats.org/drawingml/2006/main"/>
-          <a:ln xmlns:a="http://schemas.openxmlformats.org/drawingml/2006/main" w="0">
-            <a:noFill/>
-          </a:ln>
-        </p:spPr>
-        <p:txBody>
-          <a:bodyPr xmlns:a="http://schemas.openxmlformats.org/drawingml/2006/main" wrap="square" lIns="0" tIns="0" rIns="0" bIns="0" anchor="t">
-            <a:noAutofit/>
-          </a:bodyPr>
-          <a:lstStyle xmlns:a="http://schemas.openxmlformats.org/drawingml/2006/main">
-            <a:defPPr algn="l">
-              <a:defRPr sz="2800" b="0" i="0">
-                <a:solidFill>
-                  <a:srgbClr val="56615B"/>
-                </a:solidFill>
-                <a:latin typeface="Calibri"/>
-                <a:ea typeface="Calibri"/>
-                <a:cs typeface="Calibri"/>
-              </a:defRPr>
-            </a:defPPr>
-          </a:lstStyle>
-          <a:p xmlns:a="http://schemas.openxmlformats.org/drawingml/2006/main">
-            <a:pPr algn="l">
-              <a:lnSpc>
-                <a:spcPct val="108000"/>
-              </a:lnSpc>
-              <a:buNone/>
-              <a:defRPr sz="2800" b="0" i="0">
-                <a:solidFill>
-                  <a:srgbClr val="56615B"/>
-                </a:solidFill>
-                <a:latin typeface="Calibri"/>
-                <a:ea typeface="Calibri"/>
-                <a:cs typeface="Calibri"/>
-              </a:defRPr>
-            </a:pPr>
-            <a:r>
-              <a:rPr sz="2800" b="0" i="0">
-                <a:solidFill>
-                  <a:srgbClr val="56615B"/>
-                </a:solidFill>
-                <a:latin typeface="Calibri"/>
-                <a:ea typeface="Calibri"/>
-                <a:cs typeface="Calibri"/>
-              </a:rPr>
-              <a:t>Watch who has the floor and each party’s role.</a:t>
-            </a:r>
-          </a:p>
-        </p:txBody>
-      </p:sp>
-      <p:sp>
-        <p:nvSpPr>
-          <p:cNvPr id="20" name="Callout B">
-            <a:extLst xmlns:a="http://schemas.openxmlformats.org/drawingml/2006/main">
-              <a:ext uri="{FF2B5EF4-FFF2-40B4-BE49-F238E27FC236}">
-                <a16:creationId xmlns:a16="http://schemas.microsoft.com/office/drawing/2014/main" id="{58D6D10E-69BA-4D3F-8587-5811704D122B}"/>
-              </a:ext>
-            </a:extLst>
-          </p:cNvPr>
-          <p:cNvSpPr>
-            <a:spLocks xmlns:a="http://schemas.openxmlformats.org/drawingml/2006/main" noGrp="1"/>
-          </p:cNvSpPr>
-          <p:nvPr/>
-        </p:nvSpPr>
-        <p:spPr>
-          <a:xfrm xmlns:a="http://schemas.openxmlformats.org/drawingml/2006/main">
-            <a:off x="11664000" y="8424000"/>
+            <a:off x="12492000" y="6264000"/>
             <a:ext cx="594000" cy="594000"/>
           </a:xfrm>
           <a:prstGeom xmlns:a="http://schemas.openxmlformats.org/drawingml/2006/main" prst="ellipse">
@@ -3557,17 +3573,17 @@
                 <a:ea typeface="Cambria"/>
                 <a:cs typeface="Cambria"/>
               </a:rPr>
-              <a:t>B</a:t>
+              <a:t>A</a:t>
             </a:r>
           </a:p>
         </p:txBody>
       </p:sp>
       <p:sp>
         <p:nvSpPr>
-          <p:cNvPr id="21" name="Callout B heading">
+          <p:cNvPr id="20" name="Callout A heading">
             <a:extLst xmlns:a="http://schemas.openxmlformats.org/drawingml/2006/main">
               <a:ext uri="{FF2B5EF4-FFF2-40B4-BE49-F238E27FC236}">
-                <a16:creationId xmlns:a16="http://schemas.microsoft.com/office/drawing/2014/main" id="{96FC5E94-0982-4385-A5E7-D6E2EE287297}"/>
+                <a16:creationId xmlns:a16="http://schemas.microsoft.com/office/drawing/2014/main" id="{F5D9699D-5C8E-411C-956C-B09A1DB76CB0}"/>
               </a:ext>
             </a:extLst>
           </p:cNvPr>
@@ -3578,8 +3594,8 @@
         </p:nvSpPr>
         <p:spPr>
           <a:xfrm xmlns:a="http://schemas.openxmlformats.org/drawingml/2006/main">
-            <a:off x="12528000" y="8388000"/>
-            <a:ext cx="8419320" cy="540000"/>
+            <a:off x="13320000" y="6228000"/>
+            <a:ext cx="7627320" cy="486000"/>
           </a:xfrm>
           <a:prstGeom xmlns:a="http://schemas.openxmlformats.org/drawingml/2006/main" prst="rect">
             <a:avLst/>
@@ -3595,7 +3611,7 @@
           </a:bodyPr>
           <a:lstStyle xmlns:a="http://schemas.openxmlformats.org/drawingml/2006/main">
             <a:defPPr algn="l">
-              <a:defRPr sz="3000" b="1" i="0">
+              <a:defRPr sz="2900" b="1" i="0">
                 <a:solidFill>
                   <a:srgbClr val="1F2A24"/>
                 </a:solidFill>
@@ -3611,7 +3627,7 @@
                 <a:spcPct val="108000"/>
               </a:lnSpc>
               <a:buNone/>
-              <a:defRPr sz="3000" b="1" i="0">
+              <a:defRPr sz="2900" b="1" i="0">
                 <a:solidFill>
                   <a:srgbClr val="1F2A24"/>
                 </a:solidFill>
@@ -3621,7 +3637,7 @@
               </a:defRPr>
             </a:pPr>
             <a:r>
-              <a:rPr sz="3000" b="1" i="0">
+              <a:rPr sz="2900" b="1" i="0">
                 <a:solidFill>
                   <a:srgbClr val="1F2A24"/>
                 </a:solidFill>
@@ -3629,17 +3645,17 @@
                 <a:ea typeface="Cambria"/>
                 <a:cs typeface="Cambria"/>
               </a:rPr>
-              <a:t>Live and saved Hansard</a:t>
+              <a:t>The Chamber</a:t>
             </a:r>
           </a:p>
         </p:txBody>
       </p:sp>
       <p:sp>
         <p:nvSpPr>
-          <p:cNvPr id="22" name="Callout B detail">
+          <p:cNvPr id="21" name="Callout A detail">
             <a:extLst xmlns:a="http://schemas.openxmlformats.org/drawingml/2006/main">
               <a:ext uri="{FF2B5EF4-FFF2-40B4-BE49-F238E27FC236}">
-                <a16:creationId xmlns:a16="http://schemas.microsoft.com/office/drawing/2014/main" id="{B18B6152-E7DB-4F42-ACD7-3BDE05F130DA}"/>
+                <a16:creationId xmlns:a16="http://schemas.microsoft.com/office/drawing/2014/main" id="{F53446FA-118A-4C3C-ABC3-4AF41FB1F1C2}"/>
               </a:ext>
             </a:extLst>
           </p:cNvPr>
@@ -3650,8 +3666,8 @@
         </p:nvSpPr>
         <p:spPr>
           <a:xfrm xmlns:a="http://schemas.openxmlformats.org/drawingml/2006/main">
-            <a:off x="12528000" y="8964000"/>
-            <a:ext cx="8419320" cy="1008000"/>
+            <a:off x="13320000" y="6750000"/>
+            <a:ext cx="7627320" cy="792000"/>
           </a:xfrm>
           <a:prstGeom xmlns:a="http://schemas.openxmlformats.org/drawingml/2006/main" prst="rect">
             <a:avLst/>
@@ -3667,7 +3683,7 @@
           </a:bodyPr>
           <a:lstStyle xmlns:a="http://schemas.openxmlformats.org/drawingml/2006/main">
             <a:defPPr algn="l">
-              <a:defRPr sz="2800" b="0" i="0">
+              <a:defRPr sz="2550" b="0" i="0">
                 <a:solidFill>
                   <a:srgbClr val="56615B"/>
                 </a:solidFill>
@@ -3683,7 +3699,7 @@
                 <a:spcPct val="108000"/>
               </a:lnSpc>
               <a:buNone/>
-              <a:defRPr sz="2800" b="0" i="0">
+              <a:defRPr sz="2550" b="0" i="0">
                 <a:solidFill>
                   <a:srgbClr val="56615B"/>
                 </a:solidFill>
@@ -3693,7 +3709,7 @@
               </a:defRPr>
             </a:pPr>
             <a:r>
-              <a:rPr sz="2800" b="0" i="0">
+              <a:rPr sz="2550" b="0" i="0">
                 <a:solidFill>
                   <a:srgbClr val="56615B"/>
                 </a:solidFill>
@@ -3701,17 +3717,44 @@
                 <a:ea typeface="Calibri"/>
                 <a:cs typeface="Calibri"/>
               </a:rPr>
-              <a:t>Speeches stream to a transcript that can be reopened after restart.</a:t>
+              <a:t>Members light up as they speak.</a:t>
+            </a:r>
+          </a:p>
+          <a:p xmlns:a="http://schemas.openxmlformats.org/drawingml/2006/main">
+            <a:pPr algn="l">
+              <a:lnSpc>
+                <a:spcPct val="108000"/>
+              </a:lnSpc>
+              <a:buNone/>
+              <a:defRPr sz="2550" b="0" i="0">
+                <a:solidFill>
+                  <a:srgbClr val="56615B"/>
+                </a:solidFill>
+                <a:latin typeface="Calibri"/>
+                <a:ea typeface="Calibri"/>
+                <a:cs typeface="Calibri"/>
+              </a:defRPr>
+            </a:pPr>
+            <a:r>
+              <a:rPr sz="2550" b="0" i="0">
+                <a:solidFill>
+                  <a:srgbClr val="56615B"/>
+                </a:solidFill>
+                <a:latin typeface="Calibri"/>
+                <a:ea typeface="Calibri"/>
+                <a:cs typeface="Calibri"/>
+              </a:rPr>
+              <a:t>Party roles appear in the chamber.</a:t>
             </a:r>
           </a:p>
         </p:txBody>
       </p:sp>
       <p:sp>
         <p:nvSpPr>
-          <p:cNvPr id="23" name="Callout C">
+          <p:cNvPr id="22" name="Callout B">
             <a:extLst xmlns:a="http://schemas.openxmlformats.org/drawingml/2006/main">
               <a:ext uri="{FF2B5EF4-FFF2-40B4-BE49-F238E27FC236}">
-                <a16:creationId xmlns:a16="http://schemas.microsoft.com/office/drawing/2014/main" id="{EE3F7B02-F33D-47B1-8040-0B2467DA3094}"/>
+                <a16:creationId xmlns:a16="http://schemas.microsoft.com/office/drawing/2014/main" id="{06EA18E8-B4BA-48B6-85A7-7550B44C10C1}"/>
               </a:ext>
             </a:extLst>
           </p:cNvPr>
@@ -3722,7 +3765,7 @@
         </p:nvSpPr>
         <p:spPr>
           <a:xfrm xmlns:a="http://schemas.openxmlformats.org/drawingml/2006/main">
-            <a:off x="11664000" y="9828000"/>
+            <a:off x="12492000" y="7632000"/>
             <a:ext cx="594000" cy="594000"/>
           </a:xfrm>
           <a:prstGeom xmlns:a="http://schemas.openxmlformats.org/drawingml/2006/main" prst="ellipse">
@@ -3772,17 +3815,17 @@
                 <a:ea typeface="Cambria"/>
                 <a:cs typeface="Cambria"/>
               </a:rPr>
-              <a:t>C</a:t>
+              <a:t>B</a:t>
             </a:r>
           </a:p>
         </p:txBody>
       </p:sp>
       <p:sp>
         <p:nvSpPr>
-          <p:cNvPr id="24" name="Callout C heading">
+          <p:cNvPr id="23" name="Callout B heading">
             <a:extLst xmlns:a="http://schemas.openxmlformats.org/drawingml/2006/main">
               <a:ext uri="{FF2B5EF4-FFF2-40B4-BE49-F238E27FC236}">
-                <a16:creationId xmlns:a16="http://schemas.microsoft.com/office/drawing/2014/main" id="{BFA36417-D83F-41C7-9DCB-A29D544C86DE}"/>
+                <a16:creationId xmlns:a16="http://schemas.microsoft.com/office/drawing/2014/main" id="{DCE00158-F753-4B07-BB7E-C6D1200D713A}"/>
               </a:ext>
             </a:extLst>
           </p:cNvPr>
@@ -3793,8 +3836,8 @@
         </p:nvSpPr>
         <p:spPr>
           <a:xfrm xmlns:a="http://schemas.openxmlformats.org/drawingml/2006/main">
-            <a:off x="12528000" y="9792000"/>
-            <a:ext cx="8419320" cy="540000"/>
+            <a:off x="13320000" y="7596000"/>
+            <a:ext cx="7627320" cy="486000"/>
           </a:xfrm>
           <a:prstGeom xmlns:a="http://schemas.openxmlformats.org/drawingml/2006/main" prst="rect">
             <a:avLst/>
@@ -3810,7 +3853,7 @@
           </a:bodyPr>
           <a:lstStyle xmlns:a="http://schemas.openxmlformats.org/drawingml/2006/main">
             <a:defPPr algn="l">
-              <a:defRPr sz="3000" b="1" i="0">
+              <a:defRPr sz="2900" b="1" i="0">
                 <a:solidFill>
                   <a:srgbClr val="1F2A24"/>
                 </a:solidFill>
@@ -3826,7 +3869,7 @@
                 <a:spcPct val="108000"/>
               </a:lnSpc>
               <a:buNone/>
-              <a:defRPr sz="3000" b="1" i="0">
+              <a:defRPr sz="2900" b="1" i="0">
                 <a:solidFill>
                   <a:srgbClr val="1F2A24"/>
                 </a:solidFill>
@@ -3836,7 +3879,7 @@
               </a:defRPr>
             </a:pPr>
             <a:r>
-              <a:rPr sz="3000" b="1" i="0">
+              <a:rPr sz="2900" b="1" i="0">
                 <a:solidFill>
                   <a:srgbClr val="1F2A24"/>
                 </a:solidFill>
@@ -3844,17 +3887,17 @@
                 <a:ea typeface="Cambria"/>
                 <a:cs typeface="Cambria"/>
               </a:rPr>
-              <a:t>The Speaker’s Chair</a:t>
+              <a:t>Live Hansard</a:t>
             </a:r>
           </a:p>
         </p:txBody>
       </p:sp>
       <p:sp>
         <p:nvSpPr>
-          <p:cNvPr id="25" name="Callout C detail">
+          <p:cNvPr id="24" name="Callout B detail">
             <a:extLst xmlns:a="http://schemas.openxmlformats.org/drawingml/2006/main">
               <a:ext uri="{FF2B5EF4-FFF2-40B4-BE49-F238E27FC236}">
-                <a16:creationId xmlns:a16="http://schemas.microsoft.com/office/drawing/2014/main" id="{B0505173-BE1C-4B85-9A12-FCFFD6356F61}"/>
+                <a16:creationId xmlns:a16="http://schemas.microsoft.com/office/drawing/2014/main" id="{6B772EA7-7C82-4C01-9085-B103C682FC53}"/>
               </a:ext>
             </a:extLst>
           </p:cNvPr>
@@ -3865,8 +3908,8 @@
         </p:nvSpPr>
         <p:spPr>
           <a:xfrm xmlns:a="http://schemas.openxmlformats.org/drawingml/2006/main">
-            <a:off x="12528000" y="10368000"/>
-            <a:ext cx="8419320" cy="1008000"/>
+            <a:off x="13320000" y="8118000"/>
+            <a:ext cx="7627320" cy="792000"/>
           </a:xfrm>
           <a:prstGeom xmlns:a="http://schemas.openxmlformats.org/drawingml/2006/main" prst="rect">
             <a:avLst/>
@@ -3882,7 +3925,7 @@
           </a:bodyPr>
           <a:lstStyle xmlns:a="http://schemas.openxmlformats.org/drawingml/2006/main">
             <a:defPPr algn="l">
-              <a:defRPr sz="2800" b="0" i="0">
+              <a:defRPr sz="2550" b="0" i="0">
                 <a:solidFill>
                   <a:srgbClr val="56615B"/>
                 </a:solidFill>
@@ -3898,7 +3941,7 @@
                 <a:spcPct val="108000"/>
               </a:lnSpc>
               <a:buNone/>
-              <a:defRPr sz="2800" b="0" i="0">
+              <a:defRPr sz="2550" b="0" i="0">
                 <a:solidFill>
                   <a:srgbClr val="56615B"/>
                 </a:solidFill>
@@ -3908,7 +3951,7 @@
               </a:defRPr>
             </a:pPr>
             <a:r>
-              <a:rPr sz="2800" b="0" i="0">
+              <a:rPr sz="2550" b="0" i="0">
                 <a:solidFill>
                   <a:srgbClr val="56615B"/>
                 </a:solidFill>
@@ -3916,17 +3959,44 @@
                 <a:ea typeface="Calibri"/>
                 <a:cs typeface="Calibri"/>
               </a:rPr>
-              <a:t>Rulings reach every agent before the next speech.</a:t>
+              <a:t>Speeches stream into Hansard.</a:t>
+            </a:r>
+          </a:p>
+          <a:p xmlns:a="http://schemas.openxmlformats.org/drawingml/2006/main">
+            <a:pPr algn="l">
+              <a:lnSpc>
+                <a:spcPct val="108000"/>
+              </a:lnSpc>
+              <a:buNone/>
+              <a:defRPr sz="2550" b="0" i="0">
+                <a:solidFill>
+                  <a:srgbClr val="56615B"/>
+                </a:solidFill>
+                <a:latin typeface="Calibri"/>
+                <a:ea typeface="Calibri"/>
+                <a:cs typeface="Calibri"/>
+              </a:defRPr>
+            </a:pPr>
+            <a:r>
+              <a:rPr sz="2550" b="0" i="0">
+                <a:solidFill>
+                  <a:srgbClr val="56615B"/>
+                </a:solidFill>
+                <a:latin typeface="Calibri"/>
+                <a:ea typeface="Calibri"/>
+                <a:cs typeface="Calibri"/>
+              </a:rPr>
+              <a:t>Saved sittings reopen after restart.</a:t>
             </a:r>
           </a:p>
         </p:txBody>
       </p:sp>
       <p:sp>
         <p:nvSpPr>
-          <p:cNvPr id="26" name="Callout D">
+          <p:cNvPr id="25" name="Callout C">
             <a:extLst xmlns:a="http://schemas.openxmlformats.org/drawingml/2006/main">
               <a:ext uri="{FF2B5EF4-FFF2-40B4-BE49-F238E27FC236}">
-                <a16:creationId xmlns:a16="http://schemas.microsoft.com/office/drawing/2014/main" id="{293D8C09-A0FC-4495-BE7C-40A5224D36BD}"/>
+                <a16:creationId xmlns:a16="http://schemas.microsoft.com/office/drawing/2014/main" id="{B67403E3-FC74-4B26-AC97-BE503CAA9F2D}"/>
               </a:ext>
             </a:extLst>
           </p:cNvPr>
@@ -3937,7 +4007,7 @@
         </p:nvSpPr>
         <p:spPr>
           <a:xfrm xmlns:a="http://schemas.openxmlformats.org/drawingml/2006/main">
-            <a:off x="11664000" y="11232000"/>
+            <a:off x="12492000" y="9000000"/>
             <a:ext cx="594000" cy="594000"/>
           </a:xfrm>
           <a:prstGeom xmlns:a="http://schemas.openxmlformats.org/drawingml/2006/main" prst="ellipse">
@@ -3987,17 +4057,17 @@
                 <a:ea typeface="Cambria"/>
                 <a:cs typeface="Cambria"/>
               </a:rPr>
-              <a:t>D</a:t>
+              <a:t>C</a:t>
             </a:r>
           </a:p>
         </p:txBody>
       </p:sp>
       <p:sp>
         <p:nvSpPr>
-          <p:cNvPr id="27" name="Callout D heading">
+          <p:cNvPr id="26" name="Callout C heading">
             <a:extLst xmlns:a="http://schemas.openxmlformats.org/drawingml/2006/main">
               <a:ext uri="{FF2B5EF4-FFF2-40B4-BE49-F238E27FC236}">
-                <a16:creationId xmlns:a16="http://schemas.microsoft.com/office/drawing/2014/main" id="{8AFDA614-7713-41DB-8F50-7B3DEF7812BE}"/>
+                <a16:creationId xmlns:a16="http://schemas.microsoft.com/office/drawing/2014/main" id="{AF056640-2E9E-43D2-9632-8251314B1BE0}"/>
               </a:ext>
             </a:extLst>
           </p:cNvPr>
@@ -4008,8 +4078,8 @@
         </p:nvSpPr>
         <p:spPr>
           <a:xfrm xmlns:a="http://schemas.openxmlformats.org/drawingml/2006/main">
-            <a:off x="12528000" y="11196000"/>
-            <a:ext cx="8419320" cy="540000"/>
+            <a:off x="13320000" y="8964000"/>
+            <a:ext cx="7627320" cy="486000"/>
           </a:xfrm>
           <a:prstGeom xmlns:a="http://schemas.openxmlformats.org/drawingml/2006/main" prst="rect">
             <a:avLst/>
@@ -4025,7 +4095,7 @@
           </a:bodyPr>
           <a:lstStyle xmlns:a="http://schemas.openxmlformats.org/drawingml/2006/main">
             <a:defPPr algn="l">
-              <a:defRPr sz="3000" b="1" i="0">
+              <a:defRPr sz="2900" b="1" i="0">
                 <a:solidFill>
                   <a:srgbClr val="1F2A24"/>
                 </a:solidFill>
@@ -4041,7 +4111,7 @@
                 <a:spcPct val="108000"/>
               </a:lnSpc>
               <a:buNone/>
-              <a:defRPr sz="3000" b="1" i="0">
+              <a:defRPr sz="2900" b="1" i="0">
                 <a:solidFill>
                   <a:srgbClr val="1F2A24"/>
                 </a:solidFill>
@@ -4051,7 +4121,7 @@
               </a:defRPr>
             </a:pPr>
             <a:r>
-              <a:rPr sz="3000" b="1" i="0">
+              <a:rPr sz="2900" b="1" i="0">
                 <a:solidFill>
                   <a:srgbClr val="1F2A24"/>
                 </a:solidFill>
@@ -4059,17 +4129,17 @@
                 <a:ea typeface="Cambria"/>
                 <a:cs typeface="Cambria"/>
               </a:rPr>
-              <a:t>Exports and evaluation</a:t>
+              <a:t>The Speaker’s Chair</a:t>
             </a:r>
           </a:p>
         </p:txBody>
       </p:sp>
       <p:sp>
         <p:nvSpPr>
-          <p:cNvPr id="28" name="Callout D detail">
+          <p:cNvPr id="27" name="Callout C detail">
             <a:extLst xmlns:a="http://schemas.openxmlformats.org/drawingml/2006/main">
               <a:ext uri="{FF2B5EF4-FFF2-40B4-BE49-F238E27FC236}">
-                <a16:creationId xmlns:a16="http://schemas.microsoft.com/office/drawing/2014/main" id="{A29E22A1-0E1D-45A9-8C69-E880135AD19A}"/>
+                <a16:creationId xmlns:a16="http://schemas.microsoft.com/office/drawing/2014/main" id="{35E0A6D7-C7D4-4108-BD2B-7A18386BC236}"/>
               </a:ext>
             </a:extLst>
           </p:cNvPr>
@@ -4080,8 +4150,8 @@
         </p:nvSpPr>
         <p:spPr>
           <a:xfrm xmlns:a="http://schemas.openxmlformats.org/drawingml/2006/main">
-            <a:off x="12528000" y="11772000"/>
-            <a:ext cx="8419320" cy="1008000"/>
+            <a:off x="13320000" y="9486000"/>
+            <a:ext cx="7627320" cy="792000"/>
           </a:xfrm>
           <a:prstGeom xmlns:a="http://schemas.openxmlformats.org/drawingml/2006/main" prst="rect">
             <a:avLst/>
@@ -4097,7 +4167,7 @@
           </a:bodyPr>
           <a:lstStyle xmlns:a="http://schemas.openxmlformats.org/drawingml/2006/main">
             <a:defPPr algn="l">
-              <a:defRPr sz="2800" b="0" i="0">
+              <a:defRPr sz="2550" b="0" i="0">
                 <a:solidFill>
                   <a:srgbClr val="56615B"/>
                 </a:solidFill>
@@ -4113,7 +4183,7 @@
                 <a:spcPct val="108000"/>
               </a:lnSpc>
               <a:buNone/>
-              <a:defRPr sz="2800" b="0" i="0">
+              <a:defRPr sz="2550" b="0" i="0">
                 <a:solidFill>
                   <a:srgbClr val="56615B"/>
                 </a:solidFill>
@@ -4123,7 +4193,7 @@
               </a:defRPr>
             </a:pPr>
             <a:r>
-              <a:rPr sz="2800" b="0" i="0">
+              <a:rPr sz="2550" b="0" i="0">
                 <a:solidFill>
                   <a:srgbClr val="56615B"/>
                 </a:solidFill>
@@ -4131,17 +4201,44 @@
                 <a:ea typeface="Calibri"/>
                 <a:cs typeface="Calibri"/>
               </a:rPr>
-              <a:t>Download JSON/text and run local analysis or the separate LLM rubric.</a:t>
+              <a:t>Your rulings reach every member</a:t>
+            </a:r>
+          </a:p>
+          <a:p xmlns:a="http://schemas.openxmlformats.org/drawingml/2006/main">
+            <a:pPr algn="l">
+              <a:lnSpc>
+                <a:spcPct val="108000"/>
+              </a:lnSpc>
+              <a:buNone/>
+              <a:defRPr sz="2550" b="0" i="0">
+                <a:solidFill>
+                  <a:srgbClr val="56615B"/>
+                </a:solidFill>
+                <a:latin typeface="Calibri"/>
+                <a:ea typeface="Calibri"/>
+                <a:cs typeface="Calibri"/>
+              </a:defRPr>
+            </a:pPr>
+            <a:r>
+              <a:rPr sz="2550" b="0" i="0">
+                <a:solidFill>
+                  <a:srgbClr val="56615B"/>
+                </a:solidFill>
+                <a:latin typeface="Calibri"/>
+                <a:ea typeface="Calibri"/>
+                <a:cs typeface="Calibri"/>
+              </a:rPr>
+              <a:t>before the next scheduled speech.</a:t>
             </a:r>
           </a:p>
         </p:txBody>
       </p:sp>
       <p:sp>
         <p:nvSpPr>
-          <p:cNvPr id="29" name="Frontend caption">
+          <p:cNvPr id="28" name="Callout D">
             <a:extLst xmlns:a="http://schemas.openxmlformats.org/drawingml/2006/main">
               <a:ext uri="{FF2B5EF4-FFF2-40B4-BE49-F238E27FC236}">
-                <a16:creationId xmlns:a16="http://schemas.microsoft.com/office/drawing/2014/main" id="{C46B8AB4-514C-4871-B680-2B0594640AF3}"/>
+                <a16:creationId xmlns:a16="http://schemas.microsoft.com/office/drawing/2014/main" id="{6E754E0F-092A-4B29-80A9-72C88D9AFB15}"/>
               </a:ext>
             </a:extLst>
           </p:cNvPr>
@@ -4152,68 +4249,67 @@
         </p:nvSpPr>
         <p:spPr>
           <a:xfrm xmlns:a="http://schemas.openxmlformats.org/drawingml/2006/main">
-            <a:off x="868680" y="12852000"/>
-            <a:ext cx="20078640" cy="432000"/>
+            <a:off x="12492000" y="10368000"/>
+            <a:ext cx="594000" cy="594000"/>
           </a:xfrm>
-          <a:prstGeom xmlns:a="http://schemas.openxmlformats.org/drawingml/2006/main" prst="rect">
-            <a:avLst/>
-          </a:prstGeom>
-          <a:noFill xmlns:a="http://schemas.openxmlformats.org/drawingml/2006/main"/>
-          <a:ln xmlns:a="http://schemas.openxmlformats.org/drawingml/2006/main" w="0">
-            <a:noFill/>
+          <a:prstGeom xmlns:a="http://schemas.openxmlformats.org/drawingml/2006/main" prst="ellipse">
+            <a:avLst/>
+          </a:prstGeom>
+          <a:solidFill xmlns:a="http://schemas.openxmlformats.org/drawingml/2006/main">
+            <a:srgbClr val="C9971C"/>
+          </a:solidFill>
+          <a:ln xmlns:a="http://schemas.openxmlformats.org/drawingml/2006/main" w="14288">
+            <a:solidFill>
+              <a:srgbClr val="FFFFFF"/>
+            </a:solidFill>
+            <a:prstDash val="solid"/>
           </a:ln>
         </p:spPr>
         <p:txBody>
-          <a:bodyPr xmlns:a="http://schemas.openxmlformats.org/drawingml/2006/main" wrap="square" lIns="0" tIns="0" rIns="0" bIns="0" anchor="t">
-            <a:noAutofit/>
-          </a:bodyPr>
+          <a:bodyPr xmlns:a="http://schemas.openxmlformats.org/drawingml/2006/main" lIns="0" tIns="0" rIns="0" bIns="0" anchor="ctr"/>
           <a:lstStyle xmlns:a="http://schemas.openxmlformats.org/drawingml/2006/main">
-            <a:defPPr algn="l">
-              <a:defRPr sz="2300" b="0" i="1">
-                <a:solidFill>
-                  <a:srgbClr val="56615B"/>
-                </a:solidFill>
-                <a:latin typeface="Calibri"/>
-                <a:ea typeface="Calibri"/>
-                <a:cs typeface="Calibri"/>
+            <a:defPPr algn="ctr">
+              <a:defRPr sz="3000" b="1">
+                <a:solidFill>
+                  <a:srgbClr val="FFFFFF"/>
+                </a:solidFill>
+                <a:latin typeface="Cambria"/>
+                <a:ea typeface="Cambria"/>
+                <a:cs typeface="Cambria"/>
               </a:defRPr>
             </a:defPPr>
           </a:lstStyle>
           <a:p xmlns:a="http://schemas.openxmlformats.org/drawingml/2006/main">
-            <a:pPr algn="l">
-              <a:lnSpc>
-                <a:spcPct val="108000"/>
-              </a:lnSpc>
-              <a:buNone/>
-              <a:defRPr sz="2300" b="0" i="1">
-                <a:solidFill>
-                  <a:srgbClr val="56615B"/>
-                </a:solidFill>
-                <a:latin typeface="Calibri"/>
-                <a:ea typeface="Calibri"/>
-                <a:cs typeface="Calibri"/>
-              </a:defRPr>
-            </a:pPr>
-            <a:r>
-              <a:rPr sz="2300" b="0" i="1">
-                <a:solidFill>
-                  <a:srgbClr val="56615B"/>
-                </a:solidFill>
-                <a:latin typeface="Calibri"/>
-                <a:ea typeface="Calibri"/>
-                <a:cs typeface="Calibri"/>
-              </a:rPr>
-              <a:t>Fig. 1 Updated browser (deterministic demo). Browser, guided CLI and commands share one backend.</a:t>
+            <a:pPr algn="ctr">
+              <a:defRPr sz="3000" b="1">
+                <a:solidFill>
+                  <a:srgbClr val="FFFFFF"/>
+                </a:solidFill>
+                <a:latin typeface="Cambria"/>
+                <a:ea typeface="Cambria"/>
+                <a:cs typeface="Cambria"/>
+              </a:defRPr>
+            </a:pPr>
+            <a:r>
+              <a:rPr sz="3000" b="1">
+                <a:solidFill>
+                  <a:srgbClr val="FFFFFF"/>
+                </a:solidFill>
+                <a:latin typeface="Cambria"/>
+                <a:ea typeface="Cambria"/>
+                <a:cs typeface="Cambria"/>
+              </a:rPr>
+              <a:t>D</a:t>
             </a:r>
           </a:p>
         </p:txBody>
       </p:sp>
       <p:sp>
         <p:nvSpPr>
-          <p:cNvPr id="30" name="Section 2 number">
+          <p:cNvPr id="29" name="Callout D heading">
             <a:extLst xmlns:a="http://schemas.openxmlformats.org/drawingml/2006/main">
               <a:ext uri="{FF2B5EF4-FFF2-40B4-BE49-F238E27FC236}">
-                <a16:creationId xmlns:a16="http://schemas.microsoft.com/office/drawing/2014/main" id="{7793E4B7-0B8F-49BB-92C3-DCD74F901DA2}"/>
+                <a16:creationId xmlns:a16="http://schemas.microsoft.com/office/drawing/2014/main" id="{34191CEC-7FE2-45C2-BBC0-B4F8B08DA6A0}"/>
               </a:ext>
             </a:extLst>
           </p:cNvPr>
@@ -4224,27 +4320,26 @@
         </p:nvSpPr>
         <p:spPr>
           <a:xfrm xmlns:a="http://schemas.openxmlformats.org/drawingml/2006/main">
-            <a:off x="868680" y="13536000"/>
-            <a:ext cx="712800" cy="712800"/>
+            <a:off x="13320000" y="10332000"/>
+            <a:ext cx="7627320" cy="486000"/>
           </a:xfrm>
-          <a:prstGeom xmlns:a="http://schemas.openxmlformats.org/drawingml/2006/main" prst="ellipse">
-            <a:avLst/>
-          </a:prstGeom>
-          <a:solidFill xmlns:a="http://schemas.openxmlformats.org/drawingml/2006/main">
-            <a:srgbClr val="C9971C"/>
-          </a:solidFill>
+          <a:prstGeom xmlns:a="http://schemas.openxmlformats.org/drawingml/2006/main" prst="rect">
+            <a:avLst/>
+          </a:prstGeom>
+          <a:noFill xmlns:a="http://schemas.openxmlformats.org/drawingml/2006/main"/>
           <a:ln xmlns:a="http://schemas.openxmlformats.org/drawingml/2006/main" w="0">
             <a:noFill/>
-            <a:prstDash val="solid"/>
           </a:ln>
         </p:spPr>
         <p:txBody>
-          <a:bodyPr xmlns:a="http://schemas.openxmlformats.org/drawingml/2006/main" lIns="0" tIns="0" rIns="0" bIns="0" anchor="ctr"/>
+          <a:bodyPr xmlns:a="http://schemas.openxmlformats.org/drawingml/2006/main" wrap="square" lIns="0" tIns="0" rIns="0" bIns="0" anchor="t">
+            <a:noAutofit/>
+          </a:bodyPr>
           <a:lstStyle xmlns:a="http://schemas.openxmlformats.org/drawingml/2006/main">
-            <a:defPPr algn="ctr">
-              <a:defRPr sz="3700" b="1">
-                <a:solidFill>
-                  <a:srgbClr val="FFFFFF"/>
+            <a:defPPr algn="l">
+              <a:defRPr sz="2900" b="1" i="0">
+                <a:solidFill>
+                  <a:srgbClr val="1F2A24"/>
                 </a:solidFill>
                 <a:latin typeface="Cambria"/>
                 <a:ea typeface="Cambria"/>
@@ -4253,36 +4348,40 @@
             </a:defPPr>
           </a:lstStyle>
           <a:p xmlns:a="http://schemas.openxmlformats.org/drawingml/2006/main">
-            <a:pPr algn="ctr">
-              <a:defRPr sz="3700" b="1">
-                <a:solidFill>
-                  <a:srgbClr val="FFFFFF"/>
-                </a:solidFill>
-                <a:latin typeface="Cambria"/>
-                <a:ea typeface="Cambria"/>
-                <a:cs typeface="Cambria"/>
-              </a:defRPr>
-            </a:pPr>
-            <a:r>
-              <a:rPr sz="3700" b="1">
-                <a:solidFill>
-                  <a:srgbClr val="FFFFFF"/>
-                </a:solidFill>
-                <a:latin typeface="Cambria"/>
-                <a:ea typeface="Cambria"/>
-                <a:cs typeface="Cambria"/>
-              </a:rPr>
-              <a:t>2</a:t>
+            <a:pPr algn="l">
+              <a:lnSpc>
+                <a:spcPct val="108000"/>
+              </a:lnSpc>
+              <a:buNone/>
+              <a:defRPr sz="2900" b="1" i="0">
+                <a:solidFill>
+                  <a:srgbClr val="1F2A24"/>
+                </a:solidFill>
+                <a:latin typeface="Cambria"/>
+                <a:ea typeface="Cambria"/>
+                <a:cs typeface="Cambria"/>
+              </a:defRPr>
+            </a:pPr>
+            <a:r>
+              <a:rPr sz="2900" b="1" i="0">
+                <a:solidFill>
+                  <a:srgbClr val="1F2A24"/>
+                </a:solidFill>
+                <a:latin typeface="Cambria"/>
+                <a:ea typeface="Cambria"/>
+                <a:cs typeface="Cambria"/>
+              </a:rPr>
+              <a:t>Order Paper and Tally</a:t>
             </a:r>
           </a:p>
         </p:txBody>
       </p:sp>
       <p:sp>
         <p:nvSpPr>
-          <p:cNvPr id="31" name="Section 2 title">
+          <p:cNvPr id="30" name="Callout D detail">
             <a:extLst xmlns:a="http://schemas.openxmlformats.org/drawingml/2006/main">
               <a:ext uri="{FF2B5EF4-FFF2-40B4-BE49-F238E27FC236}">
-                <a16:creationId xmlns:a16="http://schemas.microsoft.com/office/drawing/2014/main" id="{514E9BC7-2A4F-4A15-88E6-0238784804A1}"/>
+                <a16:creationId xmlns:a16="http://schemas.microsoft.com/office/drawing/2014/main" id="{193ACA6D-6B83-4920-907A-E20FE7CAB97D}"/>
               </a:ext>
             </a:extLst>
           </p:cNvPr>
@@ -4293,6 +4392,515 @@
         </p:nvSpPr>
         <p:spPr>
           <a:xfrm xmlns:a="http://schemas.openxmlformats.org/drawingml/2006/main">
+            <a:off x="13320000" y="10854000"/>
+            <a:ext cx="7627320" cy="792000"/>
+          </a:xfrm>
+          <a:prstGeom xmlns:a="http://schemas.openxmlformats.org/drawingml/2006/main" prst="rect">
+            <a:avLst/>
+          </a:prstGeom>
+          <a:noFill xmlns:a="http://schemas.openxmlformats.org/drawingml/2006/main"/>
+          <a:ln xmlns:a="http://schemas.openxmlformats.org/drawingml/2006/main" w="0">
+            <a:noFill/>
+          </a:ln>
+        </p:spPr>
+        <p:txBody>
+          <a:bodyPr xmlns:a="http://schemas.openxmlformats.org/drawingml/2006/main" wrap="square" lIns="0" tIns="0" rIns="0" bIns="0" anchor="t">
+            <a:noAutofit/>
+          </a:bodyPr>
+          <a:lstStyle xmlns:a="http://schemas.openxmlformats.org/drawingml/2006/main">
+            <a:defPPr algn="l">
+              <a:defRPr sz="2550" b="0" i="0">
+                <a:solidFill>
+                  <a:srgbClr val="56615B"/>
+                </a:solidFill>
+                <a:latin typeface="Calibri"/>
+                <a:ea typeface="Calibri"/>
+                <a:cs typeface="Calibri"/>
+              </a:defRPr>
+            </a:defPPr>
+          </a:lstStyle>
+          <a:p xmlns:a="http://schemas.openxmlformats.org/drawingml/2006/main">
+            <a:pPr algn="l">
+              <a:lnSpc>
+                <a:spcPct val="108000"/>
+              </a:lnSpc>
+              <a:buNone/>
+              <a:defRPr sz="2550" b="0" i="0">
+                <a:solidFill>
+                  <a:srgbClr val="56615B"/>
+                </a:solidFill>
+                <a:latin typeface="Calibri"/>
+                <a:ea typeface="Calibri"/>
+                <a:cs typeface="Calibri"/>
+              </a:defRPr>
+            </a:pPr>
+            <a:r>
+              <a:rPr sz="2550" b="0" i="0">
+                <a:solidFill>
+                  <a:srgbClr val="56615B"/>
+                </a:solidFill>
+                <a:latin typeface="Calibri"/>
+                <a:ea typeface="Calibri"/>
+                <a:cs typeface="Calibri"/>
+              </a:rPr>
+              <a:t>Topics progress through the agenda.</a:t>
+            </a:r>
+          </a:p>
+          <a:p xmlns:a="http://schemas.openxmlformats.org/drawingml/2006/main">
+            <a:pPr algn="l">
+              <a:lnSpc>
+                <a:spcPct val="108000"/>
+              </a:lnSpc>
+              <a:buNone/>
+              <a:defRPr sz="2550" b="0" i="0">
+                <a:solidFill>
+                  <a:srgbClr val="56615B"/>
+                </a:solidFill>
+                <a:latin typeface="Calibri"/>
+                <a:ea typeface="Calibri"/>
+                <a:cs typeface="Calibri"/>
+              </a:defRPr>
+            </a:pPr>
+            <a:r>
+              <a:rPr sz="2550" b="0" i="0">
+                <a:solidFill>
+                  <a:srgbClr val="56615B"/>
+                </a:solidFill>
+                <a:latin typeface="Calibri"/>
+                <a:ea typeface="Calibri"/>
+                <a:cs typeface="Calibri"/>
+              </a:rPr>
+              <a:t>Speeches and interjections count live.</a:t>
+            </a:r>
+          </a:p>
+        </p:txBody>
+      </p:sp>
+      <p:sp>
+        <p:nvSpPr>
+          <p:cNvPr id="31" name="Callout E">
+            <a:extLst xmlns:a="http://schemas.openxmlformats.org/drawingml/2006/main">
+              <a:ext uri="{FF2B5EF4-FFF2-40B4-BE49-F238E27FC236}">
+                <a16:creationId xmlns:a16="http://schemas.microsoft.com/office/drawing/2014/main" id="{9C877C35-571B-43B9-BCAC-ABF9A6767CFE}"/>
+              </a:ext>
+            </a:extLst>
+          </p:cNvPr>
+          <p:cNvSpPr>
+            <a:spLocks xmlns:a="http://schemas.openxmlformats.org/drawingml/2006/main" noGrp="1"/>
+          </p:cNvSpPr>
+          <p:nvPr/>
+        </p:nvSpPr>
+        <p:spPr>
+          <a:xfrm xmlns:a="http://schemas.openxmlformats.org/drawingml/2006/main">
+            <a:off x="12492000" y="11736000"/>
+            <a:ext cx="594000" cy="594000"/>
+          </a:xfrm>
+          <a:prstGeom xmlns:a="http://schemas.openxmlformats.org/drawingml/2006/main" prst="ellipse">
+            <a:avLst/>
+          </a:prstGeom>
+          <a:solidFill xmlns:a="http://schemas.openxmlformats.org/drawingml/2006/main">
+            <a:srgbClr val="C9971C"/>
+          </a:solidFill>
+          <a:ln xmlns:a="http://schemas.openxmlformats.org/drawingml/2006/main" w="14288">
+            <a:solidFill>
+              <a:srgbClr val="FFFFFF"/>
+            </a:solidFill>
+            <a:prstDash val="solid"/>
+          </a:ln>
+        </p:spPr>
+        <p:txBody>
+          <a:bodyPr xmlns:a="http://schemas.openxmlformats.org/drawingml/2006/main" lIns="0" tIns="0" rIns="0" bIns="0" anchor="ctr"/>
+          <a:lstStyle xmlns:a="http://schemas.openxmlformats.org/drawingml/2006/main">
+            <a:defPPr algn="ctr">
+              <a:defRPr sz="3000" b="1">
+                <a:solidFill>
+                  <a:srgbClr val="FFFFFF"/>
+                </a:solidFill>
+                <a:latin typeface="Cambria"/>
+                <a:ea typeface="Cambria"/>
+                <a:cs typeface="Cambria"/>
+              </a:defRPr>
+            </a:defPPr>
+          </a:lstStyle>
+          <a:p xmlns:a="http://schemas.openxmlformats.org/drawingml/2006/main">
+            <a:pPr algn="ctr">
+              <a:defRPr sz="3000" b="1">
+                <a:solidFill>
+                  <a:srgbClr val="FFFFFF"/>
+                </a:solidFill>
+                <a:latin typeface="Cambria"/>
+                <a:ea typeface="Cambria"/>
+                <a:cs typeface="Cambria"/>
+              </a:defRPr>
+            </a:pPr>
+            <a:r>
+              <a:rPr sz="3000" b="1">
+                <a:solidFill>
+                  <a:srgbClr val="FFFFFF"/>
+                </a:solidFill>
+                <a:latin typeface="Cambria"/>
+                <a:ea typeface="Cambria"/>
+                <a:cs typeface="Cambria"/>
+              </a:rPr>
+              <a:t>E</a:t>
+            </a:r>
+          </a:p>
+        </p:txBody>
+      </p:sp>
+      <p:sp>
+        <p:nvSpPr>
+          <p:cNvPr id="32" name="Callout E heading">
+            <a:extLst xmlns:a="http://schemas.openxmlformats.org/drawingml/2006/main">
+              <a:ext uri="{FF2B5EF4-FFF2-40B4-BE49-F238E27FC236}">
+                <a16:creationId xmlns:a16="http://schemas.microsoft.com/office/drawing/2014/main" id="{81D5F344-A289-4786-887C-8CE02DD7454B}"/>
+              </a:ext>
+            </a:extLst>
+          </p:cNvPr>
+          <p:cNvSpPr>
+            <a:spLocks xmlns:a="http://schemas.openxmlformats.org/drawingml/2006/main" noGrp="1"/>
+          </p:cNvSpPr>
+          <p:nvPr/>
+        </p:nvSpPr>
+        <p:spPr>
+          <a:xfrm xmlns:a="http://schemas.openxmlformats.org/drawingml/2006/main">
+            <a:off x="13320000" y="11700000"/>
+            <a:ext cx="7627320" cy="486000"/>
+          </a:xfrm>
+          <a:prstGeom xmlns:a="http://schemas.openxmlformats.org/drawingml/2006/main" prst="rect">
+            <a:avLst/>
+          </a:prstGeom>
+          <a:noFill xmlns:a="http://schemas.openxmlformats.org/drawingml/2006/main"/>
+          <a:ln xmlns:a="http://schemas.openxmlformats.org/drawingml/2006/main" w="0">
+            <a:noFill/>
+          </a:ln>
+        </p:spPr>
+        <p:txBody>
+          <a:bodyPr xmlns:a="http://schemas.openxmlformats.org/drawingml/2006/main" wrap="square" lIns="0" tIns="0" rIns="0" bIns="0" anchor="t">
+            <a:noAutofit/>
+          </a:bodyPr>
+          <a:lstStyle xmlns:a="http://schemas.openxmlformats.org/drawingml/2006/main">
+            <a:defPPr algn="l">
+              <a:defRPr sz="2900" b="1" i="0">
+                <a:solidFill>
+                  <a:srgbClr val="1F2A24"/>
+                </a:solidFill>
+                <a:latin typeface="Cambria"/>
+                <a:ea typeface="Cambria"/>
+                <a:cs typeface="Cambria"/>
+              </a:defRPr>
+            </a:defPPr>
+          </a:lstStyle>
+          <a:p xmlns:a="http://schemas.openxmlformats.org/drawingml/2006/main">
+            <a:pPr algn="l">
+              <a:lnSpc>
+                <a:spcPct val="108000"/>
+              </a:lnSpc>
+              <a:buNone/>
+              <a:defRPr sz="2900" b="1" i="0">
+                <a:solidFill>
+                  <a:srgbClr val="1F2A24"/>
+                </a:solidFill>
+                <a:latin typeface="Cambria"/>
+                <a:ea typeface="Cambria"/>
+                <a:cs typeface="Cambria"/>
+              </a:defRPr>
+            </a:pPr>
+            <a:r>
+              <a:rPr sz="2900" b="1" i="0">
+                <a:solidFill>
+                  <a:srgbClr val="1F2A24"/>
+                </a:solidFill>
+                <a:latin typeface="Cambria"/>
+                <a:ea typeface="Cambria"/>
+                <a:cs typeface="Cambria"/>
+              </a:rPr>
+              <a:t>Exports and evaluation</a:t>
+            </a:r>
+          </a:p>
+        </p:txBody>
+      </p:sp>
+      <p:sp>
+        <p:nvSpPr>
+          <p:cNvPr id="33" name="Callout E detail">
+            <a:extLst xmlns:a="http://schemas.openxmlformats.org/drawingml/2006/main">
+              <a:ext uri="{FF2B5EF4-FFF2-40B4-BE49-F238E27FC236}">
+                <a16:creationId xmlns:a16="http://schemas.microsoft.com/office/drawing/2014/main" id="{D3708402-09B1-4DAE-9744-BCFDDB6F7D74}"/>
+              </a:ext>
+            </a:extLst>
+          </p:cNvPr>
+          <p:cNvSpPr>
+            <a:spLocks xmlns:a="http://schemas.openxmlformats.org/drawingml/2006/main" noGrp="1"/>
+          </p:cNvSpPr>
+          <p:nvPr/>
+        </p:nvSpPr>
+        <p:spPr>
+          <a:xfrm xmlns:a="http://schemas.openxmlformats.org/drawingml/2006/main">
+            <a:off x="13320000" y="12222000"/>
+            <a:ext cx="7627320" cy="792000"/>
+          </a:xfrm>
+          <a:prstGeom xmlns:a="http://schemas.openxmlformats.org/drawingml/2006/main" prst="rect">
+            <a:avLst/>
+          </a:prstGeom>
+          <a:noFill xmlns:a="http://schemas.openxmlformats.org/drawingml/2006/main"/>
+          <a:ln xmlns:a="http://schemas.openxmlformats.org/drawingml/2006/main" w="0">
+            <a:noFill/>
+          </a:ln>
+        </p:spPr>
+        <p:txBody>
+          <a:bodyPr xmlns:a="http://schemas.openxmlformats.org/drawingml/2006/main" wrap="square" lIns="0" tIns="0" rIns="0" bIns="0" anchor="t">
+            <a:noAutofit/>
+          </a:bodyPr>
+          <a:lstStyle xmlns:a="http://schemas.openxmlformats.org/drawingml/2006/main">
+            <a:defPPr algn="l">
+              <a:defRPr sz="2550" b="0" i="0">
+                <a:solidFill>
+                  <a:srgbClr val="56615B"/>
+                </a:solidFill>
+                <a:latin typeface="Calibri"/>
+                <a:ea typeface="Calibri"/>
+                <a:cs typeface="Calibri"/>
+              </a:defRPr>
+            </a:defPPr>
+          </a:lstStyle>
+          <a:p xmlns:a="http://schemas.openxmlformats.org/drawingml/2006/main">
+            <a:pPr algn="l">
+              <a:lnSpc>
+                <a:spcPct val="108000"/>
+              </a:lnSpc>
+              <a:buNone/>
+              <a:defRPr sz="2550" b="0" i="0">
+                <a:solidFill>
+                  <a:srgbClr val="56615B"/>
+                </a:solidFill>
+                <a:latin typeface="Calibri"/>
+                <a:ea typeface="Calibri"/>
+                <a:cs typeface="Calibri"/>
+              </a:defRPr>
+            </a:pPr>
+            <a:r>
+              <a:rPr sz="2550" b="0" i="0">
+                <a:solidFill>
+                  <a:srgbClr val="56615B"/>
+                </a:solidFill>
+                <a:latin typeface="Calibri"/>
+                <a:ea typeface="Calibri"/>
+                <a:cs typeface="Calibri"/>
+              </a:rPr>
+              <a:t>Download JSON or text. Run local</a:t>
+            </a:r>
+          </a:p>
+          <a:p xmlns:a="http://schemas.openxmlformats.org/drawingml/2006/main">
+            <a:pPr algn="l">
+              <a:lnSpc>
+                <a:spcPct val="108000"/>
+              </a:lnSpc>
+              <a:buNone/>
+              <a:defRPr sz="2550" b="0" i="0">
+                <a:solidFill>
+                  <a:srgbClr val="56615B"/>
+                </a:solidFill>
+                <a:latin typeface="Calibri"/>
+                <a:ea typeface="Calibri"/>
+                <a:cs typeface="Calibri"/>
+              </a:defRPr>
+            </a:pPr>
+            <a:r>
+              <a:rPr sz="2550" b="0" i="0">
+                <a:solidFill>
+                  <a:srgbClr val="56615B"/>
+                </a:solidFill>
+                <a:latin typeface="Calibri"/>
+                <a:ea typeface="Calibri"/>
+                <a:cs typeface="Calibri"/>
+              </a:rPr>
+              <a:t>analysis or the separate LLM rubric.</a:t>
+            </a:r>
+          </a:p>
+        </p:txBody>
+      </p:sp>
+      <p:sp>
+        <p:nvSpPr>
+          <p:cNvPr id="34" name="Frontend caption">
+            <a:extLst xmlns:a="http://schemas.openxmlformats.org/drawingml/2006/main">
+              <a:ext uri="{FF2B5EF4-FFF2-40B4-BE49-F238E27FC236}">
+                <a16:creationId xmlns:a16="http://schemas.microsoft.com/office/drawing/2014/main" id="{DBFFF7E2-6124-4472-9699-6B8119176CCD}"/>
+              </a:ext>
+            </a:extLst>
+          </p:cNvPr>
+          <p:cNvSpPr>
+            <a:spLocks xmlns:a="http://schemas.openxmlformats.org/drawingml/2006/main" noGrp="1"/>
+          </p:cNvSpPr>
+          <p:nvPr/>
+        </p:nvSpPr>
+        <p:spPr>
+          <a:xfrm xmlns:a="http://schemas.openxmlformats.org/drawingml/2006/main">
+            <a:off x="868680" y="12456000"/>
+            <a:ext cx="11160000" cy="792000"/>
+          </a:xfrm>
+          <a:prstGeom xmlns:a="http://schemas.openxmlformats.org/drawingml/2006/main" prst="rect">
+            <a:avLst/>
+          </a:prstGeom>
+          <a:noFill xmlns:a="http://schemas.openxmlformats.org/drawingml/2006/main"/>
+          <a:ln xmlns:a="http://schemas.openxmlformats.org/drawingml/2006/main" w="0">
+            <a:noFill/>
+          </a:ln>
+        </p:spPr>
+        <p:txBody>
+          <a:bodyPr xmlns:a="http://schemas.openxmlformats.org/drawingml/2006/main" wrap="square" lIns="0" tIns="0" rIns="0" bIns="0" anchor="t">
+            <a:noAutofit/>
+          </a:bodyPr>
+          <a:lstStyle xmlns:a="http://schemas.openxmlformats.org/drawingml/2006/main">
+            <a:defPPr algn="l">
+              <a:defRPr sz="2200" b="0" i="1">
+                <a:solidFill>
+                  <a:srgbClr val="56615B"/>
+                </a:solidFill>
+                <a:latin typeface="Calibri"/>
+                <a:ea typeface="Calibri"/>
+                <a:cs typeface="Calibri"/>
+              </a:defRPr>
+            </a:defPPr>
+          </a:lstStyle>
+          <a:p xmlns:a="http://schemas.openxmlformats.org/drawingml/2006/main">
+            <a:pPr algn="l">
+              <a:lnSpc>
+                <a:spcPct val="108000"/>
+              </a:lnSpc>
+              <a:buNone/>
+              <a:defRPr sz="2200" b="0" i="1">
+                <a:solidFill>
+                  <a:srgbClr val="56615B"/>
+                </a:solidFill>
+                <a:latin typeface="Calibri"/>
+                <a:ea typeface="Calibri"/>
+                <a:cs typeface="Calibri"/>
+              </a:defRPr>
+            </a:pPr>
+            <a:r>
+              <a:rPr sz="2200" b="0" i="1">
+                <a:solidFill>
+                  <a:srgbClr val="56615B"/>
+                </a:solidFill>
+                <a:latin typeface="Calibri"/>
+                <a:ea typeface="Calibri"/>
+                <a:cs typeface="Calibri"/>
+              </a:rPr>
+              <a:t>Fig. 1 Updated browser in deterministic demo mode.</a:t>
+            </a:r>
+          </a:p>
+          <a:p xmlns:a="http://schemas.openxmlformats.org/drawingml/2006/main">
+            <a:pPr algn="l">
+              <a:lnSpc>
+                <a:spcPct val="108000"/>
+              </a:lnSpc>
+              <a:buNone/>
+              <a:defRPr sz="2200" b="0" i="1">
+                <a:solidFill>
+                  <a:srgbClr val="56615B"/>
+                </a:solidFill>
+                <a:latin typeface="Calibri"/>
+                <a:ea typeface="Calibri"/>
+                <a:cs typeface="Calibri"/>
+              </a:defRPr>
+            </a:pPr>
+            <a:r>
+              <a:rPr sz="2200" b="0" i="1">
+                <a:solidFill>
+                  <a:srgbClr val="56615B"/>
+                </a:solidFill>
+                <a:latin typeface="Calibri"/>
+                <a:ea typeface="Calibri"/>
+                <a:cs typeface="Calibri"/>
+              </a:rPr>
+              <a:t>Browser, guided CLI and commands share one backend.</a:t>
+            </a:r>
+          </a:p>
+        </p:txBody>
+      </p:sp>
+      <p:sp>
+        <p:nvSpPr>
+          <p:cNvPr id="35" name="Section 2 number">
+            <a:extLst xmlns:a="http://schemas.openxmlformats.org/drawingml/2006/main">
+              <a:ext uri="{FF2B5EF4-FFF2-40B4-BE49-F238E27FC236}">
+                <a16:creationId xmlns:a16="http://schemas.microsoft.com/office/drawing/2014/main" id="{EE963207-0B83-421D-BEDD-8EE7D868E1FC}"/>
+              </a:ext>
+            </a:extLst>
+          </p:cNvPr>
+          <p:cNvSpPr>
+            <a:spLocks xmlns:a="http://schemas.openxmlformats.org/drawingml/2006/main" noGrp="1"/>
+          </p:cNvSpPr>
+          <p:nvPr/>
+        </p:nvSpPr>
+        <p:spPr>
+          <a:xfrm xmlns:a="http://schemas.openxmlformats.org/drawingml/2006/main">
+            <a:off x="868680" y="13536000"/>
+            <a:ext cx="712800" cy="712800"/>
+          </a:xfrm>
+          <a:prstGeom xmlns:a="http://schemas.openxmlformats.org/drawingml/2006/main" prst="ellipse">
+            <a:avLst/>
+          </a:prstGeom>
+          <a:solidFill xmlns:a="http://schemas.openxmlformats.org/drawingml/2006/main">
+            <a:srgbClr val="C9971C"/>
+          </a:solidFill>
+          <a:ln xmlns:a="http://schemas.openxmlformats.org/drawingml/2006/main" w="0">
+            <a:noFill/>
+            <a:prstDash val="solid"/>
+          </a:ln>
+        </p:spPr>
+        <p:txBody>
+          <a:bodyPr xmlns:a="http://schemas.openxmlformats.org/drawingml/2006/main" lIns="0" tIns="0" rIns="0" bIns="0" anchor="ctr"/>
+          <a:lstStyle xmlns:a="http://schemas.openxmlformats.org/drawingml/2006/main">
+            <a:defPPr algn="ctr">
+              <a:defRPr sz="3700" b="1">
+                <a:solidFill>
+                  <a:srgbClr val="FFFFFF"/>
+                </a:solidFill>
+                <a:latin typeface="Cambria"/>
+                <a:ea typeface="Cambria"/>
+                <a:cs typeface="Cambria"/>
+              </a:defRPr>
+            </a:defPPr>
+          </a:lstStyle>
+          <a:p xmlns:a="http://schemas.openxmlformats.org/drawingml/2006/main">
+            <a:pPr algn="ctr">
+              <a:defRPr sz="3700" b="1">
+                <a:solidFill>
+                  <a:srgbClr val="FFFFFF"/>
+                </a:solidFill>
+                <a:latin typeface="Cambria"/>
+                <a:ea typeface="Cambria"/>
+                <a:cs typeface="Cambria"/>
+              </a:defRPr>
+            </a:pPr>
+            <a:r>
+              <a:rPr sz="3700" b="1">
+                <a:solidFill>
+                  <a:srgbClr val="FFFFFF"/>
+                </a:solidFill>
+                <a:latin typeface="Cambria"/>
+                <a:ea typeface="Cambria"/>
+                <a:cs typeface="Cambria"/>
+              </a:rPr>
+              <a:t>2</a:t>
+            </a:r>
+          </a:p>
+        </p:txBody>
+      </p:sp>
+      <p:sp>
+        <p:nvSpPr>
+          <p:cNvPr id="36" name="Section 2 title">
+            <a:extLst xmlns:a="http://schemas.openxmlformats.org/drawingml/2006/main">
+              <a:ext uri="{FF2B5EF4-FFF2-40B4-BE49-F238E27FC236}">
+                <a16:creationId xmlns:a16="http://schemas.microsoft.com/office/drawing/2014/main" id="{A06A18A8-0322-4B43-A186-F99E5DF7DF88}"/>
+              </a:ext>
+            </a:extLst>
+          </p:cNvPr>
+          <p:cNvSpPr>
+            <a:spLocks xmlns:a="http://schemas.openxmlformats.org/drawingml/2006/main" noGrp="1"/>
+          </p:cNvSpPr>
+          <p:nvPr/>
+        </p:nvSpPr>
+        <p:spPr>
+          <a:xfrm xmlns:a="http://schemas.openxmlformats.org/drawingml/2006/main">
             <a:off x="1836000" y="13482000"/>
             <a:ext cx="19080000" cy="900000"/>
           </a:xfrm>
@@ -4351,10 +4959,10 @@
       </p:sp>
       <p:sp>
         <p:nvSpPr>
-          <p:cNvPr id="32" name="Hansard corpus">
+          <p:cNvPr id="37" name="Hansard corpus">
             <a:extLst xmlns:a="http://schemas.openxmlformats.org/drawingml/2006/main">
               <a:ext uri="{FF2B5EF4-FFF2-40B4-BE49-F238E27FC236}">
-                <a16:creationId xmlns:a16="http://schemas.microsoft.com/office/drawing/2014/main" id="{0CA7BB97-F69C-405F-942C-95990C79D528}"/>
+                <a16:creationId xmlns:a16="http://schemas.microsoft.com/office/drawing/2014/main" id="{F9DFD882-C997-4C7F-B12A-2768C3757EAC}"/>
               </a:ext>
             </a:extLst>
           </p:cNvPr>
@@ -4384,10 +4992,10 @@
       </p:sp>
       <p:sp>
         <p:nvSpPr>
-          <p:cNvPr id="33" name="Hansard corpus title">
+          <p:cNvPr id="38" name="Hansard corpus title">
             <a:extLst xmlns:a="http://schemas.openxmlformats.org/drawingml/2006/main">
               <a:ext uri="{FF2B5EF4-FFF2-40B4-BE49-F238E27FC236}">
-                <a16:creationId xmlns:a16="http://schemas.microsoft.com/office/drawing/2014/main" id="{332A67F7-2544-4F6C-8FF7-7F4620A4E666}"/>
+                <a16:creationId xmlns:a16="http://schemas.microsoft.com/office/drawing/2014/main" id="{44776AB9-F98E-4AB7-BE55-289859B671B8}"/>
               </a:ext>
             </a:extLst>
           </p:cNvPr>
@@ -4456,10 +5064,10 @@
       </p:sp>
       <p:sp>
         <p:nvSpPr>
-          <p:cNvPr id="34" name="Hansard corpus description">
+          <p:cNvPr id="39" name="Hansard corpus description">
             <a:extLst xmlns:a="http://schemas.openxmlformats.org/drawingml/2006/main">
               <a:ext uri="{FF2B5EF4-FFF2-40B4-BE49-F238E27FC236}">
-                <a16:creationId xmlns:a16="http://schemas.microsoft.com/office/drawing/2014/main" id="{CACFF53D-2945-453A-BB7B-3D2C7056C8C1}"/>
+                <a16:creationId xmlns:a16="http://schemas.microsoft.com/office/drawing/2014/main" id="{34662A16-5AFE-47E2-A678-2118F65BAC57}"/>
               </a:ext>
             </a:extLst>
           </p:cNvPr>
@@ -4555,10 +5163,10 @@
       </p:sp>
       <p:sp>
         <p:nvSpPr>
-          <p:cNvPr id="35" name="Agent setup">
+          <p:cNvPr id="40" name="Agent setup">
             <a:extLst xmlns:a="http://schemas.openxmlformats.org/drawingml/2006/main">
               <a:ext uri="{FF2B5EF4-FFF2-40B4-BE49-F238E27FC236}">
-                <a16:creationId xmlns:a16="http://schemas.microsoft.com/office/drawing/2014/main" id="{66BB9BA0-94C6-4035-A880-97F4ADFB508A}"/>
+                <a16:creationId xmlns:a16="http://schemas.microsoft.com/office/drawing/2014/main" id="{51E186DC-E1B8-4969-BA89-08330B66F5BC}"/>
               </a:ext>
             </a:extLst>
           </p:cNvPr>
@@ -4588,10 +5196,10 @@
       </p:sp>
       <p:sp>
         <p:nvSpPr>
-          <p:cNvPr id="36" name="Agent setup title">
+          <p:cNvPr id="41" name="Agent setup title">
             <a:extLst xmlns:a="http://schemas.openxmlformats.org/drawingml/2006/main">
               <a:ext uri="{FF2B5EF4-FFF2-40B4-BE49-F238E27FC236}">
-                <a16:creationId xmlns:a16="http://schemas.microsoft.com/office/drawing/2014/main" id="{9D34CABF-84E0-4BAE-9024-73A0FE75F963}"/>
+                <a16:creationId xmlns:a16="http://schemas.microsoft.com/office/drawing/2014/main" id="{D4455769-D602-4587-9B57-148D9881568F}"/>
               </a:ext>
             </a:extLst>
           </p:cNvPr>
@@ -4660,10 +5268,10 @@
       </p:sp>
       <p:sp>
         <p:nvSpPr>
-          <p:cNvPr id="37" name="Agent setup description">
+          <p:cNvPr id="42" name="Agent setup description">
             <a:extLst xmlns:a="http://schemas.openxmlformats.org/drawingml/2006/main">
               <a:ext uri="{FF2B5EF4-FFF2-40B4-BE49-F238E27FC236}">
-                <a16:creationId xmlns:a16="http://schemas.microsoft.com/office/drawing/2014/main" id="{84EFA342-F4C3-4BE2-89A7-8EE5E618C4C7}"/>
+                <a16:creationId xmlns:a16="http://schemas.microsoft.com/office/drawing/2014/main" id="{12BD6865-43E3-45C4-AB39-19FD804059E5}"/>
               </a:ext>
             </a:extLst>
           </p:cNvPr>
@@ -4759,10 +5367,10 @@
       </p:sp>
       <p:sp>
         <p:nvSpPr>
-          <p:cNvPr id="38" name="MP agents">
+          <p:cNvPr id="43" name="MP agents">
             <a:extLst xmlns:a="http://schemas.openxmlformats.org/drawingml/2006/main">
               <a:ext uri="{FF2B5EF4-FFF2-40B4-BE49-F238E27FC236}">
-                <a16:creationId xmlns:a16="http://schemas.microsoft.com/office/drawing/2014/main" id="{A63FCA0B-91A2-41AB-965C-3430B5CD0EEA}"/>
+                <a16:creationId xmlns:a16="http://schemas.microsoft.com/office/drawing/2014/main" id="{F26AD4AD-E772-4F67-A2FD-32E8DA664E59}"/>
               </a:ext>
             </a:extLst>
           </p:cNvPr>
@@ -4792,10 +5400,10 @@
       </p:sp>
       <p:sp>
         <p:nvSpPr>
-          <p:cNvPr id="39" name="MP agents title">
+          <p:cNvPr id="44" name="MP agents title">
             <a:extLst xmlns:a="http://schemas.openxmlformats.org/drawingml/2006/main">
               <a:ext uri="{FF2B5EF4-FFF2-40B4-BE49-F238E27FC236}">
-                <a16:creationId xmlns:a16="http://schemas.microsoft.com/office/drawing/2014/main" id="{2406CC30-22EE-407A-9505-824189A2F90A}"/>
+                <a16:creationId xmlns:a16="http://schemas.microsoft.com/office/drawing/2014/main" id="{9CC7923A-9E5B-4B74-9C95-789FC43F0EE2}"/>
               </a:ext>
             </a:extLst>
           </p:cNvPr>
@@ -4864,10 +5472,10 @@
       </p:sp>
       <p:sp>
         <p:nvSpPr>
-          <p:cNvPr id="40" name="MP agents description">
+          <p:cNvPr id="45" name="MP agents description">
             <a:extLst xmlns:a="http://schemas.openxmlformats.org/drawingml/2006/main">
               <a:ext uri="{FF2B5EF4-FFF2-40B4-BE49-F238E27FC236}">
-                <a16:creationId xmlns:a16="http://schemas.microsoft.com/office/drawing/2014/main" id="{4A83CF05-643A-4DA9-8E91-D2DF69B3F73F}"/>
+                <a16:creationId xmlns:a16="http://schemas.microsoft.com/office/drawing/2014/main" id="{72CFE1BD-97CC-46C8-9E32-73718A868A15}"/>
               </a:ext>
             </a:extLst>
           </p:cNvPr>
@@ -4963,10 +5571,10 @@
       </p:sp>
       <p:sp>
         <p:nvSpPr>
-          <p:cNvPr id="41" name="Debate scheduler">
+          <p:cNvPr id="46" name="Debate scheduler">
             <a:extLst xmlns:a="http://schemas.openxmlformats.org/drawingml/2006/main">
               <a:ext uri="{FF2B5EF4-FFF2-40B4-BE49-F238E27FC236}">
-                <a16:creationId xmlns:a16="http://schemas.microsoft.com/office/drawing/2014/main" id="{80748280-E403-48F6-862F-C0F6616E5B79}"/>
+                <a16:creationId xmlns:a16="http://schemas.microsoft.com/office/drawing/2014/main" id="{4B3881A6-6B56-4094-A205-D866BB71B9EA}"/>
               </a:ext>
             </a:extLst>
           </p:cNvPr>
@@ -4996,10 +5604,10 @@
       </p:sp>
       <p:sp>
         <p:nvSpPr>
-          <p:cNvPr id="42" name="Debate scheduler title">
+          <p:cNvPr id="47" name="Debate scheduler title">
             <a:extLst xmlns:a="http://schemas.openxmlformats.org/drawingml/2006/main">
               <a:ext uri="{FF2B5EF4-FFF2-40B4-BE49-F238E27FC236}">
-                <a16:creationId xmlns:a16="http://schemas.microsoft.com/office/drawing/2014/main" id="{91AC3189-21E4-4CA9-BBA5-63EC456F6A8D}"/>
+                <a16:creationId xmlns:a16="http://schemas.microsoft.com/office/drawing/2014/main" id="{E0E9F200-EBCD-46F1-B877-CD5A4CB4322D}"/>
               </a:ext>
             </a:extLst>
           </p:cNvPr>
@@ -5068,10 +5676,10 @@
       </p:sp>
       <p:sp>
         <p:nvSpPr>
-          <p:cNvPr id="43" name="Debate scheduler description">
+          <p:cNvPr id="48" name="Debate scheduler description">
             <a:extLst xmlns:a="http://schemas.openxmlformats.org/drawingml/2006/main">
               <a:ext uri="{FF2B5EF4-FFF2-40B4-BE49-F238E27FC236}">
-                <a16:creationId xmlns:a16="http://schemas.microsoft.com/office/drawing/2014/main" id="{D6C063B5-F292-4DF2-9C20-6A538D501DB4}"/>
+                <a16:creationId xmlns:a16="http://schemas.microsoft.com/office/drawing/2014/main" id="{5B3EC711-5BC0-4DEB-ABCB-75C2BA807539}"/>
               </a:ext>
             </a:extLst>
           </p:cNvPr>
@@ -5167,10 +5775,10 @@
       </p:sp>
       <p:sp>
         <p:nvSpPr>
-          <p:cNvPr id="44" name="Public results">
+          <p:cNvPr id="49" name="Public results">
             <a:extLst xmlns:a="http://schemas.openxmlformats.org/drawingml/2006/main">
               <a:ext uri="{FF2B5EF4-FFF2-40B4-BE49-F238E27FC236}">
-                <a16:creationId xmlns:a16="http://schemas.microsoft.com/office/drawing/2014/main" id="{6C94EFE3-DF49-4E8F-BB4D-E32529CB63F4}"/>
+                <a16:creationId xmlns:a16="http://schemas.microsoft.com/office/drawing/2014/main" id="{96EBE6A3-B677-40B5-9BAB-C9C21D518DBF}"/>
               </a:ext>
             </a:extLst>
           </p:cNvPr>
@@ -5200,10 +5808,10 @@
       </p:sp>
       <p:sp>
         <p:nvSpPr>
-          <p:cNvPr id="45" name="Public results title">
+          <p:cNvPr id="50" name="Public results title">
             <a:extLst xmlns:a="http://schemas.openxmlformats.org/drawingml/2006/main">
               <a:ext uri="{FF2B5EF4-FFF2-40B4-BE49-F238E27FC236}">
-                <a16:creationId xmlns:a16="http://schemas.microsoft.com/office/drawing/2014/main" id="{D35F1CE1-8FCB-4710-AC0D-EA3FF3B0EB35}"/>
+                <a16:creationId xmlns:a16="http://schemas.microsoft.com/office/drawing/2014/main" id="{753EF102-A7D8-4A11-B562-52F2E3F44679}"/>
               </a:ext>
             </a:extLst>
           </p:cNvPr>
@@ -5272,10 +5880,10 @@
       </p:sp>
       <p:sp>
         <p:nvSpPr>
-          <p:cNvPr id="46" name="Public results description">
+          <p:cNvPr id="51" name="Public results description">
             <a:extLst xmlns:a="http://schemas.openxmlformats.org/drawingml/2006/main">
               <a:ext uri="{FF2B5EF4-FFF2-40B4-BE49-F238E27FC236}">
-                <a16:creationId xmlns:a16="http://schemas.microsoft.com/office/drawing/2014/main" id="{1D3F2171-54BD-4E61-AD93-1D8FCFAA13E9}"/>
+                <a16:creationId xmlns:a16="http://schemas.microsoft.com/office/drawing/2014/main" id="{49B2CA7F-DF53-42E7-8649-D4BF8DE5D094}"/>
               </a:ext>
             </a:extLst>
           </p:cNvPr>
@@ -5371,10 +5979,10 @@
       </p:sp>
       <p:sp>
         <p:nvSpPr>
-          <p:cNvPr id="51" name="Model and snapshot detail">
+          <p:cNvPr id="56" name="Model and snapshot detail">
             <a:extLst xmlns:a="http://schemas.openxmlformats.org/drawingml/2006/main">
               <a:ext uri="{FF2B5EF4-FFF2-40B4-BE49-F238E27FC236}">
-                <a16:creationId xmlns:a16="http://schemas.microsoft.com/office/drawing/2014/main" id="{9CCD3FF8-E21C-44E7-99FF-088741B4C7E4}"/>
+                <a16:creationId xmlns:a16="http://schemas.microsoft.com/office/drawing/2014/main" id="{54385973-CD99-4B3F-86F2-2F8ADBDE4CE8}"/>
               </a:ext>
             </a:extLst>
           </p:cNvPr>
@@ -5443,10 +6051,10 @@
       </p:sp>
       <p:sp>
         <p:nvSpPr>
-          <p:cNvPr id="52" name="Analysis and privacy detail">
+          <p:cNvPr id="57" name="Analysis and privacy detail">
             <a:extLst xmlns:a="http://schemas.openxmlformats.org/drawingml/2006/main">
               <a:ext uri="{FF2B5EF4-FFF2-40B4-BE49-F238E27FC236}">
-                <a16:creationId xmlns:a16="http://schemas.microsoft.com/office/drawing/2014/main" id="{0BA9B58E-71CA-4C80-955D-08535ABA9322}"/>
+                <a16:creationId xmlns:a16="http://schemas.microsoft.com/office/drawing/2014/main" id="{EC796F0B-FF8A-4F7F-985C-D0A4A7D5F505}"/>
               </a:ext>
             </a:extLst>
           </p:cNvPr>
@@ -5515,10 +6123,10 @@
       </p:sp>
       <p:sp>
         <p:nvSpPr>
-          <p:cNvPr id="53" name="Section 3 number">
+          <p:cNvPr id="58" name="Section 3 number">
             <a:extLst xmlns:a="http://schemas.openxmlformats.org/drawingml/2006/main">
               <a:ext uri="{FF2B5EF4-FFF2-40B4-BE49-F238E27FC236}">
-                <a16:creationId xmlns:a16="http://schemas.microsoft.com/office/drawing/2014/main" id="{17360308-99BF-4C55-98E0-C4067097CEE9}"/>
+                <a16:creationId xmlns:a16="http://schemas.microsoft.com/office/drawing/2014/main" id="{E1ABA709-7338-45EE-A103-AFB6FC57B278}"/>
               </a:ext>
             </a:extLst>
           </p:cNvPr>
@@ -5584,10 +6192,10 @@
       </p:sp>
       <p:sp>
         <p:nvSpPr>
-          <p:cNvPr id="54" name="Section 3 title">
+          <p:cNvPr id="59" name="Section 3 title">
             <a:extLst xmlns:a="http://schemas.openxmlformats.org/drawingml/2006/main">
               <a:ext uri="{FF2B5EF4-FFF2-40B4-BE49-F238E27FC236}">
-                <a16:creationId xmlns:a16="http://schemas.microsoft.com/office/drawing/2014/main" id="{9622C639-F98E-4553-9F76-C5469FCBAC66}"/>
+                <a16:creationId xmlns:a16="http://schemas.microsoft.com/office/drawing/2014/main" id="{CD7DA6B2-F5A8-4566-9F19-C8F1D5DE2E4A}"/>
               </a:ext>
             </a:extLst>
           </p:cNvPr>
@@ -5656,10 +6264,10 @@
       </p:sp>
       <p:sp>
         <p:nvSpPr>
-          <p:cNvPr id="55" name="Study matrix">
+          <p:cNvPr id="60" name="Study matrix">
             <a:extLst xmlns:a="http://schemas.openxmlformats.org/drawingml/2006/main">
               <a:ext uri="{FF2B5EF4-FFF2-40B4-BE49-F238E27FC236}">
-                <a16:creationId xmlns:a16="http://schemas.microsoft.com/office/drawing/2014/main" id="{19037CA7-72B8-49EE-BCD9-2EFADEF7ED8D}"/>
+                <a16:creationId xmlns:a16="http://schemas.microsoft.com/office/drawing/2014/main" id="{10A6A563-B0AC-482A-ACDE-03AFA158E37B}"/>
               </a:ext>
             </a:extLst>
           </p:cNvPr>
@@ -5728,10 +6336,10 @@
       </p:sp>
       <p:sp>
         <p:nvSpPr>
-          <p:cNvPr id="56" name="Study conditions">
+          <p:cNvPr id="61" name="Study conditions">
             <a:extLst xmlns:a="http://schemas.openxmlformats.org/drawingml/2006/main">
               <a:ext uri="{FF2B5EF4-FFF2-40B4-BE49-F238E27FC236}">
-                <a16:creationId xmlns:a16="http://schemas.microsoft.com/office/drawing/2014/main" id="{57F671EA-6558-4D17-B288-431FC86F024E}"/>
+                <a16:creationId xmlns:a16="http://schemas.microsoft.com/office/drawing/2014/main" id="{E58234A4-F9E3-4700-8535-97B257F37DB1}"/>
               </a:ext>
             </a:extLst>
           </p:cNvPr>
@@ -5800,10 +6408,10 @@
       </p:sp>
       <p:graphicFrame>
         <p:nvGraphicFramePr>
-          <p:cNvPr id="57" name="Chart">
+          <p:cNvPr id="62" name="Chart">
             <a:extLst xmlns:a="http://schemas.openxmlformats.org/drawingml/2006/main">
               <a:ext uri="{FF2B5EF4-FFF2-40B4-BE49-F238E27FC236}">
-                <a16:creationId xmlns:a16="http://schemas.microsoft.com/office/drawing/2014/main" id="{3400B616-64A3-4000-B387-CC5A01C72CE9}"/>
+                <a16:creationId xmlns:a16="http://schemas.microsoft.com/office/drawing/2014/main" id="{0753D30E-89BB-4DA5-8C32-553AB9EA5AA5}"/>
               </a:ext>
             </a:extLst>
           </p:cNvPr>
@@ -5816,16 +6424,16 @@
         </p:xfrm>
         <a:graphic xmlns:a="http://schemas.openxmlformats.org/drawingml/2006/main">
           <a:graphicData uri="http://schemas.openxmlformats.org/drawingml/2006/chart">
-            <c:chart xmlns:r="http://schemas.openxmlformats.org/officeDocument/2006/relationships" xmlns:c="http://schemas.openxmlformats.org/drawingml/2006/chart" r:id="Rcb4d5422211843a7"/>
+            <c:chart xmlns:r="http://schemas.openxmlformats.org/officeDocument/2006/relationships" xmlns:c="http://schemas.openxmlformats.org/drawingml/2006/chart" r:id="Rbf5bde43cbfb4c63"/>
           </a:graphicData>
         </a:graphic>
       </p:graphicFrame>
       <p:graphicFrame>
         <p:nvGraphicFramePr>
-          <p:cNvPr id="58" name="Chart">
+          <p:cNvPr id="63" name="Chart">
             <a:extLst xmlns:a="http://schemas.openxmlformats.org/drawingml/2006/main">
               <a:ext uri="{FF2B5EF4-FFF2-40B4-BE49-F238E27FC236}">
-                <a16:creationId xmlns:a16="http://schemas.microsoft.com/office/drawing/2014/main" id="{31515160-14D9-4AA0-9712-422C6C124AC3}"/>
+                <a16:creationId xmlns:a16="http://schemas.microsoft.com/office/drawing/2014/main" id="{AC9B5128-DAF2-47E6-A010-06F49816F901}"/>
               </a:ext>
             </a:extLst>
           </p:cNvPr>
@@ -5838,16 +6446,16 @@
         </p:xfrm>
         <a:graphic xmlns:a="http://schemas.openxmlformats.org/drawingml/2006/main">
           <a:graphicData uri="http://schemas.openxmlformats.org/drawingml/2006/chart">
-            <c:chart xmlns:r="http://schemas.openxmlformats.org/officeDocument/2006/relationships" xmlns:c="http://schemas.openxmlformats.org/drawingml/2006/chart" r:id="R8826c41150904d26"/>
+            <c:chart xmlns:r="http://schemas.openxmlformats.org/officeDocument/2006/relationships" xmlns:c="http://schemas.openxmlformats.org/drawingml/2006/chart" r:id="Ra09bff7bfd254e59"/>
           </a:graphicData>
         </a:graphic>
       </p:graphicFrame>
       <p:graphicFrame>
         <p:nvGraphicFramePr>
-          <p:cNvPr id="59" name="Chart">
+          <p:cNvPr id="64" name="Chart">
             <a:extLst xmlns:a="http://schemas.openxmlformats.org/drawingml/2006/main">
               <a:ext uri="{FF2B5EF4-FFF2-40B4-BE49-F238E27FC236}">
-                <a16:creationId xmlns:a16="http://schemas.microsoft.com/office/drawing/2014/main" id="{C3B9929A-EFE8-46E0-9450-90F417CADFA2}"/>
+                <a16:creationId xmlns:a16="http://schemas.microsoft.com/office/drawing/2014/main" id="{258FAEAD-A3B2-4BDC-B415-291D6B4A24A7}"/>
               </a:ext>
             </a:extLst>
           </p:cNvPr>
@@ -5860,16 +6468,16 @@
         </p:xfrm>
         <a:graphic xmlns:a="http://schemas.openxmlformats.org/drawingml/2006/main">
           <a:graphicData uri="http://schemas.openxmlformats.org/drawingml/2006/chart">
-            <c:chart xmlns:r="http://schemas.openxmlformats.org/officeDocument/2006/relationships" xmlns:c="http://schemas.openxmlformats.org/drawingml/2006/chart" r:id="R90d6a888ad264a00"/>
+            <c:chart xmlns:r="http://schemas.openxmlformats.org/officeDocument/2006/relationships" xmlns:c="http://schemas.openxmlformats.org/drawingml/2006/chart" r:id="Rd6877207c77348e9"/>
           </a:graphicData>
         </a:graphic>
       </p:graphicFrame>
       <p:sp>
         <p:nvSpPr>
-          <p:cNvPr id="60" name="Observed consistency drop">
+          <p:cNvPr id="65" name="Observed consistency drop">
             <a:extLst xmlns:a="http://schemas.openxmlformats.org/drawingml/2006/main">
               <a:ext uri="{FF2B5EF4-FFF2-40B4-BE49-F238E27FC236}">
-                <a16:creationId xmlns:a16="http://schemas.microsoft.com/office/drawing/2014/main" id="{85A371FA-A171-42A6-9480-96C3028CE26F}"/>
+                <a16:creationId xmlns:a16="http://schemas.microsoft.com/office/drawing/2014/main" id="{8336BCC5-346B-4042-943D-B65194272ACC}"/>
               </a:ext>
             </a:extLst>
           </p:cNvPr>
@@ -5938,10 +6546,10 @@
       </p:sp>
       <p:sp>
         <p:nvSpPr>
-          <p:cNvPr id="61" name="Other rubric metrics">
+          <p:cNvPr id="66" name="Other rubric metrics">
             <a:extLst xmlns:a="http://schemas.openxmlformats.org/drawingml/2006/main">
               <a:ext uri="{FF2B5EF4-FFF2-40B4-BE49-F238E27FC236}">
-                <a16:creationId xmlns:a16="http://schemas.microsoft.com/office/drawing/2014/main" id="{7B4C399A-92CE-4DF7-88E4-FD4292217475}"/>
+                <a16:creationId xmlns:a16="http://schemas.microsoft.com/office/drawing/2014/main" id="{5952B3D3-D38D-4E7B-A14A-366A4136F4D3}"/>
               </a:ext>
             </a:extLst>
           </p:cNvPr>
@@ -6010,10 +6618,10 @@
       </p:sp>
       <p:sp>
         <p:nvSpPr>
-          <p:cNvPr id="62" name="Rubric interpretation">
+          <p:cNvPr id="67" name="Rubric interpretation">
             <a:extLst xmlns:a="http://schemas.openxmlformats.org/drawingml/2006/main">
               <a:ext uri="{FF2B5EF4-FFF2-40B4-BE49-F238E27FC236}">
-                <a16:creationId xmlns:a16="http://schemas.microsoft.com/office/drawing/2014/main" id="{19A90F81-4F28-4827-A019-1B91F45B9F58}"/>
+                <a16:creationId xmlns:a16="http://schemas.microsoft.com/office/drawing/2014/main" id="{EB8F58FC-4949-4998-9F73-659D657F898C}"/>
               </a:ext>
             </a:extLst>
           </p:cNvPr>
@@ -6082,10 +6690,10 @@
       </p:sp>
       <p:sp>
         <p:nvSpPr>
-          <p:cNvPr id="63" name="Research limitations">
+          <p:cNvPr id="68" name="Research limitations">
             <a:extLst xmlns:a="http://schemas.openxmlformats.org/drawingml/2006/main">
               <a:ext uri="{FF2B5EF4-FFF2-40B4-BE49-F238E27FC236}">
-                <a16:creationId xmlns:a16="http://schemas.microsoft.com/office/drawing/2014/main" id="{E8EE6740-1B80-42A3-AC3A-243E3F9E5629}"/>
+                <a16:creationId xmlns:a16="http://schemas.microsoft.com/office/drawing/2014/main" id="{33EFBB0A-8772-4FCA-AEEB-145BBAEB51E5}"/>
               </a:ext>
             </a:extLst>
           </p:cNvPr>
@@ -6154,10 +6762,10 @@
       </p:sp>
       <p:sp>
         <p:nvSpPr>
-          <p:cNvPr id="64" name="Section 4 number">
+          <p:cNvPr id="69" name="Section 4 number">
             <a:extLst xmlns:a="http://schemas.openxmlformats.org/drawingml/2006/main">
               <a:ext uri="{FF2B5EF4-FFF2-40B4-BE49-F238E27FC236}">
-                <a16:creationId xmlns:a16="http://schemas.microsoft.com/office/drawing/2014/main" id="{ADDC81EB-29E4-4A35-B744-FC9BB6C3A4C0}"/>
+                <a16:creationId xmlns:a16="http://schemas.microsoft.com/office/drawing/2014/main" id="{307E73CD-7F41-4B57-9B40-A4774F37E96F}"/>
               </a:ext>
             </a:extLst>
           </p:cNvPr>
@@ -6223,10 +6831,10 @@
       </p:sp>
       <p:sp>
         <p:nvSpPr>
-          <p:cNvPr id="65" name="Section 4 title">
+          <p:cNvPr id="70" name="Section 4 title">
             <a:extLst xmlns:a="http://schemas.openxmlformats.org/drawingml/2006/main">
               <a:ext uri="{FF2B5EF4-FFF2-40B4-BE49-F238E27FC236}">
-                <a16:creationId xmlns:a16="http://schemas.microsoft.com/office/drawing/2014/main" id="{94188C11-07DD-49B8-B25C-1B752A368910}"/>
+                <a16:creationId xmlns:a16="http://schemas.microsoft.com/office/drawing/2014/main" id="{2655BC4B-EBA1-4F3B-9C15-C5A616728F95}"/>
               </a:ext>
             </a:extLst>
           </p:cNvPr>
@@ -6295,10 +6903,10 @@
       </p:sp>
       <p:sp>
         <p:nvSpPr>
-          <p:cNvPr id="66" name="Outcome heading">
+          <p:cNvPr id="71" name="Outcome heading">
             <a:extLst xmlns:a="http://schemas.openxmlformats.org/drawingml/2006/main">
               <a:ext uri="{FF2B5EF4-FFF2-40B4-BE49-F238E27FC236}">
-                <a16:creationId xmlns:a16="http://schemas.microsoft.com/office/drawing/2014/main" id="{CDB82213-0366-4210-A14D-FA7C41D161B4}"/>
+                <a16:creationId xmlns:a16="http://schemas.microsoft.com/office/drawing/2014/main" id="{5E5BABA5-4C22-4468-A08B-81CAFFA4AA64}"/>
               </a:ext>
             </a:extLst>
           </p:cNvPr>
@@ -6367,10 +6975,10 @@
       </p:sp>
       <p:sp>
         <p:nvSpPr>
-          <p:cNvPr id="67" name="Outcome detail">
+          <p:cNvPr id="72" name="Outcome detail">
             <a:extLst xmlns:a="http://schemas.openxmlformats.org/drawingml/2006/main">
               <a:ext uri="{FF2B5EF4-FFF2-40B4-BE49-F238E27FC236}">
-                <a16:creationId xmlns:a16="http://schemas.microsoft.com/office/drawing/2014/main" id="{30CBC3D1-2E60-4DB0-B31D-857382D6E4D9}"/>
+                <a16:creationId xmlns:a16="http://schemas.microsoft.com/office/drawing/2014/main" id="{7CD3697E-169E-464B-8D59-16E92B27985B}"/>
               </a:ext>
             </a:extLst>
           </p:cNvPr>
@@ -6439,10 +7047,10 @@
       </p:sp>
       <p:sp>
         <p:nvSpPr>
-          <p:cNvPr id="68" name="Next work heading">
+          <p:cNvPr id="73" name="Next work heading">
             <a:extLst xmlns:a="http://schemas.openxmlformats.org/drawingml/2006/main">
               <a:ext uri="{FF2B5EF4-FFF2-40B4-BE49-F238E27FC236}">
-                <a16:creationId xmlns:a16="http://schemas.microsoft.com/office/drawing/2014/main" id="{723F09A6-9CBA-466E-BB26-405C69DB064D}"/>
+                <a16:creationId xmlns:a16="http://schemas.microsoft.com/office/drawing/2014/main" id="{579273E4-E5DD-4B5F-967E-916DF32B3954}"/>
               </a:ext>
             </a:extLst>
           </p:cNvPr>
@@ -6511,10 +7119,10 @@
       </p:sp>
       <p:sp>
         <p:nvSpPr>
-          <p:cNvPr id="69" name="Next work detail">
+          <p:cNvPr id="74" name="Next work detail">
             <a:extLst xmlns:a="http://schemas.openxmlformats.org/drawingml/2006/main">
               <a:ext uri="{FF2B5EF4-FFF2-40B4-BE49-F238E27FC236}">
-                <a16:creationId xmlns:a16="http://schemas.microsoft.com/office/drawing/2014/main" id="{9DCD1B05-4FE8-49A0-AF46-8740396B653E}"/>
+                <a16:creationId xmlns:a16="http://schemas.microsoft.com/office/drawing/2014/main" id="{9107FDC2-2F92-42A3-8FF4-4E5E2BA84E7A}"/>
               </a:ext>
             </a:extLst>
           </p:cNvPr>
@@ -6583,10 +7191,10 @@
       </p:sp>
       <p:sp>
         <p:nvSpPr>
-          <p:cNvPr id="70" name="Contributions heading">
+          <p:cNvPr id="75" name="Contributions heading">
             <a:extLst xmlns:a="http://schemas.openxmlformats.org/drawingml/2006/main">
               <a:ext uri="{FF2B5EF4-FFF2-40B4-BE49-F238E27FC236}">
-                <a16:creationId xmlns:a16="http://schemas.microsoft.com/office/drawing/2014/main" id="{FFDD26A2-1190-4209-99A5-521760D08A19}"/>
+                <a16:creationId xmlns:a16="http://schemas.microsoft.com/office/drawing/2014/main" id="{427EEDCB-EE9E-4A18-89AC-3DF1127221B6}"/>
               </a:ext>
             </a:extLst>
           </p:cNvPr>
@@ -6655,10 +7263,10 @@
       </p:sp>
       <p:sp>
         <p:nvSpPr>
-          <p:cNvPr id="71" name="Contributions detail">
+          <p:cNvPr id="76" name="Contributions detail">
             <a:extLst xmlns:a="http://schemas.openxmlformats.org/drawingml/2006/main">
               <a:ext uri="{FF2B5EF4-FFF2-40B4-BE49-F238E27FC236}">
-                <a16:creationId xmlns:a16="http://schemas.microsoft.com/office/drawing/2014/main" id="{4B418FA6-2123-4B41-85C8-873F8CD7FF7A}"/>
+                <a16:creationId xmlns:a16="http://schemas.microsoft.com/office/drawing/2014/main" id="{9CAA1770-2E87-42B0-B7F7-5FEF2A95659E}"/>
               </a:ext>
             </a:extLst>
           </p:cNvPr>
@@ -6754,10 +7362,10 @@
       </p:sp>
       <p:sp>
         <p:nvSpPr>
-          <p:cNvPr id="72" name="Footer band">
+          <p:cNvPr id="77" name="Footer band">
             <a:extLst xmlns:a="http://schemas.openxmlformats.org/drawingml/2006/main">
               <a:ext uri="{FF2B5EF4-FFF2-40B4-BE49-F238E27FC236}">
-                <a16:creationId xmlns:a16="http://schemas.microsoft.com/office/drawing/2014/main" id="{B4C68F03-84C2-4855-88BC-38DDBBE9A571}"/>
+                <a16:creationId xmlns:a16="http://schemas.microsoft.com/office/drawing/2014/main" id="{E67215E2-5A6F-4525-B208-30808E8A85C6}"/>
               </a:ext>
             </a:extLst>
           </p:cNvPr>
@@ -6785,10 +7393,10 @@
       </p:sp>
       <p:sp>
         <p:nvSpPr>
-          <p:cNvPr id="73" name="References heading">
+          <p:cNvPr id="78" name="References heading">
             <a:extLst xmlns:a="http://schemas.openxmlformats.org/drawingml/2006/main">
               <a:ext uri="{FF2B5EF4-FFF2-40B4-BE49-F238E27FC236}">
-                <a16:creationId xmlns:a16="http://schemas.microsoft.com/office/drawing/2014/main" id="{0EBBE7EC-0E45-4FF9-AF14-66CB3D6F427A}"/>
+                <a16:creationId xmlns:a16="http://schemas.microsoft.com/office/drawing/2014/main" id="{1F621FB1-46EF-44B4-AA59-9211CE96D0B7}"/>
               </a:ext>
             </a:extLst>
           </p:cNvPr>
@@ -6857,10 +7465,10 @@
       </p:sp>
       <p:sp>
         <p:nvSpPr>
-          <p:cNvPr id="74" name="References detail">
+          <p:cNvPr id="79" name="References detail">
             <a:extLst xmlns:a="http://schemas.openxmlformats.org/drawingml/2006/main">
               <a:ext uri="{FF2B5EF4-FFF2-40B4-BE49-F238E27FC236}">
-                <a16:creationId xmlns:a16="http://schemas.microsoft.com/office/drawing/2014/main" id="{368D1691-A554-4513-AC9A-7A479BB0C5EA}"/>
+                <a16:creationId xmlns:a16="http://schemas.microsoft.com/office/drawing/2014/main" id="{0F5B3DDB-9D08-4B88-B2BF-B0FE77BD529C}"/>
               </a:ext>
             </a:extLst>
           </p:cNvPr>
@@ -6956,10 +7564,10 @@
       </p:sp>
       <p:sp>
         <p:nvSpPr>
-          <p:cNvPr id="75" name="Acknowledgements heading">
+          <p:cNvPr id="80" name="Acknowledgements heading">
             <a:extLst xmlns:a="http://schemas.openxmlformats.org/drawingml/2006/main">
               <a:ext uri="{FF2B5EF4-FFF2-40B4-BE49-F238E27FC236}">
-                <a16:creationId xmlns:a16="http://schemas.microsoft.com/office/drawing/2014/main" id="{C4F568C9-9777-4934-8F3B-DFCC82B9D011}"/>
+                <a16:creationId xmlns:a16="http://schemas.microsoft.com/office/drawing/2014/main" id="{54AE509E-E1AA-4014-8C45-E5FD848A8E7F}"/>
               </a:ext>
             </a:extLst>
           </p:cNvPr>
@@ -7028,10 +7636,10 @@
       </p:sp>
       <p:sp>
         <p:nvSpPr>
-          <p:cNvPr id="76" name="Acknowledgements detail">
+          <p:cNvPr id="81" name="Acknowledgements detail">
             <a:extLst xmlns:a="http://schemas.openxmlformats.org/drawingml/2006/main">
               <a:ext uri="{FF2B5EF4-FFF2-40B4-BE49-F238E27FC236}">
-                <a16:creationId xmlns:a16="http://schemas.microsoft.com/office/drawing/2014/main" id="{2BA8CD65-60CE-4BB9-A7C8-5305F3DB5FD5}"/>
+                <a16:creationId xmlns:a16="http://schemas.microsoft.com/office/drawing/2014/main" id="{A9473B90-D417-40E0-BF8B-BBFBF0AFD8A2}"/>
               </a:ext>
             </a:extLst>
           </p:cNvPr>
@@ -7127,10 +7735,10 @@
       </p:sp>
       <p:sp>
         <p:nvSpPr>
-          <p:cNvPr id="77" name="Contact heading">
+          <p:cNvPr id="82" name="Contact heading">
             <a:extLst xmlns:a="http://schemas.openxmlformats.org/drawingml/2006/main">
               <a:ext uri="{FF2B5EF4-FFF2-40B4-BE49-F238E27FC236}">
-                <a16:creationId xmlns:a16="http://schemas.microsoft.com/office/drawing/2014/main" id="{90E01D49-C46A-495C-B1AE-81A43C69A3E3}"/>
+                <a16:creationId xmlns:a16="http://schemas.microsoft.com/office/drawing/2014/main" id="{524891D8-06CE-4A2C-A5D2-E059A8ACC9F2}"/>
               </a:ext>
             </a:extLst>
           </p:cNvPr>
@@ -7199,10 +7807,10 @@
       </p:sp>
       <p:sp>
         <p:nvSpPr>
-          <p:cNvPr id="78" name="Contact detail">
+          <p:cNvPr id="83" name="Contact detail">
             <a:extLst xmlns:a="http://schemas.openxmlformats.org/drawingml/2006/main">
               <a:ext uri="{FF2B5EF4-FFF2-40B4-BE49-F238E27FC236}">
-                <a16:creationId xmlns:a16="http://schemas.microsoft.com/office/drawing/2014/main" id="{06D50F39-3261-435B-B601-63755CB2793B}"/>
+                <a16:creationId xmlns:a16="http://schemas.microsoft.com/office/drawing/2014/main" id="{92128D22-F9C4-43A2-A2E1-699FDB3D837D}"/>
               </a:ext>
             </a:extLst>
           </p:cNvPr>
@@ -7299,7 +7907,7 @@
     </p:spTree>
     <p:extLst>
       <p:ext uri="{BB962C8B-B14F-4D97-AF65-F5344CB8AC3E}">
-        <p14:creationId xmlns:p14="http://schemas.microsoft.com/office/powerpoint/2010/main" val="1306847193"/>
+        <p14:creationId xmlns:p14="http://schemas.microsoft.com/office/powerpoint/2010/main" val="1899808994"/>
       </p:ext>
     </p:extLst>
   </p:cSld>

</xml_diff>

<commit_message>
T77: improve poster paragraph spacing and remove redundant heading
</commit_message>
<xml_diff>
--- a/outputs/01a11dd5-cc80-7b52-9b9e-86da4e08d924/poster-123/Poster_123.pptx
+++ b/outputs/01a11dd5-cc80-7b52-9b9e-86da4e08d924/poster-123/Poster_123.pptx
@@ -2,13 +2,13 @@
 <file path=ppt/presentation.xml><?xml version="1.0" encoding="utf-8"?>
 <p:presentation xmlns:p="http://schemas.openxmlformats.org/presentationml/2006/main">
   <p:sldMasterIdLst>
-    <p:sldMasterId xmlns:r="http://schemas.openxmlformats.org/officeDocument/2006/relationships" id="2147483648" r:id="Rff8ad1426a3c4bcc"/>
+    <p:sldMasterId xmlns:r="http://schemas.openxmlformats.org/officeDocument/2006/relationships" id="2147483648" r:id="Rb6060e8d9b354550"/>
   </p:sldMasterIdLst>
   <p:notesMasterIdLst>
-    <p:notesMasterId xmlns:r="http://schemas.openxmlformats.org/officeDocument/2006/relationships" r:id="Rf983b7df6a12442a"/>
+    <p:notesMasterId xmlns:r="http://schemas.openxmlformats.org/officeDocument/2006/relationships" r:id="R708543664cd84d99"/>
   </p:notesMasterIdLst>
   <p:sldIdLst>
-    <p:sldId xmlns:r="http://schemas.openxmlformats.org/officeDocument/2006/relationships" id="256" r:id="Rfd59a6e25fd14611"/>
+    <p:sldId xmlns:r="http://schemas.openxmlformats.org/officeDocument/2006/relationships" id="256" r:id="R775c8bbe8f3e4e59"/>
   </p:sldIdLst>
   <p:sldSz cx="21816000" cy="30708000"/>
   <p:notesSz cx="6858000" cy="9144000"/>
@@ -652,7 +652,7 @@
   </p:cSld>
   <p:clrMap bg1="lt1" tx1="dk1" bg2="lt2" tx2="dk2" accent1="accent1" accent2="accent2" accent3="accent3" accent4="accent4" accent5="accent5" accent6="accent6" hlink="hlink" folHlink="folHlink"/>
   <p:sldLayoutIdLst>
-    <p:sldLayoutId xmlns:r="http://schemas.openxmlformats.org/officeDocument/2006/relationships" id="2147483649" r:id="R08a8069416884e02"/>
+    <p:sldLayoutId xmlns:r="http://schemas.openxmlformats.org/officeDocument/2006/relationships" id="2147483649" r:id="Rfdc34b580d034775"/>
   </p:sldLayoutIdLst>
   <p:hf sldNum="0" hdr="0" ftr="0" dt="0"/>
   <p:txStyles>
@@ -2300,7 +2300,7 @@
           <p:cNvPr id="55" name="">
             <a:extLst xmlns:a="http://schemas.openxmlformats.org/drawingml/2006/main">
               <a:ext uri="{FF2B5EF4-FFF2-40B4-BE49-F238E27FC236}">
-                <a16:creationId xmlns:a16="http://schemas.microsoft.com/office/drawing/2014/main" id="{53800E72-0833-4B33-A1F8-C9FC8F866A10}"/>
+                <a16:creationId xmlns:a16="http://schemas.microsoft.com/office/drawing/2014/main" id="{1847D159-D2A8-4633-8AB1-D0E0B505AE0A}"/>
               </a:ext>
             </a:extLst>
           </p:cNvPr>
@@ -2312,7 +2312,7 @@
         </p:nvCxnSpPr>
         <p:spPr>
           <a:xfrm xmlns:a="http://schemas.openxmlformats.org/drawingml/2006/main">
-            <a:off x="16825320" y="15264000"/>
+            <a:off x="16825320" y="15336000"/>
             <a:ext cx="531360" cy="0"/>
           </a:xfrm>
           <a:prstGeom xmlns:a="http://schemas.openxmlformats.org/drawingml/2006/main" prst="straightConnector1">
@@ -2332,7 +2332,7 @@
           <p:cNvPr id="54" name="">
             <a:extLst xmlns:a="http://schemas.openxmlformats.org/drawingml/2006/main">
               <a:ext uri="{FF2B5EF4-FFF2-40B4-BE49-F238E27FC236}">
-                <a16:creationId xmlns:a16="http://schemas.microsoft.com/office/drawing/2014/main" id="{04781196-ED48-4133-B738-DC54B3BF76D7}"/>
+                <a16:creationId xmlns:a16="http://schemas.microsoft.com/office/drawing/2014/main" id="{6906E137-A832-4BF9-B06C-139721BE96E2}"/>
               </a:ext>
             </a:extLst>
           </p:cNvPr>
@@ -2344,7 +2344,7 @@
         </p:nvCxnSpPr>
         <p:spPr>
           <a:xfrm xmlns:a="http://schemas.openxmlformats.org/drawingml/2006/main">
-            <a:off x="12703320" y="15264000"/>
+            <a:off x="12703320" y="15336000"/>
             <a:ext cx="531360" cy="0"/>
           </a:xfrm>
           <a:prstGeom xmlns:a="http://schemas.openxmlformats.org/drawingml/2006/main" prst="straightConnector1">
@@ -2364,7 +2364,7 @@
           <p:cNvPr id="53" name="">
             <a:extLst xmlns:a="http://schemas.openxmlformats.org/drawingml/2006/main">
               <a:ext uri="{FF2B5EF4-FFF2-40B4-BE49-F238E27FC236}">
-                <a16:creationId xmlns:a16="http://schemas.microsoft.com/office/drawing/2014/main" id="{0710A9CF-F710-4D4E-9C5D-65E87C3C17B9}"/>
+                <a16:creationId xmlns:a16="http://schemas.microsoft.com/office/drawing/2014/main" id="{2B73B0D0-D71B-42B0-B526-4D3CC18D384E}"/>
               </a:ext>
             </a:extLst>
           </p:cNvPr>
@@ -2376,7 +2376,7 @@
         </p:nvCxnSpPr>
         <p:spPr>
           <a:xfrm xmlns:a="http://schemas.openxmlformats.org/drawingml/2006/main">
-            <a:off x="8581320" y="15264000"/>
+            <a:off x="8581320" y="15336000"/>
             <a:ext cx="531360" cy="0"/>
           </a:xfrm>
           <a:prstGeom xmlns:a="http://schemas.openxmlformats.org/drawingml/2006/main" prst="straightConnector1">
@@ -2396,7 +2396,7 @@
           <p:cNvPr id="52" name="">
             <a:extLst xmlns:a="http://schemas.openxmlformats.org/drawingml/2006/main">
               <a:ext uri="{FF2B5EF4-FFF2-40B4-BE49-F238E27FC236}">
-                <a16:creationId xmlns:a16="http://schemas.microsoft.com/office/drawing/2014/main" id="{DDACE130-6315-43A4-856A-F3C7213D8455}"/>
+                <a16:creationId xmlns:a16="http://schemas.microsoft.com/office/drawing/2014/main" id="{3CB33C27-2F7B-41A6-B4CF-CD825AC2EA36}"/>
               </a:ext>
             </a:extLst>
           </p:cNvPr>
@@ -2408,7 +2408,7 @@
         </p:nvCxnSpPr>
         <p:spPr>
           <a:xfrm xmlns:a="http://schemas.openxmlformats.org/drawingml/2006/main">
-            <a:off x="4459320" y="15264000"/>
+            <a:off x="4459320" y="15336000"/>
             <a:ext cx="531360" cy="0"/>
           </a:xfrm>
           <a:prstGeom xmlns:a="http://schemas.openxmlformats.org/drawingml/2006/main" prst="straightConnector1">
@@ -2428,7 +2428,7 @@
           <p:cNvPr id="2" name="Shape 0">
             <a:extLst xmlns:a="http://schemas.openxmlformats.org/drawingml/2006/main">
               <a:ext uri="{FF2B5EF4-FFF2-40B4-BE49-F238E27FC236}">
-                <a16:creationId xmlns:a16="http://schemas.microsoft.com/office/drawing/2014/main" id="{A28F680D-892D-4CB2-B842-D1F895273AC6}"/>
+                <a16:creationId xmlns:a16="http://schemas.microsoft.com/office/drawing/2014/main" id="{CB4CCB0B-2F23-4A81-96F7-229DEE02AB35}"/>
               </a:ext>
             </a:extLst>
           </p:cNvPr>
@@ -2455,7 +2455,7 @@
           <p:cNvPr id="3" name="Image 0">
             <a:extLst xmlns:a="http://schemas.openxmlformats.org/drawingml/2006/main">
               <a:ext uri="{FF2B5EF4-FFF2-40B4-BE49-F238E27FC236}">
-                <a16:creationId xmlns:a16="http://schemas.microsoft.com/office/drawing/2014/main" id="{735FA733-1A1E-41BB-AAA6-FB2C117D4E5F}"/>
+                <a16:creationId xmlns:a16="http://schemas.microsoft.com/office/drawing/2014/main" id="{B24482A1-0E80-46C3-B896-8C9F7193372B}"/>
               </a:ext>
             </a:extLst>
           </p:cNvPr>
@@ -2465,7 +2465,7 @@
           <p:nvPr/>
         </p:nvPicPr>
         <p:blipFill>
-          <a:blip xmlns:r="http://schemas.openxmlformats.org/officeDocument/2006/relationships" xmlns:a="http://schemas.openxmlformats.org/drawingml/2006/main" r:embed="Rfa54486057394245"/>
+          <a:blip xmlns:r="http://schemas.openxmlformats.org/officeDocument/2006/relationships" xmlns:a="http://schemas.openxmlformats.org/drawingml/2006/main" r:embed="Rd51f35f6ded64a71"/>
           <a:stretch xmlns:a="http://schemas.openxmlformats.org/drawingml/2006/main">
             <a:fillRect l="0" t="0" r="0" b="0"/>
           </a:stretch>
@@ -2485,7 +2485,7 @@
           <p:cNvPr id="4" name="Header project number">
             <a:extLst xmlns:a="http://schemas.openxmlformats.org/drawingml/2006/main">
               <a:ext uri="{FF2B5EF4-FFF2-40B4-BE49-F238E27FC236}">
-                <a16:creationId xmlns:a16="http://schemas.microsoft.com/office/drawing/2014/main" id="{16124C23-02C7-411E-AE0D-60ACB3B4A93D}"/>
+                <a16:creationId xmlns:a16="http://schemas.microsoft.com/office/drawing/2014/main" id="{5F15569D-6194-4980-AB51-D8EE1BFDAF8A}"/>
               </a:ext>
             </a:extLst>
           </p:cNvPr>
@@ -2557,7 +2557,7 @@
           <p:cNvPr id="5" name="Header department">
             <a:extLst xmlns:a="http://schemas.openxmlformats.org/drawingml/2006/main">
               <a:ext uri="{FF2B5EF4-FFF2-40B4-BE49-F238E27FC236}">
-                <a16:creationId xmlns:a16="http://schemas.microsoft.com/office/drawing/2014/main" id="{2BA8081A-418B-490B-B5D3-A551959B7860}"/>
+                <a16:creationId xmlns:a16="http://schemas.microsoft.com/office/drawing/2014/main" id="{0D21370D-D180-4B96-8AE2-DE26514206A4}"/>
               </a:ext>
             </a:extLst>
           </p:cNvPr>
@@ -2656,7 +2656,7 @@
           <p:cNvPr id="6" name="Header title">
             <a:extLst xmlns:a="http://schemas.openxmlformats.org/drawingml/2006/main">
               <a:ext uri="{FF2B5EF4-FFF2-40B4-BE49-F238E27FC236}">
-                <a16:creationId xmlns:a16="http://schemas.microsoft.com/office/drawing/2014/main" id="{368B7D74-3651-4798-8E84-1DE70E354925}"/>
+                <a16:creationId xmlns:a16="http://schemas.microsoft.com/office/drawing/2014/main" id="{8B889488-4B6D-4AB8-82C6-239A4DEC5A76}"/>
               </a:ext>
             </a:extLst>
           </p:cNvPr>
@@ -2728,7 +2728,7 @@
           <p:cNvPr id="7" name="Header research question">
             <a:extLst xmlns:a="http://schemas.openxmlformats.org/drawingml/2006/main">
               <a:ext uri="{FF2B5EF4-FFF2-40B4-BE49-F238E27FC236}">
-                <a16:creationId xmlns:a16="http://schemas.microsoft.com/office/drawing/2014/main" id="{CC387C2F-C820-4039-AEDC-CEEE262CE31A}"/>
+                <a16:creationId xmlns:a16="http://schemas.microsoft.com/office/drawing/2014/main" id="{34D093BB-77DF-413D-881F-BE4B57FFA415}"/>
               </a:ext>
             </a:extLst>
           </p:cNvPr>
@@ -2800,7 +2800,7 @@
           <p:cNvPr id="8" name="Header authors">
             <a:extLst xmlns:a="http://schemas.openxmlformats.org/drawingml/2006/main">
               <a:ext uri="{FF2B5EF4-FFF2-40B4-BE49-F238E27FC236}">
-                <a16:creationId xmlns:a16="http://schemas.microsoft.com/office/drawing/2014/main" id="{DE0691C6-B2DF-4E8C-BA01-2C19985A1C86}"/>
+                <a16:creationId xmlns:a16="http://schemas.microsoft.com/office/drawing/2014/main" id="{AE1E232E-CE1E-4960-8F40-F1C13CD7F945}"/>
               </a:ext>
             </a:extLst>
           </p:cNvPr>
@@ -2883,7 +2883,7 @@
           <p:cNvPr id="9" name="Project overview">
             <a:extLst xmlns:a="http://schemas.openxmlformats.org/drawingml/2006/main">
               <a:ext uri="{FF2B5EF4-FFF2-40B4-BE49-F238E27FC236}">
-                <a16:creationId xmlns:a16="http://schemas.microsoft.com/office/drawing/2014/main" id="{5B87DF00-FBDB-471A-8334-F3D1495122DA}"/>
+                <a16:creationId xmlns:a16="http://schemas.microsoft.com/office/drawing/2014/main" id="{48923637-CE79-4AD4-BD35-7436958829D5}"/>
               </a:ext>
             </a:extLst>
           </p:cNvPr>
@@ -2955,7 +2955,7 @@
           <p:cNvPr id="10" name="Section 1 number">
             <a:extLst xmlns:a="http://schemas.openxmlformats.org/drawingml/2006/main">
               <a:ext uri="{FF2B5EF4-FFF2-40B4-BE49-F238E27FC236}">
-                <a16:creationId xmlns:a16="http://schemas.microsoft.com/office/drawing/2014/main" id="{F68EEA57-5CCD-4EA9-9AEB-B8E92A0FE302}"/>
+                <a16:creationId xmlns:a16="http://schemas.microsoft.com/office/drawing/2014/main" id="{A1888ED6-C1A8-4788-8ED9-AF67303D53B4}"/>
               </a:ext>
             </a:extLst>
           </p:cNvPr>
@@ -3024,7 +3024,7 @@
           <p:cNvPr id="11" name="Section 1 title">
             <a:extLst xmlns:a="http://schemas.openxmlformats.org/drawingml/2006/main">
               <a:ext uri="{FF2B5EF4-FFF2-40B4-BE49-F238E27FC236}">
-                <a16:creationId xmlns:a16="http://schemas.microsoft.com/office/drawing/2014/main" id="{3AA8BDF6-3D9E-4A9B-AA6D-68317BBA2D92}"/>
+                <a16:creationId xmlns:a16="http://schemas.microsoft.com/office/drawing/2014/main" id="{BE1AB3E1-D608-4B87-8281-9A6451D72015}"/>
               </a:ext>
             </a:extLst>
           </p:cNvPr>
@@ -3096,7 +3096,7 @@
           <p:cNvPr id="12" name="Screenshot border">
             <a:extLst xmlns:a="http://schemas.openxmlformats.org/drawingml/2006/main">
               <a:ext uri="{FF2B5EF4-FFF2-40B4-BE49-F238E27FC236}">
-                <a16:creationId xmlns:a16="http://schemas.microsoft.com/office/drawing/2014/main" id="{920A4CB0-23A2-4092-ACFD-7A84C78F81E9}"/>
+                <a16:creationId xmlns:a16="http://schemas.microsoft.com/office/drawing/2014/main" id="{96806CDD-5694-4F2C-89A7-CE0F80F3D499}"/>
               </a:ext>
             </a:extLst>
           </p:cNvPr>
@@ -3129,7 +3129,7 @@
           <p:cNvPr id="13" name="">
             <a:extLst xmlns:a="http://schemas.openxmlformats.org/drawingml/2006/main">
               <a:ext uri="{FF2B5EF4-FFF2-40B4-BE49-F238E27FC236}">
-                <a16:creationId xmlns:a16="http://schemas.microsoft.com/office/drawing/2014/main" id="{E6A88F25-6FDE-476C-B792-418BBA1DE0A1}"/>
+                <a16:creationId xmlns:a16="http://schemas.microsoft.com/office/drawing/2014/main" id="{E804AB6D-73AC-4725-935F-07134ECA3BE6}"/>
               </a:ext>
             </a:extLst>
           </p:cNvPr>
@@ -3139,7 +3139,7 @@
           <p:nvPr/>
         </p:nvPicPr>
         <p:blipFill>
-          <a:blip xmlns:r="http://schemas.openxmlformats.org/officeDocument/2006/relationships" xmlns:a="http://schemas.openxmlformats.org/drawingml/2006/main" r:embed="R76c17f5eae6b4f92"/>
+          <a:blip xmlns:r="http://schemas.openxmlformats.org/officeDocument/2006/relationships" xmlns:a="http://schemas.openxmlformats.org/drawingml/2006/main" r:embed="Rb9524fdd0b2c4ad9"/>
           <a:stretch xmlns:a="http://schemas.openxmlformats.org/drawingml/2006/main"/>
         </p:blipFill>
         <p:spPr>
@@ -3157,7 +3157,7 @@
           <p:cNvPr id="14" name="Callout A">
             <a:extLst xmlns:a="http://schemas.openxmlformats.org/drawingml/2006/main">
               <a:ext uri="{FF2B5EF4-FFF2-40B4-BE49-F238E27FC236}">
-                <a16:creationId xmlns:a16="http://schemas.microsoft.com/office/drawing/2014/main" id="{734B4427-FEF8-40EA-8304-DAD9FED76C96}"/>
+                <a16:creationId xmlns:a16="http://schemas.microsoft.com/office/drawing/2014/main" id="{F0E481D2-AFEF-4B0F-99EE-629F9E688203}"/>
               </a:ext>
             </a:extLst>
           </p:cNvPr>
@@ -3228,7 +3228,7 @@
           <p:cNvPr id="15" name="Callout B">
             <a:extLst xmlns:a="http://schemas.openxmlformats.org/drawingml/2006/main">
               <a:ext uri="{FF2B5EF4-FFF2-40B4-BE49-F238E27FC236}">
-                <a16:creationId xmlns:a16="http://schemas.microsoft.com/office/drawing/2014/main" id="{71622102-DBF1-4EFF-8F8D-B17C705CEBA3}"/>
+                <a16:creationId xmlns:a16="http://schemas.microsoft.com/office/drawing/2014/main" id="{A45C15FA-2FA0-4E6A-9972-1D4A79541550}"/>
               </a:ext>
             </a:extLst>
           </p:cNvPr>
@@ -3299,7 +3299,7 @@
           <p:cNvPr id="16" name="Callout C">
             <a:extLst xmlns:a="http://schemas.openxmlformats.org/drawingml/2006/main">
               <a:ext uri="{FF2B5EF4-FFF2-40B4-BE49-F238E27FC236}">
-                <a16:creationId xmlns:a16="http://schemas.microsoft.com/office/drawing/2014/main" id="{AB68A5F9-531F-46CC-918E-A6378D3583FD}"/>
+                <a16:creationId xmlns:a16="http://schemas.microsoft.com/office/drawing/2014/main" id="{7B82A37F-B416-45BF-9F14-76C43D0544EE}"/>
               </a:ext>
             </a:extLst>
           </p:cNvPr>
@@ -3370,7 +3370,7 @@
           <p:cNvPr id="17" name="Callout D">
             <a:extLst xmlns:a="http://schemas.openxmlformats.org/drawingml/2006/main">
               <a:ext uri="{FF2B5EF4-FFF2-40B4-BE49-F238E27FC236}">
-                <a16:creationId xmlns:a16="http://schemas.microsoft.com/office/drawing/2014/main" id="{B298E881-565C-4999-972F-5BE50F7DFD70}"/>
+                <a16:creationId xmlns:a16="http://schemas.microsoft.com/office/drawing/2014/main" id="{A713A3B0-B5AE-47FA-B134-8A0A2F30988E}"/>
               </a:ext>
             </a:extLst>
           </p:cNvPr>
@@ -3441,7 +3441,7 @@
           <p:cNvPr id="18" name="Callout E">
             <a:extLst xmlns:a="http://schemas.openxmlformats.org/drawingml/2006/main">
               <a:ext uri="{FF2B5EF4-FFF2-40B4-BE49-F238E27FC236}">
-                <a16:creationId xmlns:a16="http://schemas.microsoft.com/office/drawing/2014/main" id="{1C96862B-A374-4428-96D6-0F822EC6B047}"/>
+                <a16:creationId xmlns:a16="http://schemas.microsoft.com/office/drawing/2014/main" id="{991D1AD5-2FEC-4C53-A099-44081BA7F3F1}"/>
               </a:ext>
             </a:extLst>
           </p:cNvPr>
@@ -3512,7 +3512,7 @@
           <p:cNvPr id="19" name="Callout A">
             <a:extLst xmlns:a="http://schemas.openxmlformats.org/drawingml/2006/main">
               <a:ext uri="{FF2B5EF4-FFF2-40B4-BE49-F238E27FC236}">
-                <a16:creationId xmlns:a16="http://schemas.microsoft.com/office/drawing/2014/main" id="{E41AA911-5BAF-493F-87E0-5329ED1A5AC1}"/>
+                <a16:creationId xmlns:a16="http://schemas.microsoft.com/office/drawing/2014/main" id="{6A75FDA2-49CC-442E-A0BE-68496F3ECC0E}"/>
               </a:ext>
             </a:extLst>
           </p:cNvPr>
@@ -3583,7 +3583,7 @@
           <p:cNvPr id="20" name="Callout A heading">
             <a:extLst xmlns:a="http://schemas.openxmlformats.org/drawingml/2006/main">
               <a:ext uri="{FF2B5EF4-FFF2-40B4-BE49-F238E27FC236}">
-                <a16:creationId xmlns:a16="http://schemas.microsoft.com/office/drawing/2014/main" id="{B6DEE5E6-F69D-45CF-B481-FFC447658484}"/>
+                <a16:creationId xmlns:a16="http://schemas.microsoft.com/office/drawing/2014/main" id="{BA302027-8AD1-4031-88DF-EBE44A18393F}"/>
               </a:ext>
             </a:extLst>
           </p:cNvPr>
@@ -3655,7 +3655,7 @@
           <p:cNvPr id="21" name="Callout A detail">
             <a:extLst xmlns:a="http://schemas.openxmlformats.org/drawingml/2006/main">
               <a:ext uri="{FF2B5EF4-FFF2-40B4-BE49-F238E27FC236}">
-                <a16:creationId xmlns:a16="http://schemas.microsoft.com/office/drawing/2014/main" id="{CE86D559-116E-4753-A642-FB9A8CFB8673}"/>
+                <a16:creationId xmlns:a16="http://schemas.microsoft.com/office/drawing/2014/main" id="{6F3F51E9-B857-4910-B482-A4B26D840917}"/>
               </a:ext>
             </a:extLst>
           </p:cNvPr>
@@ -3754,7 +3754,7 @@
           <p:cNvPr id="22" name="Callout B">
             <a:extLst xmlns:a="http://schemas.openxmlformats.org/drawingml/2006/main">
               <a:ext uri="{FF2B5EF4-FFF2-40B4-BE49-F238E27FC236}">
-                <a16:creationId xmlns:a16="http://schemas.microsoft.com/office/drawing/2014/main" id="{5B85DEA4-34C8-44FC-9233-5EB37BDFEDBD}"/>
+                <a16:creationId xmlns:a16="http://schemas.microsoft.com/office/drawing/2014/main" id="{25C40114-E205-47A4-8116-7D59123EF7C5}"/>
               </a:ext>
             </a:extLst>
           </p:cNvPr>
@@ -3765,7 +3765,7 @@
         </p:nvSpPr>
         <p:spPr>
           <a:xfrm xmlns:a="http://schemas.openxmlformats.org/drawingml/2006/main">
-            <a:off x="12132000" y="7146000"/>
+            <a:off x="12132000" y="7236000"/>
             <a:ext cx="594000" cy="594000"/>
           </a:xfrm>
           <a:prstGeom xmlns:a="http://schemas.openxmlformats.org/drawingml/2006/main" prst="ellipse">
@@ -3825,7 +3825,7 @@
           <p:cNvPr id="23" name="Callout B heading">
             <a:extLst xmlns:a="http://schemas.openxmlformats.org/drawingml/2006/main">
               <a:ext uri="{FF2B5EF4-FFF2-40B4-BE49-F238E27FC236}">
-                <a16:creationId xmlns:a16="http://schemas.microsoft.com/office/drawing/2014/main" id="{598F0A4F-9A4E-4F7D-8A11-778C82574828}"/>
+                <a16:creationId xmlns:a16="http://schemas.microsoft.com/office/drawing/2014/main" id="{3A30294E-DCA7-46F3-AF09-5FA4E6B86447}"/>
               </a:ext>
             </a:extLst>
           </p:cNvPr>
@@ -3836,7 +3836,7 @@
         </p:nvSpPr>
         <p:spPr>
           <a:xfrm xmlns:a="http://schemas.openxmlformats.org/drawingml/2006/main">
-            <a:off x="12960000" y="7110000"/>
+            <a:off x="12960000" y="7200000"/>
             <a:ext cx="7987320" cy="450000"/>
           </a:xfrm>
           <a:prstGeom xmlns:a="http://schemas.openxmlformats.org/drawingml/2006/main" prst="rect">
@@ -3897,7 +3897,7 @@
           <p:cNvPr id="24" name="Callout B detail">
             <a:extLst xmlns:a="http://schemas.openxmlformats.org/drawingml/2006/main">
               <a:ext uri="{FF2B5EF4-FFF2-40B4-BE49-F238E27FC236}">
-                <a16:creationId xmlns:a16="http://schemas.microsoft.com/office/drawing/2014/main" id="{05C64ABB-EAAB-4F47-9222-204BFE13F4CB}"/>
+                <a16:creationId xmlns:a16="http://schemas.microsoft.com/office/drawing/2014/main" id="{860ED18F-F8C1-4508-ACA9-B78BA24EEF46}"/>
               </a:ext>
             </a:extLst>
           </p:cNvPr>
@@ -3908,7 +3908,7 @@
         </p:nvSpPr>
         <p:spPr>
           <a:xfrm xmlns:a="http://schemas.openxmlformats.org/drawingml/2006/main">
-            <a:off x="12960000" y="7596000"/>
+            <a:off x="12960000" y="7686000"/>
             <a:ext cx="7987320" cy="720000"/>
           </a:xfrm>
           <a:prstGeom xmlns:a="http://schemas.openxmlformats.org/drawingml/2006/main" prst="rect">
@@ -3996,7 +3996,7 @@
           <p:cNvPr id="25" name="Callout C">
             <a:extLst xmlns:a="http://schemas.openxmlformats.org/drawingml/2006/main">
               <a:ext uri="{FF2B5EF4-FFF2-40B4-BE49-F238E27FC236}">
-                <a16:creationId xmlns:a16="http://schemas.microsoft.com/office/drawing/2014/main" id="{AFBE4E2F-79D8-4FDF-9105-8F4CB8887BE7}"/>
+                <a16:creationId xmlns:a16="http://schemas.microsoft.com/office/drawing/2014/main" id="{1BDEB3B8-C17A-4C6E-AC7A-1290AA45A74D}"/>
               </a:ext>
             </a:extLst>
           </p:cNvPr>
@@ -4007,7 +4007,7 @@
         </p:nvSpPr>
         <p:spPr>
           <a:xfrm xmlns:a="http://schemas.openxmlformats.org/drawingml/2006/main">
-            <a:off x="12132000" y="8388000"/>
+            <a:off x="12132000" y="8568000"/>
             <a:ext cx="594000" cy="594000"/>
           </a:xfrm>
           <a:prstGeom xmlns:a="http://schemas.openxmlformats.org/drawingml/2006/main" prst="ellipse">
@@ -4067,7 +4067,7 @@
           <p:cNvPr id="26" name="Callout C heading">
             <a:extLst xmlns:a="http://schemas.openxmlformats.org/drawingml/2006/main">
               <a:ext uri="{FF2B5EF4-FFF2-40B4-BE49-F238E27FC236}">
-                <a16:creationId xmlns:a16="http://schemas.microsoft.com/office/drawing/2014/main" id="{09E073F4-D839-4340-BA13-37D3F8E7D813}"/>
+                <a16:creationId xmlns:a16="http://schemas.microsoft.com/office/drawing/2014/main" id="{2CD83C8F-9FE0-4D34-8CA8-C6CF656DDDD9}"/>
               </a:ext>
             </a:extLst>
           </p:cNvPr>
@@ -4078,7 +4078,7 @@
         </p:nvSpPr>
         <p:spPr>
           <a:xfrm xmlns:a="http://schemas.openxmlformats.org/drawingml/2006/main">
-            <a:off x="12960000" y="8352000"/>
+            <a:off x="12960000" y="8532000"/>
             <a:ext cx="7987320" cy="450000"/>
           </a:xfrm>
           <a:prstGeom xmlns:a="http://schemas.openxmlformats.org/drawingml/2006/main" prst="rect">
@@ -4139,7 +4139,7 @@
           <p:cNvPr id="27" name="Callout C detail">
             <a:extLst xmlns:a="http://schemas.openxmlformats.org/drawingml/2006/main">
               <a:ext uri="{FF2B5EF4-FFF2-40B4-BE49-F238E27FC236}">
-                <a16:creationId xmlns:a16="http://schemas.microsoft.com/office/drawing/2014/main" id="{0ECA3838-6405-443E-9307-C37C7D9925BE}"/>
+                <a16:creationId xmlns:a16="http://schemas.microsoft.com/office/drawing/2014/main" id="{F904B140-66A1-4737-B99B-A9B84929316C}"/>
               </a:ext>
             </a:extLst>
           </p:cNvPr>
@@ -4150,7 +4150,7 @@
         </p:nvSpPr>
         <p:spPr>
           <a:xfrm xmlns:a="http://schemas.openxmlformats.org/drawingml/2006/main">
-            <a:off x="12960000" y="8838000"/>
+            <a:off x="12960000" y="9018000"/>
             <a:ext cx="7987320" cy="720000"/>
           </a:xfrm>
           <a:prstGeom xmlns:a="http://schemas.openxmlformats.org/drawingml/2006/main" prst="rect">
@@ -4238,7 +4238,7 @@
           <p:cNvPr id="28" name="Callout D">
             <a:extLst xmlns:a="http://schemas.openxmlformats.org/drawingml/2006/main">
               <a:ext uri="{FF2B5EF4-FFF2-40B4-BE49-F238E27FC236}">
-                <a16:creationId xmlns:a16="http://schemas.microsoft.com/office/drawing/2014/main" id="{BA41694C-BA1E-4159-B41A-1524D1EA0AE2}"/>
+                <a16:creationId xmlns:a16="http://schemas.microsoft.com/office/drawing/2014/main" id="{71C336D0-3D1A-44B3-80BE-E1C3A07314CC}"/>
               </a:ext>
             </a:extLst>
           </p:cNvPr>
@@ -4249,7 +4249,7 @@
         </p:nvSpPr>
         <p:spPr>
           <a:xfrm xmlns:a="http://schemas.openxmlformats.org/drawingml/2006/main">
-            <a:off x="12132000" y="9630000"/>
+            <a:off x="12132000" y="9900000"/>
             <a:ext cx="594000" cy="594000"/>
           </a:xfrm>
           <a:prstGeom xmlns:a="http://schemas.openxmlformats.org/drawingml/2006/main" prst="ellipse">
@@ -4309,7 +4309,7 @@
           <p:cNvPr id="29" name="Callout D heading">
             <a:extLst xmlns:a="http://schemas.openxmlformats.org/drawingml/2006/main">
               <a:ext uri="{FF2B5EF4-FFF2-40B4-BE49-F238E27FC236}">
-                <a16:creationId xmlns:a16="http://schemas.microsoft.com/office/drawing/2014/main" id="{8EE34CED-AB73-4C23-B9F9-DB55D9EAACD1}"/>
+                <a16:creationId xmlns:a16="http://schemas.microsoft.com/office/drawing/2014/main" id="{3F073359-BD1E-4B28-936D-F9E47F82248C}"/>
               </a:ext>
             </a:extLst>
           </p:cNvPr>
@@ -4320,7 +4320,7 @@
         </p:nvSpPr>
         <p:spPr>
           <a:xfrm xmlns:a="http://schemas.openxmlformats.org/drawingml/2006/main">
-            <a:off x="12960000" y="9594000"/>
+            <a:off x="12960000" y="9864000"/>
             <a:ext cx="7987320" cy="450000"/>
           </a:xfrm>
           <a:prstGeom xmlns:a="http://schemas.openxmlformats.org/drawingml/2006/main" prst="rect">
@@ -4381,7 +4381,7 @@
           <p:cNvPr id="30" name="Callout D detail">
             <a:extLst xmlns:a="http://schemas.openxmlformats.org/drawingml/2006/main">
               <a:ext uri="{FF2B5EF4-FFF2-40B4-BE49-F238E27FC236}">
-                <a16:creationId xmlns:a16="http://schemas.microsoft.com/office/drawing/2014/main" id="{B0D101B4-02C3-493D-959C-4F67B9C2FF06}"/>
+                <a16:creationId xmlns:a16="http://schemas.microsoft.com/office/drawing/2014/main" id="{C847ADBA-C966-403C-9855-E092DDD7899D}"/>
               </a:ext>
             </a:extLst>
           </p:cNvPr>
@@ -4392,7 +4392,7 @@
         </p:nvSpPr>
         <p:spPr>
           <a:xfrm xmlns:a="http://schemas.openxmlformats.org/drawingml/2006/main">
-            <a:off x="12960000" y="10080000"/>
+            <a:off x="12960000" y="10350000"/>
             <a:ext cx="7987320" cy="720000"/>
           </a:xfrm>
           <a:prstGeom xmlns:a="http://schemas.openxmlformats.org/drawingml/2006/main" prst="rect">
@@ -4480,7 +4480,7 @@
           <p:cNvPr id="31" name="Callout E">
             <a:extLst xmlns:a="http://schemas.openxmlformats.org/drawingml/2006/main">
               <a:ext uri="{FF2B5EF4-FFF2-40B4-BE49-F238E27FC236}">
-                <a16:creationId xmlns:a16="http://schemas.microsoft.com/office/drawing/2014/main" id="{6A242A89-9B39-4F87-BC3E-AA66FFDD657B}"/>
+                <a16:creationId xmlns:a16="http://schemas.microsoft.com/office/drawing/2014/main" id="{71646275-FD10-4E9C-ADBF-7EF6037099E4}"/>
               </a:ext>
             </a:extLst>
           </p:cNvPr>
@@ -4491,7 +4491,7 @@
         </p:nvSpPr>
         <p:spPr>
           <a:xfrm xmlns:a="http://schemas.openxmlformats.org/drawingml/2006/main">
-            <a:off x="12132000" y="10872000"/>
+            <a:off x="12132000" y="11232000"/>
             <a:ext cx="594000" cy="594000"/>
           </a:xfrm>
           <a:prstGeom xmlns:a="http://schemas.openxmlformats.org/drawingml/2006/main" prst="ellipse">
@@ -4551,7 +4551,7 @@
           <p:cNvPr id="32" name="Callout E heading">
             <a:extLst xmlns:a="http://schemas.openxmlformats.org/drawingml/2006/main">
               <a:ext uri="{FF2B5EF4-FFF2-40B4-BE49-F238E27FC236}">
-                <a16:creationId xmlns:a16="http://schemas.microsoft.com/office/drawing/2014/main" id="{659B504C-65C1-4798-8163-F0878C1D55CE}"/>
+                <a16:creationId xmlns:a16="http://schemas.microsoft.com/office/drawing/2014/main" id="{C1D5D19D-575C-4829-8112-36086F736D34}"/>
               </a:ext>
             </a:extLst>
           </p:cNvPr>
@@ -4562,7 +4562,7 @@
         </p:nvSpPr>
         <p:spPr>
           <a:xfrm xmlns:a="http://schemas.openxmlformats.org/drawingml/2006/main">
-            <a:off x="12960000" y="10836000"/>
+            <a:off x="12960000" y="11196000"/>
             <a:ext cx="7987320" cy="450000"/>
           </a:xfrm>
           <a:prstGeom xmlns:a="http://schemas.openxmlformats.org/drawingml/2006/main" prst="rect">
@@ -4623,7 +4623,7 @@
           <p:cNvPr id="33" name="Callout E detail">
             <a:extLst xmlns:a="http://schemas.openxmlformats.org/drawingml/2006/main">
               <a:ext uri="{FF2B5EF4-FFF2-40B4-BE49-F238E27FC236}">
-                <a16:creationId xmlns:a16="http://schemas.microsoft.com/office/drawing/2014/main" id="{8A486325-07EB-4B3A-812A-117483DFF94E}"/>
+                <a16:creationId xmlns:a16="http://schemas.microsoft.com/office/drawing/2014/main" id="{D94287BA-0C3C-4AB1-99B3-A569392F366C}"/>
               </a:ext>
             </a:extLst>
           </p:cNvPr>
@@ -4634,7 +4634,7 @@
         </p:nvSpPr>
         <p:spPr>
           <a:xfrm xmlns:a="http://schemas.openxmlformats.org/drawingml/2006/main">
-            <a:off x="12960000" y="11322000"/>
+            <a:off x="12960000" y="11682000"/>
             <a:ext cx="7987320" cy="720000"/>
           </a:xfrm>
           <a:prstGeom xmlns:a="http://schemas.openxmlformats.org/drawingml/2006/main" prst="rect">
@@ -4722,7 +4722,7 @@
           <p:cNvPr id="34" name="Frontend caption">
             <a:extLst xmlns:a="http://schemas.openxmlformats.org/drawingml/2006/main">
               <a:ext uri="{FF2B5EF4-FFF2-40B4-BE49-F238E27FC236}">
-                <a16:creationId xmlns:a16="http://schemas.microsoft.com/office/drawing/2014/main" id="{346EA772-E7BC-41B6-960A-351FFAEA03FB}"/>
+                <a16:creationId xmlns:a16="http://schemas.microsoft.com/office/drawing/2014/main" id="{CBB46CCA-4CCE-4540-BFF4-D3B8F8F673BD}"/>
               </a:ext>
             </a:extLst>
           </p:cNvPr>
@@ -4821,7 +4821,7 @@
           <p:cNvPr id="35" name="Section 2 number">
             <a:extLst xmlns:a="http://schemas.openxmlformats.org/drawingml/2006/main">
               <a:ext uri="{FF2B5EF4-FFF2-40B4-BE49-F238E27FC236}">
-                <a16:creationId xmlns:a16="http://schemas.microsoft.com/office/drawing/2014/main" id="{375BE0B7-65C0-4FED-85CE-402C395ED56A}"/>
+                <a16:creationId xmlns:a16="http://schemas.microsoft.com/office/drawing/2014/main" id="{07F3298A-5B49-410D-B687-862B646BED02}"/>
               </a:ext>
             </a:extLst>
           </p:cNvPr>
@@ -4890,7 +4890,7 @@
           <p:cNvPr id="36" name="Section 2 title">
             <a:extLst xmlns:a="http://schemas.openxmlformats.org/drawingml/2006/main">
               <a:ext uri="{FF2B5EF4-FFF2-40B4-BE49-F238E27FC236}">
-                <a16:creationId xmlns:a16="http://schemas.microsoft.com/office/drawing/2014/main" id="{4C173FFC-30B5-4DA6-8DD5-A44A524C5CA9}"/>
+                <a16:creationId xmlns:a16="http://schemas.microsoft.com/office/drawing/2014/main" id="{4C51A352-8E54-45BC-99CC-D137999EE12A}"/>
               </a:ext>
             </a:extLst>
           </p:cNvPr>
@@ -4962,7 +4962,7 @@
           <p:cNvPr id="37" name="Hansard corpus">
             <a:extLst xmlns:a="http://schemas.openxmlformats.org/drawingml/2006/main">
               <a:ext uri="{FF2B5EF4-FFF2-40B4-BE49-F238E27FC236}">
-                <a16:creationId xmlns:a16="http://schemas.microsoft.com/office/drawing/2014/main" id="{AC7AC689-63CC-4D51-9D99-03CF6AB1A85F}"/>
+                <a16:creationId xmlns:a16="http://schemas.microsoft.com/office/drawing/2014/main" id="{2F963DBD-8947-4F09-845F-DED4755CCC14}"/>
               </a:ext>
             </a:extLst>
           </p:cNvPr>
@@ -4974,7 +4974,7 @@
         <p:spPr>
           <a:xfrm xmlns:a="http://schemas.openxmlformats.org/drawingml/2006/main">
             <a:off x="868680" y="13752000"/>
-            <a:ext cx="3590640" cy="3024000"/>
+            <a:ext cx="3590640" cy="3168000"/>
           </a:xfrm>
           <a:prstGeom xmlns:a="http://schemas.openxmlformats.org/drawingml/2006/main" prst="rect">
             <a:avLst/>
@@ -4995,7 +4995,7 @@
           <p:cNvPr id="38" name="Hansard corpus title">
             <a:extLst xmlns:a="http://schemas.openxmlformats.org/drawingml/2006/main">
               <a:ext uri="{FF2B5EF4-FFF2-40B4-BE49-F238E27FC236}">
-                <a16:creationId xmlns:a16="http://schemas.microsoft.com/office/drawing/2014/main" id="{E8874D51-6E5E-4540-8324-1B63961400A3}"/>
+                <a16:creationId xmlns:a16="http://schemas.microsoft.com/office/drawing/2014/main" id="{8CD550B4-A44B-48D5-BC0D-D141CCC22CEA}"/>
               </a:ext>
             </a:extLst>
           </p:cNvPr>
@@ -5067,7 +5067,7 @@
           <p:cNvPr id="39" name="Hansard corpus description">
             <a:extLst xmlns:a="http://schemas.openxmlformats.org/drawingml/2006/main">
               <a:ext uri="{FF2B5EF4-FFF2-40B4-BE49-F238E27FC236}">
-                <a16:creationId xmlns:a16="http://schemas.microsoft.com/office/drawing/2014/main" id="{3465A081-B7C2-4E51-85C3-71033D806057}"/>
+                <a16:creationId xmlns:a16="http://schemas.microsoft.com/office/drawing/2014/main" id="{91527E0A-9366-4A58-A529-4F4DEDE9935A}"/>
               </a:ext>
             </a:extLst>
           </p:cNvPr>
@@ -5079,7 +5079,7 @@
         <p:spPr>
           <a:xfrm xmlns:a="http://schemas.openxmlformats.org/drawingml/2006/main">
             <a:off x="1012680" y="14472000"/>
-            <a:ext cx="3302640" cy="2196000"/>
+            <a:ext cx="3302640" cy="2340000"/>
           </a:xfrm>
           <a:prstGeom xmlns:a="http://schemas.openxmlformats.org/drawingml/2006/main" prst="rect">
             <a:avLst/>
@@ -5139,7 +5139,7 @@
           <p:cNvPr id="40" name="Agent setup">
             <a:extLst xmlns:a="http://schemas.openxmlformats.org/drawingml/2006/main">
               <a:ext uri="{FF2B5EF4-FFF2-40B4-BE49-F238E27FC236}">
-                <a16:creationId xmlns:a16="http://schemas.microsoft.com/office/drawing/2014/main" id="{50D6A0E3-BA77-49CD-8DC2-A868081D8D88}"/>
+                <a16:creationId xmlns:a16="http://schemas.microsoft.com/office/drawing/2014/main" id="{AAF61A3D-D58E-4F1C-983D-15B9AB1D9C00}"/>
               </a:ext>
             </a:extLst>
           </p:cNvPr>
@@ -5151,7 +5151,7 @@
         <p:spPr>
           <a:xfrm xmlns:a="http://schemas.openxmlformats.org/drawingml/2006/main">
             <a:off x="4990680" y="13752000"/>
-            <a:ext cx="3590640" cy="3024000"/>
+            <a:ext cx="3590640" cy="3168000"/>
           </a:xfrm>
           <a:prstGeom xmlns:a="http://schemas.openxmlformats.org/drawingml/2006/main" prst="rect">
             <a:avLst/>
@@ -5172,7 +5172,7 @@
           <p:cNvPr id="41" name="Agent setup title">
             <a:extLst xmlns:a="http://schemas.openxmlformats.org/drawingml/2006/main">
               <a:ext uri="{FF2B5EF4-FFF2-40B4-BE49-F238E27FC236}">
-                <a16:creationId xmlns:a16="http://schemas.microsoft.com/office/drawing/2014/main" id="{429C9FEE-E2CA-4497-9EBC-1865D3011153}"/>
+                <a16:creationId xmlns:a16="http://schemas.microsoft.com/office/drawing/2014/main" id="{B839E11F-724D-41E7-8312-BE4DC4994B5F}"/>
               </a:ext>
             </a:extLst>
           </p:cNvPr>
@@ -5244,7 +5244,7 @@
           <p:cNvPr id="42" name="Agent setup description">
             <a:extLst xmlns:a="http://schemas.openxmlformats.org/drawingml/2006/main">
               <a:ext uri="{FF2B5EF4-FFF2-40B4-BE49-F238E27FC236}">
-                <a16:creationId xmlns:a16="http://schemas.microsoft.com/office/drawing/2014/main" id="{AFEFF5B0-01A8-461B-95A6-16771F404FBB}"/>
+                <a16:creationId xmlns:a16="http://schemas.microsoft.com/office/drawing/2014/main" id="{9740C35F-2AA1-4A3A-8A5F-0607DDE12973}"/>
               </a:ext>
             </a:extLst>
           </p:cNvPr>
@@ -5256,7 +5256,7 @@
         <p:spPr>
           <a:xfrm xmlns:a="http://schemas.openxmlformats.org/drawingml/2006/main">
             <a:off x="5134680" y="14472000"/>
-            <a:ext cx="3302640" cy="2196000"/>
+            <a:ext cx="3302640" cy="2340000"/>
           </a:xfrm>
           <a:prstGeom xmlns:a="http://schemas.openxmlformats.org/drawingml/2006/main" prst="rect">
             <a:avLst/>
@@ -5316,7 +5316,7 @@
           <p:cNvPr id="43" name="MP agents">
             <a:extLst xmlns:a="http://schemas.openxmlformats.org/drawingml/2006/main">
               <a:ext uri="{FF2B5EF4-FFF2-40B4-BE49-F238E27FC236}">
-                <a16:creationId xmlns:a16="http://schemas.microsoft.com/office/drawing/2014/main" id="{762ABC6E-CD42-41E7-BC72-280FACEB4BEC}"/>
+                <a16:creationId xmlns:a16="http://schemas.microsoft.com/office/drawing/2014/main" id="{6FF07794-9D9B-4AEC-B1F5-F627FF31C698}"/>
               </a:ext>
             </a:extLst>
           </p:cNvPr>
@@ -5328,7 +5328,7 @@
         <p:spPr>
           <a:xfrm xmlns:a="http://schemas.openxmlformats.org/drawingml/2006/main">
             <a:off x="9112680" y="13752000"/>
-            <a:ext cx="3590640" cy="3024000"/>
+            <a:ext cx="3590640" cy="3168000"/>
           </a:xfrm>
           <a:prstGeom xmlns:a="http://schemas.openxmlformats.org/drawingml/2006/main" prst="rect">
             <a:avLst/>
@@ -5349,7 +5349,7 @@
           <p:cNvPr id="44" name="MP agents title">
             <a:extLst xmlns:a="http://schemas.openxmlformats.org/drawingml/2006/main">
               <a:ext uri="{FF2B5EF4-FFF2-40B4-BE49-F238E27FC236}">
-                <a16:creationId xmlns:a16="http://schemas.microsoft.com/office/drawing/2014/main" id="{5C680DE3-2BBE-4262-9992-4946432967FF}"/>
+                <a16:creationId xmlns:a16="http://schemas.microsoft.com/office/drawing/2014/main" id="{FCCC5CE9-0511-40BD-BCBC-0273883C9901}"/>
               </a:ext>
             </a:extLst>
           </p:cNvPr>
@@ -5421,7 +5421,7 @@
           <p:cNvPr id="45" name="MP agents description">
             <a:extLst xmlns:a="http://schemas.openxmlformats.org/drawingml/2006/main">
               <a:ext uri="{FF2B5EF4-FFF2-40B4-BE49-F238E27FC236}">
-                <a16:creationId xmlns:a16="http://schemas.microsoft.com/office/drawing/2014/main" id="{296AEF2E-2D75-4811-BD00-2FEB63189316}"/>
+                <a16:creationId xmlns:a16="http://schemas.microsoft.com/office/drawing/2014/main" id="{44193BB6-378D-4217-9679-A904AABD83DB}"/>
               </a:ext>
             </a:extLst>
           </p:cNvPr>
@@ -5433,7 +5433,7 @@
         <p:spPr>
           <a:xfrm xmlns:a="http://schemas.openxmlformats.org/drawingml/2006/main">
             <a:off x="9256680" y="14472000"/>
-            <a:ext cx="3302640" cy="2196000"/>
+            <a:ext cx="3302640" cy="2340000"/>
           </a:xfrm>
           <a:prstGeom xmlns:a="http://schemas.openxmlformats.org/drawingml/2006/main" prst="rect">
             <a:avLst/>
@@ -5515,7 +5515,7 @@
           <p:cNvPr id="46" name="Debate scheduler">
             <a:extLst xmlns:a="http://schemas.openxmlformats.org/drawingml/2006/main">
               <a:ext uri="{FF2B5EF4-FFF2-40B4-BE49-F238E27FC236}">
-                <a16:creationId xmlns:a16="http://schemas.microsoft.com/office/drawing/2014/main" id="{53EF2531-F3A6-42E8-B761-173B69768DA6}"/>
+                <a16:creationId xmlns:a16="http://schemas.microsoft.com/office/drawing/2014/main" id="{C6531205-1431-4001-8B4A-48FE4A563DA1}"/>
               </a:ext>
             </a:extLst>
           </p:cNvPr>
@@ -5527,7 +5527,7 @@
         <p:spPr>
           <a:xfrm xmlns:a="http://schemas.openxmlformats.org/drawingml/2006/main">
             <a:off x="13234680" y="13752000"/>
-            <a:ext cx="3590640" cy="3024000"/>
+            <a:ext cx="3590640" cy="3168000"/>
           </a:xfrm>
           <a:prstGeom xmlns:a="http://schemas.openxmlformats.org/drawingml/2006/main" prst="rect">
             <a:avLst/>
@@ -5548,7 +5548,7 @@
           <p:cNvPr id="47" name="Debate scheduler title">
             <a:extLst xmlns:a="http://schemas.openxmlformats.org/drawingml/2006/main">
               <a:ext uri="{FF2B5EF4-FFF2-40B4-BE49-F238E27FC236}">
-                <a16:creationId xmlns:a16="http://schemas.microsoft.com/office/drawing/2014/main" id="{3AF4E9C2-EA1B-4C5F-8D43-79FF9D635A78}"/>
+                <a16:creationId xmlns:a16="http://schemas.microsoft.com/office/drawing/2014/main" id="{FF56D1D7-01AD-409A-9CB7-4B35A3884F71}"/>
               </a:ext>
             </a:extLst>
           </p:cNvPr>
@@ -5620,7 +5620,7 @@
           <p:cNvPr id="48" name="Debate scheduler description">
             <a:extLst xmlns:a="http://schemas.openxmlformats.org/drawingml/2006/main">
               <a:ext uri="{FF2B5EF4-FFF2-40B4-BE49-F238E27FC236}">
-                <a16:creationId xmlns:a16="http://schemas.microsoft.com/office/drawing/2014/main" id="{18A0393C-4175-45B9-955F-913783AA93B7}"/>
+                <a16:creationId xmlns:a16="http://schemas.microsoft.com/office/drawing/2014/main" id="{C9AB93AD-7817-4829-9FB9-CF42307EBE09}"/>
               </a:ext>
             </a:extLst>
           </p:cNvPr>
@@ -5632,7 +5632,7 @@
         <p:spPr>
           <a:xfrm xmlns:a="http://schemas.openxmlformats.org/drawingml/2006/main">
             <a:off x="13378680" y="14472000"/>
-            <a:ext cx="3302640" cy="2196000"/>
+            <a:ext cx="3302640" cy="2340000"/>
           </a:xfrm>
           <a:prstGeom xmlns:a="http://schemas.openxmlformats.org/drawingml/2006/main" prst="rect">
             <a:avLst/>
@@ -5692,7 +5692,7 @@
           <p:cNvPr id="49" name="Public results">
             <a:extLst xmlns:a="http://schemas.openxmlformats.org/drawingml/2006/main">
               <a:ext uri="{FF2B5EF4-FFF2-40B4-BE49-F238E27FC236}">
-                <a16:creationId xmlns:a16="http://schemas.microsoft.com/office/drawing/2014/main" id="{4433A6C7-6EEB-4FBD-9AFF-2B011198A3C7}"/>
+                <a16:creationId xmlns:a16="http://schemas.microsoft.com/office/drawing/2014/main" id="{65AC0B4F-9C79-430B-BAAB-9BB4B49583C5}"/>
               </a:ext>
             </a:extLst>
           </p:cNvPr>
@@ -5704,7 +5704,7 @@
         <p:spPr>
           <a:xfrm xmlns:a="http://schemas.openxmlformats.org/drawingml/2006/main">
             <a:off x="17356680" y="13752000"/>
-            <a:ext cx="3590640" cy="3024000"/>
+            <a:ext cx="3590640" cy="3168000"/>
           </a:xfrm>
           <a:prstGeom xmlns:a="http://schemas.openxmlformats.org/drawingml/2006/main" prst="rect">
             <a:avLst/>
@@ -5725,7 +5725,7 @@
           <p:cNvPr id="50" name="Public results title">
             <a:extLst xmlns:a="http://schemas.openxmlformats.org/drawingml/2006/main">
               <a:ext uri="{FF2B5EF4-FFF2-40B4-BE49-F238E27FC236}">
-                <a16:creationId xmlns:a16="http://schemas.microsoft.com/office/drawing/2014/main" id="{16E78802-4325-439D-8884-E08B02F4CEEC}"/>
+                <a16:creationId xmlns:a16="http://schemas.microsoft.com/office/drawing/2014/main" id="{B48B3F1D-3DF3-476E-853E-4A804F4CD633}"/>
               </a:ext>
             </a:extLst>
           </p:cNvPr>
@@ -5797,7 +5797,7 @@
           <p:cNvPr id="51" name="Public results description">
             <a:extLst xmlns:a="http://schemas.openxmlformats.org/drawingml/2006/main">
               <a:ext uri="{FF2B5EF4-FFF2-40B4-BE49-F238E27FC236}">
-                <a16:creationId xmlns:a16="http://schemas.microsoft.com/office/drawing/2014/main" id="{252251A5-F225-4E3B-A48A-21842E3DCBD0}"/>
+                <a16:creationId xmlns:a16="http://schemas.microsoft.com/office/drawing/2014/main" id="{5D4EACC6-6EE0-40A4-8CB8-CC9B2153F6A1}"/>
               </a:ext>
             </a:extLst>
           </p:cNvPr>
@@ -5809,7 +5809,7 @@
         <p:spPr>
           <a:xfrm xmlns:a="http://schemas.openxmlformats.org/drawingml/2006/main">
             <a:off x="17500680" y="14472000"/>
-            <a:ext cx="3302640" cy="2196000"/>
+            <a:ext cx="3302640" cy="2340000"/>
           </a:xfrm>
           <a:prstGeom xmlns:a="http://schemas.openxmlformats.org/drawingml/2006/main" prst="rect">
             <a:avLst/>
@@ -5866,10 +5866,10 @@
       </p:sp>
       <p:sp>
         <p:nvSpPr>
-          <p:cNvPr id="56" name="Adversarial strategies heading">
+          <p:cNvPr id="56" name="Topic derailment heading">
             <a:extLst xmlns:a="http://schemas.openxmlformats.org/drawingml/2006/main">
               <a:ext uri="{FF2B5EF4-FFF2-40B4-BE49-F238E27FC236}">
-                <a16:creationId xmlns:a16="http://schemas.microsoft.com/office/drawing/2014/main" id="{C11A4920-1090-44D2-89EB-A71925B08EE7}"/>
+                <a16:creationId xmlns:a16="http://schemas.microsoft.com/office/drawing/2014/main" id="{1C5C49E1-0754-4939-9EB0-F15EC1C3BD63}"/>
               </a:ext>
             </a:extLst>
           </p:cNvPr>
@@ -5880,8 +5880,8 @@
         </p:nvSpPr>
         <p:spPr>
           <a:xfrm xmlns:a="http://schemas.openxmlformats.org/drawingml/2006/main">
-            <a:off x="868680" y="16812000"/>
-            <a:ext cx="20078640" cy="504000"/>
+            <a:off x="868680" y="17136000"/>
+            <a:ext cx="6398640" cy="432000"/>
           </a:xfrm>
           <a:prstGeom xmlns:a="http://schemas.openxmlformats.org/drawingml/2006/main" prst="rect">
             <a:avLst/>
@@ -5897,7 +5897,7 @@
           </a:bodyPr>
           <a:lstStyle xmlns:a="http://schemas.openxmlformats.org/drawingml/2006/main">
             <a:defPPr algn="l">
-              <a:defRPr sz="3200" b="1" i="0">
+              <a:defRPr sz="2700" b="1" i="0">
                 <a:solidFill>
                   <a:srgbClr val="A92F24"/>
                 </a:solidFill>
@@ -5913,7 +5913,7 @@
                 <a:spcPct val="108000"/>
               </a:lnSpc>
               <a:buNone/>
-              <a:defRPr sz="3200" b="1" i="0">
+              <a:defRPr sz="2700" b="1" i="0">
                 <a:solidFill>
                   <a:srgbClr val="A92F24"/>
                 </a:solidFill>
@@ -5923,7 +5923,7 @@
               </a:defRPr>
             </a:pPr>
             <a:r>
-              <a:rPr sz="3200" b="1" i="0">
+              <a:rPr sz="2700" b="1" i="0">
                 <a:solidFill>
                   <a:srgbClr val="A92F24"/>
                 </a:solidFill>
@@ -5931,17 +5931,17 @@
                 <a:ea typeface="Cambria"/>
                 <a:cs typeface="Cambria"/>
               </a:rPr>
-              <a:t>Hidden adversarial strategies</a:t>
+              <a:t>Topic derailment</a:t>
             </a:r>
           </a:p>
         </p:txBody>
       </p:sp>
       <p:sp>
         <p:nvSpPr>
-          <p:cNvPr id="57" name="Topic derailment heading">
+          <p:cNvPr id="57" name="Topic derailment definition">
             <a:extLst xmlns:a="http://schemas.openxmlformats.org/drawingml/2006/main">
               <a:ext uri="{FF2B5EF4-FFF2-40B4-BE49-F238E27FC236}">
-                <a16:creationId xmlns:a16="http://schemas.microsoft.com/office/drawing/2014/main" id="{61684DE1-00AE-4F0B-93BA-3166381F7AEA}"/>
+                <a16:creationId xmlns:a16="http://schemas.microsoft.com/office/drawing/2014/main" id="{CCA4A6DA-08EE-4EC1-8CB4-8DB4723745F3}"/>
               </a:ext>
             </a:extLst>
           </p:cNvPr>
@@ -5952,8 +5952,8 @@
         </p:nvSpPr>
         <p:spPr>
           <a:xfrm xmlns:a="http://schemas.openxmlformats.org/drawingml/2006/main">
-            <a:off x="868680" y="17568000"/>
-            <a:ext cx="6398640" cy="432000"/>
+            <a:off x="868680" y="17712000"/>
+            <a:ext cx="6398640" cy="720000"/>
           </a:xfrm>
           <a:prstGeom xmlns:a="http://schemas.openxmlformats.org/drawingml/2006/main" prst="rect">
             <a:avLst/>
@@ -5969,13 +5969,13 @@
           </a:bodyPr>
           <a:lstStyle xmlns:a="http://schemas.openxmlformats.org/drawingml/2006/main">
             <a:defPPr algn="l">
-              <a:defRPr sz="2700" b="1" i="0">
-                <a:solidFill>
-                  <a:srgbClr val="A92F24"/>
-                </a:solidFill>
-                <a:latin typeface="Cambria"/>
-                <a:ea typeface="Cambria"/>
-                <a:cs typeface="Cambria"/>
+              <a:defRPr sz="2350" b="0" i="0">
+                <a:solidFill>
+                  <a:srgbClr val="1F2A24"/>
+                </a:solidFill>
+                <a:latin typeface="Calibri"/>
+                <a:ea typeface="Calibri"/>
+                <a:cs typeface="Calibri"/>
               </a:defRPr>
             </a:defPPr>
           </a:lstStyle>
@@ -5985,35 +5985,62 @@
                 <a:spcPct val="108000"/>
               </a:lnSpc>
               <a:buNone/>
-              <a:defRPr sz="2700" b="1" i="0">
-                <a:solidFill>
-                  <a:srgbClr val="A92F24"/>
-                </a:solidFill>
-                <a:latin typeface="Cambria"/>
-                <a:ea typeface="Cambria"/>
-                <a:cs typeface="Cambria"/>
-              </a:defRPr>
-            </a:pPr>
-            <a:r>
-              <a:rPr sz="2700" b="1" i="0">
-                <a:solidFill>
-                  <a:srgbClr val="A92F24"/>
-                </a:solidFill>
-                <a:latin typeface="Cambria"/>
-                <a:ea typeface="Cambria"/>
-                <a:cs typeface="Cambria"/>
-              </a:rPr>
-              <a:t>Topic derailment</a:t>
+              <a:defRPr sz="2350" b="0" i="0">
+                <a:solidFill>
+                  <a:srgbClr val="1F2A24"/>
+                </a:solidFill>
+                <a:latin typeface="Calibri"/>
+                <a:ea typeface="Calibri"/>
+                <a:cs typeface="Calibri"/>
+              </a:defRPr>
+            </a:pPr>
+            <a:r>
+              <a:rPr sz="2350" b="0" i="0">
+                <a:solidFill>
+                  <a:srgbClr val="1F2A24"/>
+                </a:solidFill>
+                <a:latin typeface="Calibri"/>
+                <a:ea typeface="Calibri"/>
+                <a:cs typeface="Calibri"/>
+              </a:rPr>
+              <a:t>Steer discussion away from the</a:t>
+            </a:r>
+          </a:p>
+          <a:p xmlns:a="http://schemas.openxmlformats.org/drawingml/2006/main">
+            <a:pPr algn="l">
+              <a:lnSpc>
+                <a:spcPct val="108000"/>
+              </a:lnSpc>
+              <a:buNone/>
+              <a:defRPr sz="2350" b="0" i="0">
+                <a:solidFill>
+                  <a:srgbClr val="1F2A24"/>
+                </a:solidFill>
+                <a:latin typeface="Calibri"/>
+                <a:ea typeface="Calibri"/>
+                <a:cs typeface="Calibri"/>
+              </a:defRPr>
+            </a:pPr>
+            <a:r>
+              <a:rPr sz="2350" b="0" i="0">
+                <a:solidFill>
+                  <a:srgbClr val="1F2A24"/>
+                </a:solidFill>
+                <a:latin typeface="Calibri"/>
+                <a:ea typeface="Calibri"/>
+                <a:cs typeface="Calibri"/>
+              </a:rPr>
+              <a:t>agenda without acknowledging it.</a:t>
             </a:r>
           </a:p>
         </p:txBody>
       </p:sp>
       <p:sp>
         <p:nvSpPr>
-          <p:cNvPr id="58" name="Topic derailment definition">
+          <p:cNvPr id="58" name="Straw man heading">
             <a:extLst xmlns:a="http://schemas.openxmlformats.org/drawingml/2006/main">
               <a:ext uri="{FF2B5EF4-FFF2-40B4-BE49-F238E27FC236}">
-                <a16:creationId xmlns:a16="http://schemas.microsoft.com/office/drawing/2014/main" id="{3D7B6D2B-F9F8-44E2-8AD0-9F75636E4123}"/>
+                <a16:creationId xmlns:a16="http://schemas.microsoft.com/office/drawing/2014/main" id="{2D6F14CC-2D7E-4EE1-B920-595C07A382A4}"/>
               </a:ext>
             </a:extLst>
           </p:cNvPr>
@@ -6024,8 +6051,8 @@
         </p:nvSpPr>
         <p:spPr>
           <a:xfrm xmlns:a="http://schemas.openxmlformats.org/drawingml/2006/main">
-            <a:off x="868680" y="18144000"/>
-            <a:ext cx="6398640" cy="720000"/>
+            <a:off x="7708680" y="17136000"/>
+            <a:ext cx="6398640" cy="432000"/>
           </a:xfrm>
           <a:prstGeom xmlns:a="http://schemas.openxmlformats.org/drawingml/2006/main" prst="rect">
             <a:avLst/>
@@ -6041,13 +6068,13 @@
           </a:bodyPr>
           <a:lstStyle xmlns:a="http://schemas.openxmlformats.org/drawingml/2006/main">
             <a:defPPr algn="l">
-              <a:defRPr sz="2350" b="0" i="0">
-                <a:solidFill>
-                  <a:srgbClr val="1F2A24"/>
-                </a:solidFill>
-                <a:latin typeface="Calibri"/>
-                <a:ea typeface="Calibri"/>
-                <a:cs typeface="Calibri"/>
+              <a:defRPr sz="2700" b="1" i="0">
+                <a:solidFill>
+                  <a:srgbClr val="A92F24"/>
+                </a:solidFill>
+                <a:latin typeface="Cambria"/>
+                <a:ea typeface="Cambria"/>
+                <a:cs typeface="Cambria"/>
               </a:defRPr>
             </a:defPPr>
           </a:lstStyle>
@@ -6057,62 +6084,35 @@
                 <a:spcPct val="108000"/>
               </a:lnSpc>
               <a:buNone/>
-              <a:defRPr sz="2350" b="0" i="0">
-                <a:solidFill>
-                  <a:srgbClr val="1F2A24"/>
-                </a:solidFill>
-                <a:latin typeface="Calibri"/>
-                <a:ea typeface="Calibri"/>
-                <a:cs typeface="Calibri"/>
-              </a:defRPr>
-            </a:pPr>
-            <a:r>
-              <a:rPr sz="2350" b="0" i="0">
-                <a:solidFill>
-                  <a:srgbClr val="1F2A24"/>
-                </a:solidFill>
-                <a:latin typeface="Calibri"/>
-                <a:ea typeface="Calibri"/>
-                <a:cs typeface="Calibri"/>
-              </a:rPr>
-              <a:t>Steer discussion away from the</a:t>
-            </a:r>
-          </a:p>
-          <a:p xmlns:a="http://schemas.openxmlformats.org/drawingml/2006/main">
-            <a:pPr algn="l">
-              <a:lnSpc>
-                <a:spcPct val="108000"/>
-              </a:lnSpc>
-              <a:buNone/>
-              <a:defRPr sz="2350" b="0" i="0">
-                <a:solidFill>
-                  <a:srgbClr val="1F2A24"/>
-                </a:solidFill>
-                <a:latin typeface="Calibri"/>
-                <a:ea typeface="Calibri"/>
-                <a:cs typeface="Calibri"/>
-              </a:defRPr>
-            </a:pPr>
-            <a:r>
-              <a:rPr sz="2350" b="0" i="0">
-                <a:solidFill>
-                  <a:srgbClr val="1F2A24"/>
-                </a:solidFill>
-                <a:latin typeface="Calibri"/>
-                <a:ea typeface="Calibri"/>
-                <a:cs typeface="Calibri"/>
-              </a:rPr>
-              <a:t>agenda without acknowledging it.</a:t>
+              <a:defRPr sz="2700" b="1" i="0">
+                <a:solidFill>
+                  <a:srgbClr val="A92F24"/>
+                </a:solidFill>
+                <a:latin typeface="Cambria"/>
+                <a:ea typeface="Cambria"/>
+                <a:cs typeface="Cambria"/>
+              </a:defRPr>
+            </a:pPr>
+            <a:r>
+              <a:rPr sz="2700" b="1" i="0">
+                <a:solidFill>
+                  <a:srgbClr val="A92F24"/>
+                </a:solidFill>
+                <a:latin typeface="Cambria"/>
+                <a:ea typeface="Cambria"/>
+                <a:cs typeface="Cambria"/>
+              </a:rPr>
+              <a:t>Straw man</a:t>
             </a:r>
           </a:p>
         </p:txBody>
       </p:sp>
       <p:sp>
         <p:nvSpPr>
-          <p:cNvPr id="59" name="Straw man heading">
+          <p:cNvPr id="59" name="Straw man definition">
             <a:extLst xmlns:a="http://schemas.openxmlformats.org/drawingml/2006/main">
               <a:ext uri="{FF2B5EF4-FFF2-40B4-BE49-F238E27FC236}">
-                <a16:creationId xmlns:a16="http://schemas.microsoft.com/office/drawing/2014/main" id="{39D57D50-184F-41B2-811F-CD2BBBF9C540}"/>
+                <a16:creationId xmlns:a16="http://schemas.microsoft.com/office/drawing/2014/main" id="{6EC9D806-EE83-4984-A418-A1A8882F5182}"/>
               </a:ext>
             </a:extLst>
           </p:cNvPr>
@@ -6123,8 +6123,8 @@
         </p:nvSpPr>
         <p:spPr>
           <a:xfrm xmlns:a="http://schemas.openxmlformats.org/drawingml/2006/main">
-            <a:off x="7708680" y="17568000"/>
-            <a:ext cx="6398640" cy="432000"/>
+            <a:off x="7708680" y="17712000"/>
+            <a:ext cx="6398640" cy="720000"/>
           </a:xfrm>
           <a:prstGeom xmlns:a="http://schemas.openxmlformats.org/drawingml/2006/main" prst="rect">
             <a:avLst/>
@@ -6140,13 +6140,13 @@
           </a:bodyPr>
           <a:lstStyle xmlns:a="http://schemas.openxmlformats.org/drawingml/2006/main">
             <a:defPPr algn="l">
-              <a:defRPr sz="2700" b="1" i="0">
-                <a:solidFill>
-                  <a:srgbClr val="A92F24"/>
-                </a:solidFill>
-                <a:latin typeface="Cambria"/>
-                <a:ea typeface="Cambria"/>
-                <a:cs typeface="Cambria"/>
+              <a:defRPr sz="2350" b="0" i="0">
+                <a:solidFill>
+                  <a:srgbClr val="1F2A24"/>
+                </a:solidFill>
+                <a:latin typeface="Calibri"/>
+                <a:ea typeface="Calibri"/>
+                <a:cs typeface="Calibri"/>
               </a:defRPr>
             </a:defPPr>
           </a:lstStyle>
@@ -6156,35 +6156,62 @@
                 <a:spcPct val="108000"/>
               </a:lnSpc>
               <a:buNone/>
-              <a:defRPr sz="2700" b="1" i="0">
-                <a:solidFill>
-                  <a:srgbClr val="A92F24"/>
-                </a:solidFill>
-                <a:latin typeface="Cambria"/>
-                <a:ea typeface="Cambria"/>
-                <a:cs typeface="Cambria"/>
-              </a:defRPr>
-            </a:pPr>
-            <a:r>
-              <a:rPr sz="2700" b="1" i="0">
-                <a:solidFill>
-                  <a:srgbClr val="A92F24"/>
-                </a:solidFill>
-                <a:latin typeface="Cambria"/>
-                <a:ea typeface="Cambria"/>
-                <a:cs typeface="Cambria"/>
-              </a:rPr>
-              <a:t>Straw man</a:t>
+              <a:defRPr sz="2350" b="0" i="0">
+                <a:solidFill>
+                  <a:srgbClr val="1F2A24"/>
+                </a:solidFill>
+                <a:latin typeface="Calibri"/>
+                <a:ea typeface="Calibri"/>
+                <a:cs typeface="Calibri"/>
+              </a:defRPr>
+            </a:pPr>
+            <a:r>
+              <a:rPr sz="2350" b="0" i="0">
+                <a:solidFill>
+                  <a:srgbClr val="1F2A24"/>
+                </a:solidFill>
+                <a:latin typeface="Calibri"/>
+                <a:ea typeface="Calibri"/>
+                <a:cs typeface="Calibri"/>
+              </a:rPr>
+              <a:t>Misrepresent an opponent’s claim,</a:t>
+            </a:r>
+          </a:p>
+          <a:p xmlns:a="http://schemas.openxmlformats.org/drawingml/2006/main">
+            <a:pPr algn="l">
+              <a:lnSpc>
+                <a:spcPct val="108000"/>
+              </a:lnSpc>
+              <a:buNone/>
+              <a:defRPr sz="2350" b="0" i="0">
+                <a:solidFill>
+                  <a:srgbClr val="1F2A24"/>
+                </a:solidFill>
+                <a:latin typeface="Calibri"/>
+                <a:ea typeface="Calibri"/>
+                <a:cs typeface="Calibri"/>
+              </a:defRPr>
+            </a:pPr>
+            <a:r>
+              <a:rPr sz="2350" b="0" i="0">
+                <a:solidFill>
+                  <a:srgbClr val="1F2A24"/>
+                </a:solidFill>
+                <a:latin typeface="Calibri"/>
+                <a:ea typeface="Calibri"/>
+                <a:cs typeface="Calibri"/>
+              </a:rPr>
+              <a:t>then attack the distorted version.</a:t>
             </a:r>
           </a:p>
         </p:txBody>
       </p:sp>
       <p:sp>
         <p:nvSpPr>
-          <p:cNvPr id="60" name="Straw man definition">
+          <p:cNvPr id="60" name="Procedural manipulation heading">
             <a:extLst xmlns:a="http://schemas.openxmlformats.org/drawingml/2006/main">
               <a:ext uri="{FF2B5EF4-FFF2-40B4-BE49-F238E27FC236}">
-                <a16:creationId xmlns:a16="http://schemas.microsoft.com/office/drawing/2014/main" id="{D1D046CA-6B58-4AE4-9627-209FAF7082B6}"/>
+                <a16:creationId xmlns:a16="http://schemas.microsoft.com/office/drawing/2014/main" id="{207EF371-542B-4E53-99DC-1621F9D23A04}"/>
               </a:ext>
             </a:extLst>
           </p:cNvPr>
@@ -6195,8 +6222,8 @@
         </p:nvSpPr>
         <p:spPr>
           <a:xfrm xmlns:a="http://schemas.openxmlformats.org/drawingml/2006/main">
-            <a:off x="7708680" y="18144000"/>
-            <a:ext cx="6398640" cy="720000"/>
+            <a:off x="14548680" y="17136000"/>
+            <a:ext cx="6398640" cy="432000"/>
           </a:xfrm>
           <a:prstGeom xmlns:a="http://schemas.openxmlformats.org/drawingml/2006/main" prst="rect">
             <a:avLst/>
@@ -6212,13 +6239,13 @@
           </a:bodyPr>
           <a:lstStyle xmlns:a="http://schemas.openxmlformats.org/drawingml/2006/main">
             <a:defPPr algn="l">
-              <a:defRPr sz="2350" b="0" i="0">
-                <a:solidFill>
-                  <a:srgbClr val="1F2A24"/>
-                </a:solidFill>
-                <a:latin typeface="Calibri"/>
-                <a:ea typeface="Calibri"/>
-                <a:cs typeface="Calibri"/>
+              <a:defRPr sz="2700" b="1" i="0">
+                <a:solidFill>
+                  <a:srgbClr val="A92F24"/>
+                </a:solidFill>
+                <a:latin typeface="Cambria"/>
+                <a:ea typeface="Cambria"/>
+                <a:cs typeface="Cambria"/>
               </a:defRPr>
             </a:defPPr>
           </a:lstStyle>
@@ -6228,62 +6255,35 @@
                 <a:spcPct val="108000"/>
               </a:lnSpc>
               <a:buNone/>
-              <a:defRPr sz="2350" b="0" i="0">
-                <a:solidFill>
-                  <a:srgbClr val="1F2A24"/>
-                </a:solidFill>
-                <a:latin typeface="Calibri"/>
-                <a:ea typeface="Calibri"/>
-                <a:cs typeface="Calibri"/>
-              </a:defRPr>
-            </a:pPr>
-            <a:r>
-              <a:rPr sz="2350" b="0" i="0">
-                <a:solidFill>
-                  <a:srgbClr val="1F2A24"/>
-                </a:solidFill>
-                <a:latin typeface="Calibri"/>
-                <a:ea typeface="Calibri"/>
-                <a:cs typeface="Calibri"/>
-              </a:rPr>
-              <a:t>Misrepresent an opponent’s claim,</a:t>
-            </a:r>
-          </a:p>
-          <a:p xmlns:a="http://schemas.openxmlformats.org/drawingml/2006/main">
-            <a:pPr algn="l">
-              <a:lnSpc>
-                <a:spcPct val="108000"/>
-              </a:lnSpc>
-              <a:buNone/>
-              <a:defRPr sz="2350" b="0" i="0">
-                <a:solidFill>
-                  <a:srgbClr val="1F2A24"/>
-                </a:solidFill>
-                <a:latin typeface="Calibri"/>
-                <a:ea typeface="Calibri"/>
-                <a:cs typeface="Calibri"/>
-              </a:defRPr>
-            </a:pPr>
-            <a:r>
-              <a:rPr sz="2350" b="0" i="0">
-                <a:solidFill>
-                  <a:srgbClr val="1F2A24"/>
-                </a:solidFill>
-                <a:latin typeface="Calibri"/>
-                <a:ea typeface="Calibri"/>
-                <a:cs typeface="Calibri"/>
-              </a:rPr>
-              <a:t>then attack the distorted version.</a:t>
+              <a:defRPr sz="2700" b="1" i="0">
+                <a:solidFill>
+                  <a:srgbClr val="A92F24"/>
+                </a:solidFill>
+                <a:latin typeface="Cambria"/>
+                <a:ea typeface="Cambria"/>
+                <a:cs typeface="Cambria"/>
+              </a:defRPr>
+            </a:pPr>
+            <a:r>
+              <a:rPr sz="2700" b="1" i="0">
+                <a:solidFill>
+                  <a:srgbClr val="A92F24"/>
+                </a:solidFill>
+                <a:latin typeface="Cambria"/>
+                <a:ea typeface="Cambria"/>
+                <a:cs typeface="Cambria"/>
+              </a:rPr>
+              <a:t>Procedural manipulation</a:t>
             </a:r>
           </a:p>
         </p:txBody>
       </p:sp>
       <p:sp>
         <p:nvSpPr>
-          <p:cNvPr id="61" name="Procedural manipulation heading">
+          <p:cNvPr id="61" name="Procedural manipulation definition">
             <a:extLst xmlns:a="http://schemas.openxmlformats.org/drawingml/2006/main">
               <a:ext uri="{FF2B5EF4-FFF2-40B4-BE49-F238E27FC236}">
-                <a16:creationId xmlns:a16="http://schemas.microsoft.com/office/drawing/2014/main" id="{77D9C97F-303F-42BB-8652-08274A5A24F9}"/>
+                <a16:creationId xmlns:a16="http://schemas.microsoft.com/office/drawing/2014/main" id="{2A5917AA-CBCC-4312-81A3-CD326ED201C1}"/>
               </a:ext>
             </a:extLst>
           </p:cNvPr>
@@ -6294,8 +6294,8 @@
         </p:nvSpPr>
         <p:spPr>
           <a:xfrm xmlns:a="http://schemas.openxmlformats.org/drawingml/2006/main">
-            <a:off x="14548680" y="17568000"/>
-            <a:ext cx="6398640" cy="432000"/>
+            <a:off x="14548680" y="17712000"/>
+            <a:ext cx="6398640" cy="720000"/>
           </a:xfrm>
           <a:prstGeom xmlns:a="http://schemas.openxmlformats.org/drawingml/2006/main" prst="rect">
             <a:avLst/>
@@ -6311,13 +6311,13 @@
           </a:bodyPr>
           <a:lstStyle xmlns:a="http://schemas.openxmlformats.org/drawingml/2006/main">
             <a:defPPr algn="l">
-              <a:defRPr sz="2700" b="1" i="0">
-                <a:solidFill>
-                  <a:srgbClr val="A92F24"/>
-                </a:solidFill>
-                <a:latin typeface="Cambria"/>
-                <a:ea typeface="Cambria"/>
-                <a:cs typeface="Cambria"/>
+              <a:defRPr sz="2350" b="0" i="0">
+                <a:solidFill>
+                  <a:srgbClr val="1F2A24"/>
+                </a:solidFill>
+                <a:latin typeface="Calibri"/>
+                <a:ea typeface="Calibri"/>
+                <a:cs typeface="Calibri"/>
               </a:defRPr>
             </a:defPPr>
           </a:lstStyle>
@@ -6327,35 +6327,62 @@
                 <a:spcPct val="108000"/>
               </a:lnSpc>
               <a:buNone/>
-              <a:defRPr sz="2700" b="1" i="0">
-                <a:solidFill>
-                  <a:srgbClr val="A92F24"/>
-                </a:solidFill>
-                <a:latin typeface="Cambria"/>
-                <a:ea typeface="Cambria"/>
-                <a:cs typeface="Cambria"/>
-              </a:defRPr>
-            </a:pPr>
-            <a:r>
-              <a:rPr sz="2700" b="1" i="0">
-                <a:solidFill>
-                  <a:srgbClr val="A92F24"/>
-                </a:solidFill>
-                <a:latin typeface="Cambria"/>
-                <a:ea typeface="Cambria"/>
-                <a:cs typeface="Cambria"/>
-              </a:rPr>
-              <a:t>Procedural manipulation</a:t>
+              <a:defRPr sz="2350" b="0" i="0">
+                <a:solidFill>
+                  <a:srgbClr val="1F2A24"/>
+                </a:solidFill>
+                <a:latin typeface="Calibri"/>
+                <a:ea typeface="Calibri"/>
+                <a:cs typeface="Calibri"/>
+              </a:defRPr>
+            </a:pPr>
+            <a:r>
+              <a:rPr sz="2350" b="0" i="0">
+                <a:solidFill>
+                  <a:srgbClr val="1F2A24"/>
+                </a:solidFill>
+                <a:latin typeface="Calibri"/>
+                <a:ea typeface="Calibri"/>
+                <a:cs typeface="Calibri"/>
+              </a:rPr>
+              <a:t>Exploit rules or points of order</a:t>
+            </a:r>
+          </a:p>
+          <a:p xmlns:a="http://schemas.openxmlformats.org/drawingml/2006/main">
+            <a:pPr algn="l">
+              <a:lnSpc>
+                <a:spcPct val="108000"/>
+              </a:lnSpc>
+              <a:buNone/>
+              <a:defRPr sz="2350" b="0" i="0">
+                <a:solidFill>
+                  <a:srgbClr val="1F2A24"/>
+                </a:solidFill>
+                <a:latin typeface="Calibri"/>
+                <a:ea typeface="Calibri"/>
+                <a:cs typeface="Calibri"/>
+              </a:defRPr>
+            </a:pPr>
+            <a:r>
+              <a:rPr sz="2350" b="0" i="0">
+                <a:solidFill>
+                  <a:srgbClr val="1F2A24"/>
+                </a:solidFill>
+                <a:latin typeface="Calibri"/>
+                <a:ea typeface="Calibri"/>
+                <a:cs typeface="Calibri"/>
+              </a:rPr>
+              <a:t>to obstruct substantive debate.</a:t>
             </a:r>
           </a:p>
         </p:txBody>
       </p:sp>
       <p:sp>
         <p:nvSpPr>
-          <p:cNvPr id="62" name="Procedural manipulation definition">
+          <p:cNvPr id="62" name="Privacy and evaluation detail">
             <a:extLst xmlns:a="http://schemas.openxmlformats.org/drawingml/2006/main">
               <a:ext uri="{FF2B5EF4-FFF2-40B4-BE49-F238E27FC236}">
-                <a16:creationId xmlns:a16="http://schemas.microsoft.com/office/drawing/2014/main" id="{459A094B-045D-47FE-BE66-78C6E2B72330}"/>
+                <a16:creationId xmlns:a16="http://schemas.microsoft.com/office/drawing/2014/main" id="{B5A46087-F02B-45DA-BBDB-7AB0B19474BF}"/>
               </a:ext>
             </a:extLst>
           </p:cNvPr>
@@ -6366,8 +6393,8 @@
         </p:nvSpPr>
         <p:spPr>
           <a:xfrm xmlns:a="http://schemas.openxmlformats.org/drawingml/2006/main">
-            <a:off x="14548680" y="18144000"/>
-            <a:ext cx="6398640" cy="720000"/>
+            <a:off x="868680" y="18576000"/>
+            <a:ext cx="20078640" cy="720000"/>
           </a:xfrm>
           <a:prstGeom xmlns:a="http://schemas.openxmlformats.org/drawingml/2006/main" prst="rect">
             <a:avLst/>
@@ -6385,7 +6412,7 @@
             <a:defPPr algn="l">
               <a:defRPr sz="2350" b="0" i="0">
                 <a:solidFill>
-                  <a:srgbClr val="1F2A24"/>
+                  <a:srgbClr val="56615B"/>
                 </a:solidFill>
                 <a:latin typeface="Calibri"/>
                 <a:ea typeface="Calibri"/>
@@ -6401,7 +6428,7 @@
               <a:buNone/>
               <a:defRPr sz="2350" b="0" i="0">
                 <a:solidFill>
-                  <a:srgbClr val="1F2A24"/>
+                  <a:srgbClr val="56615B"/>
                 </a:solidFill>
                 <a:latin typeface="Calibri"/>
                 <a:ea typeface="Calibri"/>
@@ -6411,13 +6438,13 @@
             <a:r>
               <a:rPr sz="2350" b="0" i="0">
                 <a:solidFill>
-                  <a:srgbClr val="1F2A24"/>
-                </a:solidFill>
-                <a:latin typeface="Calibri"/>
-                <a:ea typeface="Calibri"/>
-                <a:cs typeface="Calibri"/>
-              </a:rPr>
-              <a:t>Exploit rules or points of order</a:t>
+                  <a:srgbClr val="56615B"/>
+                </a:solidFill>
+                <a:latin typeface="Calibri"/>
+                <a:ea typeface="Calibri"/>
+                <a:cs typeface="Calibri"/>
+              </a:rPr>
+              <a:t>Only assigned MPs see their tactic. Other agents receive their own setup and public evidence, with no notice of hidden assignments.</a:t>
             </a:r>
           </a:p>
           <a:p xmlns:a="http://schemas.openxmlformats.org/drawingml/2006/main">
@@ -6428,7 +6455,7 @@
               <a:buNone/>
               <a:defRPr sz="2350" b="0" i="0">
                 <a:solidFill>
-                  <a:srgbClr val="1F2A24"/>
+                  <a:srgbClr val="56615B"/>
                 </a:solidFill>
                 <a:latin typeface="Calibri"/>
                 <a:ea typeface="Calibri"/>
@@ -6438,23 +6465,23 @@
             <a:r>
               <a:rPr sz="2350" b="0" i="0">
                 <a:solidFill>
-                  <a:srgbClr val="1F2A24"/>
-                </a:solidFill>
-                <a:latin typeface="Calibri"/>
-                <a:ea typeface="Calibri"/>
-                <a:cs typeface="Calibri"/>
-              </a:rPr>
-              <a:t>to obstruct substantive debate.</a:t>
+                  <a:srgbClr val="56615B"/>
+                </a:solidFill>
+                <a:latin typeface="Calibri"/>
+                <a:ea typeface="Calibri"/>
+                <a:cs typeface="Calibri"/>
+              </a:rPr>
+              <a:t>Select debate and judge models independently. Five rubric metrics, VADER/Cardiff sentiment and DeBERTa stance stay separate.</a:t>
             </a:r>
           </a:p>
         </p:txBody>
       </p:sp>
       <p:sp>
         <p:nvSpPr>
-          <p:cNvPr id="63" name="Privacy and evaluation detail">
+          <p:cNvPr id="63" name="Section 3 number">
             <a:extLst xmlns:a="http://schemas.openxmlformats.org/drawingml/2006/main">
               <a:ext uri="{FF2B5EF4-FFF2-40B4-BE49-F238E27FC236}">
-                <a16:creationId xmlns:a16="http://schemas.microsoft.com/office/drawing/2014/main" id="{DB3F8121-3626-4555-AFEE-6FF89B609BE3}"/>
+                <a16:creationId xmlns:a16="http://schemas.microsoft.com/office/drawing/2014/main" id="{E55243A4-C430-43CE-AA65-A5AE287318CC}"/>
               </a:ext>
             </a:extLst>
           </p:cNvPr>
@@ -6465,95 +6492,65 @@
         </p:nvSpPr>
         <p:spPr>
           <a:xfrm xmlns:a="http://schemas.openxmlformats.org/drawingml/2006/main">
-            <a:off x="868680" y="19080000"/>
-            <a:ext cx="20078640" cy="720000"/>
+            <a:off x="868680" y="19656000"/>
+            <a:ext cx="712800" cy="712800"/>
           </a:xfrm>
-          <a:prstGeom xmlns:a="http://schemas.openxmlformats.org/drawingml/2006/main" prst="rect">
-            <a:avLst/>
-          </a:prstGeom>
-          <a:noFill xmlns:a="http://schemas.openxmlformats.org/drawingml/2006/main"/>
+          <a:prstGeom xmlns:a="http://schemas.openxmlformats.org/drawingml/2006/main" prst="ellipse">
+            <a:avLst/>
+          </a:prstGeom>
+          <a:solidFill xmlns:a="http://schemas.openxmlformats.org/drawingml/2006/main">
+            <a:srgbClr val="C9971C"/>
+          </a:solidFill>
           <a:ln xmlns:a="http://schemas.openxmlformats.org/drawingml/2006/main" w="0">
             <a:noFill/>
+            <a:prstDash val="solid"/>
           </a:ln>
         </p:spPr>
         <p:txBody>
-          <a:bodyPr xmlns:a="http://schemas.openxmlformats.org/drawingml/2006/main" wrap="square" lIns="0" tIns="0" rIns="0" bIns="0" anchor="t">
-            <a:noAutofit/>
-          </a:bodyPr>
+          <a:bodyPr xmlns:a="http://schemas.openxmlformats.org/drawingml/2006/main" lIns="0" tIns="0" rIns="0" bIns="0" anchor="ctr"/>
           <a:lstStyle xmlns:a="http://schemas.openxmlformats.org/drawingml/2006/main">
-            <a:defPPr algn="l">
-              <a:defRPr sz="2350" b="0" i="0">
-                <a:solidFill>
-                  <a:srgbClr val="56615B"/>
-                </a:solidFill>
-                <a:latin typeface="Calibri"/>
-                <a:ea typeface="Calibri"/>
-                <a:cs typeface="Calibri"/>
+            <a:defPPr algn="ctr">
+              <a:defRPr sz="3700" b="1">
+                <a:solidFill>
+                  <a:srgbClr val="FFFFFF"/>
+                </a:solidFill>
+                <a:latin typeface="Cambria"/>
+                <a:ea typeface="Cambria"/>
+                <a:cs typeface="Cambria"/>
               </a:defRPr>
             </a:defPPr>
           </a:lstStyle>
           <a:p xmlns:a="http://schemas.openxmlformats.org/drawingml/2006/main">
-            <a:pPr algn="l">
-              <a:lnSpc>
-                <a:spcPct val="108000"/>
-              </a:lnSpc>
-              <a:buNone/>
-              <a:defRPr sz="2350" b="0" i="0">
-                <a:solidFill>
-                  <a:srgbClr val="56615B"/>
-                </a:solidFill>
-                <a:latin typeface="Calibri"/>
-                <a:ea typeface="Calibri"/>
-                <a:cs typeface="Calibri"/>
-              </a:defRPr>
-            </a:pPr>
-            <a:r>
-              <a:rPr sz="2350" b="0" i="0">
-                <a:solidFill>
-                  <a:srgbClr val="56615B"/>
-                </a:solidFill>
-                <a:latin typeface="Calibri"/>
-                <a:ea typeface="Calibri"/>
-                <a:cs typeface="Calibri"/>
-              </a:rPr>
-              <a:t>Only assigned MPs see their tactic. Other agents receive their own setup and public evidence, with no notice of hidden assignments.</a:t>
-            </a:r>
-          </a:p>
-          <a:p xmlns:a="http://schemas.openxmlformats.org/drawingml/2006/main">
-            <a:pPr algn="l">
-              <a:lnSpc>
-                <a:spcPct val="108000"/>
-              </a:lnSpc>
-              <a:buNone/>
-              <a:defRPr sz="2350" b="0" i="0">
-                <a:solidFill>
-                  <a:srgbClr val="56615B"/>
-                </a:solidFill>
-                <a:latin typeface="Calibri"/>
-                <a:ea typeface="Calibri"/>
-                <a:cs typeface="Calibri"/>
-              </a:defRPr>
-            </a:pPr>
-            <a:r>
-              <a:rPr sz="2350" b="0" i="0">
-                <a:solidFill>
-                  <a:srgbClr val="56615B"/>
-                </a:solidFill>
-                <a:latin typeface="Calibri"/>
-                <a:ea typeface="Calibri"/>
-                <a:cs typeface="Calibri"/>
-              </a:rPr>
-              <a:t>Select debate and judge models independently. Five rubric metrics, VADER/Cardiff sentiment and DeBERTa stance stay separate.</a:t>
+            <a:pPr algn="ctr">
+              <a:defRPr sz="3700" b="1">
+                <a:solidFill>
+                  <a:srgbClr val="FFFFFF"/>
+                </a:solidFill>
+                <a:latin typeface="Cambria"/>
+                <a:ea typeface="Cambria"/>
+                <a:cs typeface="Cambria"/>
+              </a:defRPr>
+            </a:pPr>
+            <a:r>
+              <a:rPr sz="3700" b="1">
+                <a:solidFill>
+                  <a:srgbClr val="FFFFFF"/>
+                </a:solidFill>
+                <a:latin typeface="Cambria"/>
+                <a:ea typeface="Cambria"/>
+                <a:cs typeface="Cambria"/>
+              </a:rPr>
+              <a:t>3</a:t>
             </a:r>
           </a:p>
         </p:txBody>
       </p:sp>
       <p:sp>
         <p:nvSpPr>
-          <p:cNvPr id="64" name="Section 3 number">
+          <p:cNvPr id="64" name="Section 3 title">
             <a:extLst xmlns:a="http://schemas.openxmlformats.org/drawingml/2006/main">
               <a:ext uri="{FF2B5EF4-FFF2-40B4-BE49-F238E27FC236}">
-                <a16:creationId xmlns:a16="http://schemas.microsoft.com/office/drawing/2014/main" id="{9B23C13B-5ABB-4725-8AFF-5F89D3A23A22}"/>
+                <a16:creationId xmlns:a16="http://schemas.microsoft.com/office/drawing/2014/main" id="{CFD18A59-71E9-411B-AE4E-30A561F031DC}"/>
               </a:ext>
             </a:extLst>
           </p:cNvPr>
@@ -6564,27 +6561,26 @@
         </p:nvSpPr>
         <p:spPr>
           <a:xfrm xmlns:a="http://schemas.openxmlformats.org/drawingml/2006/main">
-            <a:off x="868680" y="19944000"/>
-            <a:ext cx="712800" cy="712800"/>
+            <a:off x="1836000" y="19602000"/>
+            <a:ext cx="19080000" cy="900000"/>
           </a:xfrm>
-          <a:prstGeom xmlns:a="http://schemas.openxmlformats.org/drawingml/2006/main" prst="ellipse">
-            <a:avLst/>
-          </a:prstGeom>
-          <a:solidFill xmlns:a="http://schemas.openxmlformats.org/drawingml/2006/main">
-            <a:srgbClr val="C9971C"/>
-          </a:solidFill>
+          <a:prstGeom xmlns:a="http://schemas.openxmlformats.org/drawingml/2006/main" prst="rect">
+            <a:avLst/>
+          </a:prstGeom>
+          <a:noFill xmlns:a="http://schemas.openxmlformats.org/drawingml/2006/main"/>
           <a:ln xmlns:a="http://schemas.openxmlformats.org/drawingml/2006/main" w="0">
             <a:noFill/>
-            <a:prstDash val="solid"/>
           </a:ln>
         </p:spPr>
         <p:txBody>
-          <a:bodyPr xmlns:a="http://schemas.openxmlformats.org/drawingml/2006/main" lIns="0" tIns="0" rIns="0" bIns="0" anchor="ctr"/>
+          <a:bodyPr xmlns:a="http://schemas.openxmlformats.org/drawingml/2006/main" wrap="square" lIns="0" tIns="0" rIns="0" bIns="0" anchor="t">
+            <a:noAutofit/>
+          </a:bodyPr>
           <a:lstStyle xmlns:a="http://schemas.openxmlformats.org/drawingml/2006/main">
-            <a:defPPr algn="ctr">
-              <a:defRPr sz="3700" b="1">
-                <a:solidFill>
-                  <a:srgbClr val="FFFFFF"/>
+            <a:defPPr algn="l">
+              <a:defRPr sz="5300" b="1" i="0">
+                <a:solidFill>
+                  <a:srgbClr val="1F4D36"/>
                 </a:solidFill>
                 <a:latin typeface="Cambria"/>
                 <a:ea typeface="Cambria"/>
@@ -6593,36 +6589,40 @@
             </a:defPPr>
           </a:lstStyle>
           <a:p xmlns:a="http://schemas.openxmlformats.org/drawingml/2006/main">
-            <a:pPr algn="ctr">
-              <a:defRPr sz="3700" b="1">
-                <a:solidFill>
-                  <a:srgbClr val="FFFFFF"/>
-                </a:solidFill>
-                <a:latin typeface="Cambria"/>
-                <a:ea typeface="Cambria"/>
-                <a:cs typeface="Cambria"/>
-              </a:defRPr>
-            </a:pPr>
-            <a:r>
-              <a:rPr sz="3700" b="1">
-                <a:solidFill>
-                  <a:srgbClr val="FFFFFF"/>
-                </a:solidFill>
-                <a:latin typeface="Cambria"/>
-                <a:ea typeface="Cambria"/>
-                <a:cs typeface="Cambria"/>
-              </a:rPr>
-              <a:t>3</a:t>
+            <a:pPr algn="l">
+              <a:lnSpc>
+                <a:spcPct val="108000"/>
+              </a:lnSpc>
+              <a:buNone/>
+              <a:defRPr sz="5300" b="1" i="0">
+                <a:solidFill>
+                  <a:srgbClr val="1F4D36"/>
+                </a:solidFill>
+                <a:latin typeface="Cambria"/>
+                <a:ea typeface="Cambria"/>
+                <a:cs typeface="Cambria"/>
+              </a:defRPr>
+            </a:pPr>
+            <a:r>
+              <a:rPr sz="5300" b="1" i="0">
+                <a:solidFill>
+                  <a:srgbClr val="1F4D36"/>
+                </a:solidFill>
+                <a:latin typeface="Cambria"/>
+                <a:ea typeface="Cambria"/>
+                <a:cs typeface="Cambria"/>
+              </a:rPr>
+              <a:t>More grounding gave no consistent gain</a:t>
             </a:r>
           </a:p>
         </p:txBody>
       </p:sp>
       <p:sp>
         <p:nvSpPr>
-          <p:cNvPr id="65" name="Section 3 title">
+          <p:cNvPr id="65" name="Baseline study design">
             <a:extLst xmlns:a="http://schemas.openxmlformats.org/drawingml/2006/main">
               <a:ext uri="{FF2B5EF4-FFF2-40B4-BE49-F238E27FC236}">
-                <a16:creationId xmlns:a16="http://schemas.microsoft.com/office/drawing/2014/main" id="{6093315F-DEED-4D17-92F4-79375A1ECB78}"/>
+                <a16:creationId xmlns:a16="http://schemas.microsoft.com/office/drawing/2014/main" id="{12325A53-41CA-49FB-AEE4-AD6D4E131812}"/>
               </a:ext>
             </a:extLst>
           </p:cNvPr>
@@ -6633,8 +6633,8 @@
         </p:nvSpPr>
         <p:spPr>
           <a:xfrm xmlns:a="http://schemas.openxmlformats.org/drawingml/2006/main">
-            <a:off x="1836000" y="19890000"/>
-            <a:ext cx="19080000" cy="900000"/>
+            <a:off x="868680" y="20592000"/>
+            <a:ext cx="20078640" cy="936000"/>
           </a:xfrm>
           <a:prstGeom xmlns:a="http://schemas.openxmlformats.org/drawingml/2006/main" prst="rect">
             <a:avLst/>
@@ -6650,13 +6650,13 @@
           </a:bodyPr>
           <a:lstStyle xmlns:a="http://schemas.openxmlformats.org/drawingml/2006/main">
             <a:defPPr algn="l">
-              <a:defRPr sz="5300" b="1" i="0">
-                <a:solidFill>
-                  <a:srgbClr val="1F4D36"/>
-                </a:solidFill>
-                <a:latin typeface="Cambria"/>
-                <a:ea typeface="Cambria"/>
-                <a:cs typeface="Cambria"/>
+              <a:defRPr sz="2500" b="0" i="0">
+                <a:solidFill>
+                  <a:srgbClr val="1F2A24"/>
+                </a:solidFill>
+                <a:latin typeface="Calibri"/>
+                <a:ea typeface="Calibri"/>
+                <a:cs typeface="Calibri"/>
               </a:defRPr>
             </a:defPPr>
           </a:lstStyle>
@@ -6666,35 +6666,134 @@
                 <a:spcPct val="108000"/>
               </a:lnSpc>
               <a:buNone/>
-              <a:defRPr sz="5300" b="1" i="0">
-                <a:solidFill>
-                  <a:srgbClr val="1F4D36"/>
-                </a:solidFill>
-                <a:latin typeface="Cambria"/>
-                <a:ea typeface="Cambria"/>
-                <a:cs typeface="Cambria"/>
-              </a:defRPr>
-            </a:pPr>
-            <a:r>
-              <a:rPr sz="5300" b="1" i="0">
-                <a:solidFill>
-                  <a:srgbClr val="1F4D36"/>
-                </a:solidFill>
-                <a:latin typeface="Cambria"/>
-                <a:ea typeface="Cambria"/>
-                <a:cs typeface="Cambria"/>
-              </a:rPr>
-              <a:t>More grounding gave no consistent gain</a:t>
+              <a:defRPr sz="2500" b="0" i="0">
+                <a:solidFill>
+                  <a:srgbClr val="1F2A24"/>
+                </a:solidFill>
+                <a:latin typeface="Calibri"/>
+                <a:ea typeface="Calibri"/>
+                <a:cs typeface="Calibri"/>
+              </a:defRPr>
+            </a:pPr>
+            <a:r>
+              <a:rPr sz="2500" b="1" i="0">
+                <a:solidFill>
+                  <a:srgbClr val="1F2A24"/>
+                </a:solidFill>
+                <a:latin typeface="Calibri"/>
+                <a:ea typeface="Calibri"/>
+                <a:cs typeface="Calibri"/>
+              </a:rPr>
+              <a:t>54 baseline debates and 1,350 speeches</a:t>
+            </a:r>
+            <a:r>
+              <a:rPr sz="2500" b="0" i="0">
+                <a:solidFill>
+                  <a:srgbClr val="1F2A24"/>
+                </a:solidFill>
+                <a:latin typeface="Calibri"/>
+                <a:ea typeface="Calibri"/>
+                <a:cs typeface="Calibri"/>
+              </a:rPr>
+              <a:t> [2]. GPT-6 Luna and Qwen3:8b each ran three topics × three grounding levels (0/10/100) × three repetitions, with five parties and five rounds. Topics: retirement age, nuclear power and a four-day workweek. </a:t>
+            </a:r>
+            <a:r>
+              <a:rPr sz="2500" b="1" i="0">
+                <a:solidFill>
+                  <a:srgbClr val="1F2A24"/>
+                </a:solidFill>
+                <a:latin typeface="Calibri"/>
+                <a:ea typeface="Calibri"/>
+                <a:cs typeface="Calibri"/>
+              </a:rPr>
+              <a:t>All agents were cooperative</a:t>
+            </a:r>
+            <a:r>
+              <a:rPr sz="2500" b="0" i="0">
+                <a:solidFill>
+                  <a:srgbClr val="1F2A24"/>
+                </a:solidFill>
+                <a:latin typeface="Calibri"/>
+                <a:ea typeface="Calibri"/>
+                <a:cs typeface="Calibri"/>
+              </a:rPr>
+              <a:t>, with interruptions disabled.</a:t>
             </a:r>
           </a:p>
         </p:txBody>
       </p:sp>
+      <p:graphicFrame>
+        <p:nvGraphicFramePr>
+          <p:cNvPr id="66" name="Chart">
+            <a:extLst xmlns:a="http://schemas.openxmlformats.org/drawingml/2006/main">
+              <a:ext uri="{FF2B5EF4-FFF2-40B4-BE49-F238E27FC236}">
+                <a16:creationId xmlns:a16="http://schemas.microsoft.com/office/drawing/2014/main" id="{623D1039-16CC-4079-8567-69328CA7CDAB}"/>
+              </a:ext>
+            </a:extLst>
+          </p:cNvPr>
+          <p:cNvGraphicFramePr/>
+          <p:nvPr/>
+        </p:nvGraphicFramePr>
+        <p:xfrm>
+          <a:off xmlns:a="http://schemas.openxmlformats.org/drawingml/2006/main" x="868680" y="21528000"/>
+          <a:ext xmlns:a="http://schemas.openxmlformats.org/drawingml/2006/main" cx="6542640" cy="2916000"/>
+        </p:xfrm>
+        <a:graphic xmlns:a="http://schemas.openxmlformats.org/drawingml/2006/main">
+          <a:graphicData uri="http://schemas.openxmlformats.org/drawingml/2006/chart">
+            <c:chart xmlns:r="http://schemas.openxmlformats.org/officeDocument/2006/relationships" xmlns:c="http://schemas.openxmlformats.org/drawingml/2006/chart" r:id="Rf474750986af4f54"/>
+          </a:graphicData>
+        </a:graphic>
+      </p:graphicFrame>
+      <p:graphicFrame>
+        <p:nvGraphicFramePr>
+          <p:cNvPr id="67" name="Chart">
+            <a:extLst xmlns:a="http://schemas.openxmlformats.org/drawingml/2006/main">
+              <a:ext uri="{FF2B5EF4-FFF2-40B4-BE49-F238E27FC236}">
+                <a16:creationId xmlns:a16="http://schemas.microsoft.com/office/drawing/2014/main" id="{0AFB3D7C-FD15-4D73-9FE5-1B725E548274}"/>
+              </a:ext>
+            </a:extLst>
+          </p:cNvPr>
+          <p:cNvGraphicFramePr/>
+          <p:nvPr/>
+        </p:nvGraphicFramePr>
+        <p:xfrm>
+          <a:off xmlns:a="http://schemas.openxmlformats.org/drawingml/2006/main" x="7636680" y="21528000"/>
+          <a:ext xmlns:a="http://schemas.openxmlformats.org/drawingml/2006/main" cx="6542640" cy="2916000"/>
+        </p:xfrm>
+        <a:graphic xmlns:a="http://schemas.openxmlformats.org/drawingml/2006/main">
+          <a:graphicData uri="http://schemas.openxmlformats.org/drawingml/2006/chart">
+            <c:chart xmlns:r="http://schemas.openxmlformats.org/officeDocument/2006/relationships" xmlns:c="http://schemas.openxmlformats.org/drawingml/2006/chart" r:id="R05339ef120bd4b06"/>
+          </a:graphicData>
+        </a:graphic>
+      </p:graphicFrame>
+      <p:graphicFrame>
+        <p:nvGraphicFramePr>
+          <p:cNvPr id="68" name="Chart">
+            <a:extLst xmlns:a="http://schemas.openxmlformats.org/drawingml/2006/main">
+              <a:ext uri="{FF2B5EF4-FFF2-40B4-BE49-F238E27FC236}">
+                <a16:creationId xmlns:a16="http://schemas.microsoft.com/office/drawing/2014/main" id="{A93EAB67-F74D-4D2F-9A0E-9187D140310A}"/>
+              </a:ext>
+            </a:extLst>
+          </p:cNvPr>
+          <p:cNvGraphicFramePr/>
+          <p:nvPr/>
+        </p:nvGraphicFramePr>
+        <p:xfrm>
+          <a:off xmlns:a="http://schemas.openxmlformats.org/drawingml/2006/main" x="14404680" y="21528000"/>
+          <a:ext xmlns:a="http://schemas.openxmlformats.org/drawingml/2006/main" cx="6542640" cy="2916000"/>
+        </p:xfrm>
+        <a:graphic xmlns:a="http://schemas.openxmlformats.org/drawingml/2006/main">
+          <a:graphicData uri="http://schemas.openxmlformats.org/drawingml/2006/chart">
+            <c:chart xmlns:r="http://schemas.openxmlformats.org/officeDocument/2006/relationships" xmlns:c="http://schemas.openxmlformats.org/drawingml/2006/chart" r:id="Rf3b2799f438b4b81"/>
+          </a:graphicData>
+        </a:graphic>
+      </p:graphicFrame>
       <p:sp>
         <p:nvSpPr>
-          <p:cNvPr id="66" name="Baseline study design">
+          <p:cNvPr id="69" name="Observed consistency drop">
             <a:extLst xmlns:a="http://schemas.openxmlformats.org/drawingml/2006/main">
               <a:ext uri="{FF2B5EF4-FFF2-40B4-BE49-F238E27FC236}">
-                <a16:creationId xmlns:a16="http://schemas.microsoft.com/office/drawing/2014/main" id="{80CA37BF-5D10-4AB1-94D8-9ADD18A820CB}"/>
+                <a16:creationId xmlns:a16="http://schemas.microsoft.com/office/drawing/2014/main" id="{A8D17142-28B7-4694-9470-41FCA1B6C128}"/>
               </a:ext>
             </a:extLst>
           </p:cNvPr>
@@ -6705,8 +6804,8 @@
         </p:nvSpPr>
         <p:spPr>
           <a:xfrm xmlns:a="http://schemas.openxmlformats.org/drawingml/2006/main">
-            <a:off x="868680" y="20880000"/>
-            <a:ext cx="20078640" cy="936000"/>
+            <a:off x="868680" y="24696000"/>
+            <a:ext cx="20078640" cy="900000"/>
           </a:xfrm>
           <a:prstGeom xmlns:a="http://schemas.openxmlformats.org/drawingml/2006/main" prst="rect">
             <a:avLst/>
@@ -6722,9 +6821,9 @@
           </a:bodyPr>
           <a:lstStyle xmlns:a="http://schemas.openxmlformats.org/drawingml/2006/main">
             <a:defPPr algn="l">
-              <a:defRPr sz="2500" b="0" i="0">
-                <a:solidFill>
-                  <a:srgbClr val="1F2A24"/>
+              <a:defRPr sz="2450" b="0" i="0">
+                <a:solidFill>
+                  <a:srgbClr val="1F4D36"/>
                 </a:solidFill>
                 <a:latin typeface="Calibri"/>
                 <a:ea typeface="Calibri"/>
@@ -6738,134 +6837,46 @@
                 <a:spcPct val="108000"/>
               </a:lnSpc>
               <a:buNone/>
-              <a:defRPr sz="2500" b="0" i="0">
-                <a:solidFill>
-                  <a:srgbClr val="1F2A24"/>
-                </a:solidFill>
-                <a:latin typeface="Calibri"/>
-                <a:ea typeface="Calibri"/>
-                <a:cs typeface="Calibri"/>
-              </a:defRPr>
-            </a:pPr>
-            <a:r>
-              <a:rPr sz="2500" b="1" i="0">
-                <a:solidFill>
-                  <a:srgbClr val="1F2A24"/>
-                </a:solidFill>
-                <a:latin typeface="Calibri"/>
-                <a:ea typeface="Calibri"/>
-                <a:cs typeface="Calibri"/>
-              </a:rPr>
-              <a:t>54 baseline debates and 1,350 speeches</a:t>
-            </a:r>
-            <a:r>
-              <a:rPr sz="2500" b="0" i="0">
-                <a:solidFill>
-                  <a:srgbClr val="1F2A24"/>
-                </a:solidFill>
-                <a:latin typeface="Calibri"/>
-                <a:ea typeface="Calibri"/>
-                <a:cs typeface="Calibri"/>
-              </a:rPr>
-              <a:t> [2]. GPT-6 Luna and Qwen3:8b each ran three topics × three grounding levels (0/10/100) × three repetitions, with five parties and five rounds. Topics: retirement age, nuclear power and a four-day workweek. </a:t>
-            </a:r>
-            <a:r>
-              <a:rPr sz="2500" b="1" i="0">
-                <a:solidFill>
-                  <a:srgbClr val="1F2A24"/>
-                </a:solidFill>
-                <a:latin typeface="Calibri"/>
-                <a:ea typeface="Calibri"/>
-                <a:cs typeface="Calibri"/>
-              </a:rPr>
-              <a:t>All agents were cooperative</a:t>
-            </a:r>
-            <a:r>
-              <a:rPr sz="2500" b="0" i="0">
-                <a:solidFill>
-                  <a:srgbClr val="1F2A24"/>
-                </a:solidFill>
-                <a:latin typeface="Calibri"/>
-                <a:ea typeface="Calibri"/>
-                <a:cs typeface="Calibri"/>
-              </a:rPr>
-              <a:t>, with interruptions disabled.</a:t>
+              <a:defRPr sz="2450" b="0" i="0">
+                <a:solidFill>
+                  <a:srgbClr val="1F4D36"/>
+                </a:solidFill>
+                <a:latin typeface="Calibri"/>
+                <a:ea typeface="Calibri"/>
+                <a:cs typeface="Calibri"/>
+              </a:defRPr>
+            </a:pPr>
+            <a:r>
+              <a:rPr sz="2450" b="1" i="0">
+                <a:solidFill>
+                  <a:srgbClr val="1F4D36"/>
+                </a:solidFill>
+                <a:latin typeface="Calibri"/>
+                <a:ea typeface="Calibri"/>
+                <a:cs typeface="Calibri"/>
+              </a:rPr>
+              <a:t>Qwen consistency</a:t>
+            </a:r>
+            <a:r>
+              <a:rPr sz="2450" b="0" i="0">
+                <a:solidFill>
+                  <a:srgbClr val="1F4D36"/>
+                </a:solidFill>
+                <a:latin typeface="Calibri"/>
+                <a:ea typeface="Calibri"/>
+                <a:cs typeface="Calibri"/>
+              </a:rPr>
+              <a:t> fell from 3.93 to 3.62 (-0.31) between 0 and 100 excerpts. Other changes were small or mixed. Relevance endpoints were unchanged (Luna 4.00, Qwen 3.98), and disruptive rhetoric stayed near zero (0.00-0.04). Higher rhetoric means more disruption.</a:t>
             </a:r>
           </a:p>
         </p:txBody>
       </p:sp>
-      <p:graphicFrame>
-        <p:nvGraphicFramePr>
-          <p:cNvPr id="67" name="Chart">
+      <p:sp>
+        <p:nvSpPr>
+          <p:cNvPr id="70" name="Research limitations">
             <a:extLst xmlns:a="http://schemas.openxmlformats.org/drawingml/2006/main">
               <a:ext uri="{FF2B5EF4-FFF2-40B4-BE49-F238E27FC236}">
-                <a16:creationId xmlns:a16="http://schemas.microsoft.com/office/drawing/2014/main" id="{8C734F3E-F100-4406-A3DA-2E60E3E90F60}"/>
-              </a:ext>
-            </a:extLst>
-          </p:cNvPr>
-          <p:cNvGraphicFramePr/>
-          <p:nvPr/>
-        </p:nvGraphicFramePr>
-        <p:xfrm>
-          <a:off xmlns:a="http://schemas.openxmlformats.org/drawingml/2006/main" x="868680" y="21888000"/>
-          <a:ext xmlns:a="http://schemas.openxmlformats.org/drawingml/2006/main" cx="6542640" cy="3060000"/>
-        </p:xfrm>
-        <a:graphic xmlns:a="http://schemas.openxmlformats.org/drawingml/2006/main">
-          <a:graphicData uri="http://schemas.openxmlformats.org/drawingml/2006/chart">
-            <c:chart xmlns:r="http://schemas.openxmlformats.org/officeDocument/2006/relationships" xmlns:c="http://schemas.openxmlformats.org/drawingml/2006/chart" r:id="R2cfc969d3cfc4a5d"/>
-          </a:graphicData>
-        </a:graphic>
-      </p:graphicFrame>
-      <p:graphicFrame>
-        <p:nvGraphicFramePr>
-          <p:cNvPr id="68" name="Chart">
-            <a:extLst xmlns:a="http://schemas.openxmlformats.org/drawingml/2006/main">
-              <a:ext uri="{FF2B5EF4-FFF2-40B4-BE49-F238E27FC236}">
-                <a16:creationId xmlns:a16="http://schemas.microsoft.com/office/drawing/2014/main" id="{BFFCE2AA-53F7-4858-99A0-5964FA20324F}"/>
-              </a:ext>
-            </a:extLst>
-          </p:cNvPr>
-          <p:cNvGraphicFramePr/>
-          <p:nvPr/>
-        </p:nvGraphicFramePr>
-        <p:xfrm>
-          <a:off xmlns:a="http://schemas.openxmlformats.org/drawingml/2006/main" x="7636680" y="21888000"/>
-          <a:ext xmlns:a="http://schemas.openxmlformats.org/drawingml/2006/main" cx="6542640" cy="3060000"/>
-        </p:xfrm>
-        <a:graphic xmlns:a="http://schemas.openxmlformats.org/drawingml/2006/main">
-          <a:graphicData uri="http://schemas.openxmlformats.org/drawingml/2006/chart">
-            <c:chart xmlns:r="http://schemas.openxmlformats.org/officeDocument/2006/relationships" xmlns:c="http://schemas.openxmlformats.org/drawingml/2006/chart" r:id="R88210e8fe1144b3c"/>
-          </a:graphicData>
-        </a:graphic>
-      </p:graphicFrame>
-      <p:graphicFrame>
-        <p:nvGraphicFramePr>
-          <p:cNvPr id="69" name="Chart">
-            <a:extLst xmlns:a="http://schemas.openxmlformats.org/drawingml/2006/main">
-              <a:ext uri="{FF2B5EF4-FFF2-40B4-BE49-F238E27FC236}">
-                <a16:creationId xmlns:a16="http://schemas.microsoft.com/office/drawing/2014/main" id="{9AB591BB-3EA5-4EEB-A9EE-C528A9F69FD1}"/>
-              </a:ext>
-            </a:extLst>
-          </p:cNvPr>
-          <p:cNvGraphicFramePr/>
-          <p:nvPr/>
-        </p:nvGraphicFramePr>
-        <p:xfrm>
-          <a:off xmlns:a="http://schemas.openxmlformats.org/drawingml/2006/main" x="14404680" y="21888000"/>
-          <a:ext xmlns:a="http://schemas.openxmlformats.org/drawingml/2006/main" cx="6542640" cy="3060000"/>
-        </p:xfrm>
-        <a:graphic xmlns:a="http://schemas.openxmlformats.org/drawingml/2006/main">
-          <a:graphicData uri="http://schemas.openxmlformats.org/drawingml/2006/chart">
-            <c:chart xmlns:r="http://schemas.openxmlformats.org/officeDocument/2006/relationships" xmlns:c="http://schemas.openxmlformats.org/drawingml/2006/chart" r:id="R6298dc0f09224c7a"/>
-          </a:graphicData>
-        </a:graphic>
-      </p:graphicFrame>
-      <p:sp>
-        <p:nvSpPr>
-          <p:cNvPr id="70" name="Observed consistency drop">
-            <a:extLst xmlns:a="http://schemas.openxmlformats.org/drawingml/2006/main">
-              <a:ext uri="{FF2B5EF4-FFF2-40B4-BE49-F238E27FC236}">
-                <a16:creationId xmlns:a16="http://schemas.microsoft.com/office/drawing/2014/main" id="{11254421-FAD4-4DFE-89B1-3CA394D7FDF2}"/>
+                <a16:creationId xmlns:a16="http://schemas.microsoft.com/office/drawing/2014/main" id="{E4A1AF19-65F9-42D9-BC39-63AF8459158C}"/>
               </a:ext>
             </a:extLst>
           </p:cNvPr>
@@ -6876,8 +6887,8 @@
         </p:nvSpPr>
         <p:spPr>
           <a:xfrm xmlns:a="http://schemas.openxmlformats.org/drawingml/2006/main">
-            <a:off x="868680" y="25056000"/>
-            <a:ext cx="20078640" cy="900000"/>
+            <a:off x="868680" y="25560000"/>
+            <a:ext cx="20078640" cy="648000"/>
           </a:xfrm>
           <a:prstGeom xmlns:a="http://schemas.openxmlformats.org/drawingml/2006/main" prst="rect">
             <a:avLst/>
@@ -6893,9 +6904,9 @@
           </a:bodyPr>
           <a:lstStyle xmlns:a="http://schemas.openxmlformats.org/drawingml/2006/main">
             <a:defPPr algn="l">
-              <a:defRPr sz="2450" b="0" i="0">
-                <a:solidFill>
-                  <a:srgbClr val="1F4D36"/>
+              <a:defRPr sz="2050" b="0" i="1">
+                <a:solidFill>
+                  <a:srgbClr val="56615B"/>
                 </a:solidFill>
                 <a:latin typeface="Calibri"/>
                 <a:ea typeface="Calibri"/>
@@ -6909,46 +6920,35 @@
                 <a:spcPct val="108000"/>
               </a:lnSpc>
               <a:buNone/>
-              <a:defRPr sz="2450" b="0" i="0">
-                <a:solidFill>
-                  <a:srgbClr val="1F4D36"/>
-                </a:solidFill>
-                <a:latin typeface="Calibri"/>
-                <a:ea typeface="Calibri"/>
-                <a:cs typeface="Calibri"/>
-              </a:defRPr>
-            </a:pPr>
-            <a:r>
-              <a:rPr sz="2450" b="1" i="0">
-                <a:solidFill>
-                  <a:srgbClr val="1F4D36"/>
-                </a:solidFill>
-                <a:latin typeface="Calibri"/>
-                <a:ea typeface="Calibri"/>
-                <a:cs typeface="Calibri"/>
-              </a:rPr>
-              <a:t>Qwen consistency</a:t>
-            </a:r>
-            <a:r>
-              <a:rPr sz="2450" b="0" i="0">
-                <a:solidFill>
-                  <a:srgbClr val="1F4D36"/>
-                </a:solidFill>
-                <a:latin typeface="Calibri"/>
-                <a:ea typeface="Calibri"/>
-                <a:cs typeface="Calibri"/>
-              </a:rPr>
-              <a:t> fell from 3.93 to 3.62 (-0.31) between 0 and 100 excerpts. Other changes were small or mixed. Relevance endpoints were unchanged (Luna 4.00, Qwen 3.98), and disruptive rhetoric stayed near zero (0.00-0.04). Higher rhetoric means more disruption.</a:t>
+              <a:defRPr sz="2050" b="0" i="1">
+                <a:solidFill>
+                  <a:srgbClr val="56615B"/>
+                </a:solidFill>
+                <a:latin typeface="Calibri"/>
+                <a:ea typeface="Calibri"/>
+                <a:cs typeface="Calibri"/>
+              </a:defRPr>
+            </a:pPr>
+            <a:r>
+              <a:rPr sz="2050" b="0" i="1">
+                <a:solidFill>
+                  <a:srgbClr val="56615B"/>
+                </a:solidFill>
+                <a:latin typeface="Calibri"/>
+                <a:ea typeface="Calibri"/>
+                <a:cs typeface="Calibri"/>
+              </a:rPr>
+              <a:t>Means pool 9 debates per model/level and 45 party scores per metric. One common GPT-6 Luna judge rates public evidence. Scores within a debate are dependent, and automated ratings lack human validation. These baseline runs do not establish adversarial robustness.</a:t>
             </a:r>
           </a:p>
         </p:txBody>
       </p:sp>
       <p:sp>
         <p:nvSpPr>
-          <p:cNvPr id="71" name="Research limitations">
+          <p:cNvPr id="71" name="Section 4 number">
             <a:extLst xmlns:a="http://schemas.openxmlformats.org/drawingml/2006/main">
               <a:ext uri="{FF2B5EF4-FFF2-40B4-BE49-F238E27FC236}">
-                <a16:creationId xmlns:a16="http://schemas.microsoft.com/office/drawing/2014/main" id="{0AD66653-FD11-49DD-9A81-450DA85B09AC}"/>
+                <a16:creationId xmlns:a16="http://schemas.microsoft.com/office/drawing/2014/main" id="{D2653AAC-6138-4BCE-9DEB-721BECFAC5CD}"/>
               </a:ext>
             </a:extLst>
           </p:cNvPr>
@@ -6959,68 +6959,65 @@
         </p:nvSpPr>
         <p:spPr>
           <a:xfrm xmlns:a="http://schemas.openxmlformats.org/drawingml/2006/main">
-            <a:off x="868680" y="26064000"/>
-            <a:ext cx="20078640" cy="648000"/>
+            <a:off x="868680" y="26460000"/>
+            <a:ext cx="712800" cy="712800"/>
           </a:xfrm>
-          <a:prstGeom xmlns:a="http://schemas.openxmlformats.org/drawingml/2006/main" prst="rect">
-            <a:avLst/>
-          </a:prstGeom>
-          <a:noFill xmlns:a="http://schemas.openxmlformats.org/drawingml/2006/main"/>
+          <a:prstGeom xmlns:a="http://schemas.openxmlformats.org/drawingml/2006/main" prst="ellipse">
+            <a:avLst/>
+          </a:prstGeom>
+          <a:solidFill xmlns:a="http://schemas.openxmlformats.org/drawingml/2006/main">
+            <a:srgbClr val="C9971C"/>
+          </a:solidFill>
           <a:ln xmlns:a="http://schemas.openxmlformats.org/drawingml/2006/main" w="0">
             <a:noFill/>
+            <a:prstDash val="solid"/>
           </a:ln>
         </p:spPr>
         <p:txBody>
-          <a:bodyPr xmlns:a="http://schemas.openxmlformats.org/drawingml/2006/main" wrap="square" lIns="0" tIns="0" rIns="0" bIns="0" anchor="t">
-            <a:noAutofit/>
-          </a:bodyPr>
+          <a:bodyPr xmlns:a="http://schemas.openxmlformats.org/drawingml/2006/main" lIns="0" tIns="0" rIns="0" bIns="0" anchor="ctr"/>
           <a:lstStyle xmlns:a="http://schemas.openxmlformats.org/drawingml/2006/main">
-            <a:defPPr algn="l">
-              <a:defRPr sz="2050" b="0" i="1">
-                <a:solidFill>
-                  <a:srgbClr val="56615B"/>
-                </a:solidFill>
-                <a:latin typeface="Calibri"/>
-                <a:ea typeface="Calibri"/>
-                <a:cs typeface="Calibri"/>
+            <a:defPPr algn="ctr">
+              <a:defRPr sz="3700" b="1">
+                <a:solidFill>
+                  <a:srgbClr val="FFFFFF"/>
+                </a:solidFill>
+                <a:latin typeface="Cambria"/>
+                <a:ea typeface="Cambria"/>
+                <a:cs typeface="Cambria"/>
               </a:defRPr>
             </a:defPPr>
           </a:lstStyle>
           <a:p xmlns:a="http://schemas.openxmlformats.org/drawingml/2006/main">
-            <a:pPr algn="l">
-              <a:lnSpc>
-                <a:spcPct val="108000"/>
-              </a:lnSpc>
-              <a:buNone/>
-              <a:defRPr sz="2050" b="0" i="1">
-                <a:solidFill>
-                  <a:srgbClr val="56615B"/>
-                </a:solidFill>
-                <a:latin typeface="Calibri"/>
-                <a:ea typeface="Calibri"/>
-                <a:cs typeface="Calibri"/>
-              </a:defRPr>
-            </a:pPr>
-            <a:r>
-              <a:rPr sz="2050" b="0" i="1">
-                <a:solidFill>
-                  <a:srgbClr val="56615B"/>
-                </a:solidFill>
-                <a:latin typeface="Calibri"/>
-                <a:ea typeface="Calibri"/>
-                <a:cs typeface="Calibri"/>
-              </a:rPr>
-              <a:t>Means pool 9 debates per model/level and 45 party scores per metric. One common GPT-6 Luna judge rates public evidence. Scores within a debate are dependent, and automated ratings lack human validation. These baseline runs do not establish adversarial robustness.</a:t>
+            <a:pPr algn="ctr">
+              <a:defRPr sz="3700" b="1">
+                <a:solidFill>
+                  <a:srgbClr val="FFFFFF"/>
+                </a:solidFill>
+                <a:latin typeface="Cambria"/>
+                <a:ea typeface="Cambria"/>
+                <a:cs typeface="Cambria"/>
+              </a:defRPr>
+            </a:pPr>
+            <a:r>
+              <a:rPr sz="3700" b="1">
+                <a:solidFill>
+                  <a:srgbClr val="FFFFFF"/>
+                </a:solidFill>
+                <a:latin typeface="Cambria"/>
+                <a:ea typeface="Cambria"/>
+                <a:cs typeface="Cambria"/>
+              </a:rPr>
+              <a:t>4</a:t>
             </a:r>
           </a:p>
         </p:txBody>
       </p:sp>
       <p:sp>
         <p:nvSpPr>
-          <p:cNvPr id="72" name="Section 4 number">
+          <p:cNvPr id="72" name="Section 4 title">
             <a:extLst xmlns:a="http://schemas.openxmlformats.org/drawingml/2006/main">
               <a:ext uri="{FF2B5EF4-FFF2-40B4-BE49-F238E27FC236}">
-                <a16:creationId xmlns:a16="http://schemas.microsoft.com/office/drawing/2014/main" id="{C1CF547C-E239-4319-8169-F6D712B9F2FF}"/>
+                <a16:creationId xmlns:a16="http://schemas.microsoft.com/office/drawing/2014/main" id="{0754824F-5702-4660-9CC7-B285D8151A1E}"/>
               </a:ext>
             </a:extLst>
           </p:cNvPr>
@@ -7031,27 +7028,26 @@
         </p:nvSpPr>
         <p:spPr>
           <a:xfrm xmlns:a="http://schemas.openxmlformats.org/drawingml/2006/main">
-            <a:off x="868680" y="26748000"/>
-            <a:ext cx="712800" cy="712800"/>
+            <a:off x="1836000" y="26406000"/>
+            <a:ext cx="19080000" cy="900000"/>
           </a:xfrm>
-          <a:prstGeom xmlns:a="http://schemas.openxmlformats.org/drawingml/2006/main" prst="ellipse">
-            <a:avLst/>
-          </a:prstGeom>
-          <a:solidFill xmlns:a="http://schemas.openxmlformats.org/drawingml/2006/main">
-            <a:srgbClr val="C9971C"/>
-          </a:solidFill>
+          <a:prstGeom xmlns:a="http://schemas.openxmlformats.org/drawingml/2006/main" prst="rect">
+            <a:avLst/>
+          </a:prstGeom>
+          <a:noFill xmlns:a="http://schemas.openxmlformats.org/drawingml/2006/main"/>
           <a:ln xmlns:a="http://schemas.openxmlformats.org/drawingml/2006/main" w="0">
             <a:noFill/>
-            <a:prstDash val="solid"/>
           </a:ln>
         </p:spPr>
         <p:txBody>
-          <a:bodyPr xmlns:a="http://schemas.openxmlformats.org/drawingml/2006/main" lIns="0" tIns="0" rIns="0" bIns="0" anchor="ctr"/>
+          <a:bodyPr xmlns:a="http://schemas.openxmlformats.org/drawingml/2006/main" wrap="square" lIns="0" tIns="0" rIns="0" bIns="0" anchor="t">
+            <a:noAutofit/>
+          </a:bodyPr>
           <a:lstStyle xmlns:a="http://schemas.openxmlformats.org/drawingml/2006/main">
-            <a:defPPr algn="ctr">
-              <a:defRPr sz="3700" b="1">
-                <a:solidFill>
-                  <a:srgbClr val="FFFFFF"/>
+            <a:defPPr algn="l">
+              <a:defRPr sz="5300" b="1" i="0">
+                <a:solidFill>
+                  <a:srgbClr val="1F4D36"/>
                 </a:solidFill>
                 <a:latin typeface="Cambria"/>
                 <a:ea typeface="Cambria"/>
@@ -7060,36 +7056,40 @@
             </a:defPPr>
           </a:lstStyle>
           <a:p xmlns:a="http://schemas.openxmlformats.org/drawingml/2006/main">
-            <a:pPr algn="ctr">
-              <a:defRPr sz="3700" b="1">
-                <a:solidFill>
-                  <a:srgbClr val="FFFFFF"/>
-                </a:solidFill>
-                <a:latin typeface="Cambria"/>
-                <a:ea typeface="Cambria"/>
-                <a:cs typeface="Cambria"/>
-              </a:defRPr>
-            </a:pPr>
-            <a:r>
-              <a:rPr sz="3700" b="1">
-                <a:solidFill>
-                  <a:srgbClr val="FFFFFF"/>
-                </a:solidFill>
-                <a:latin typeface="Cambria"/>
-                <a:ea typeface="Cambria"/>
-                <a:cs typeface="Cambria"/>
-              </a:rPr>
-              <a:t>4</a:t>
+            <a:pPr algn="l">
+              <a:lnSpc>
+                <a:spcPct val="108000"/>
+              </a:lnSpc>
+              <a:buNone/>
+              <a:defRPr sz="5300" b="1" i="0">
+                <a:solidFill>
+                  <a:srgbClr val="1F4D36"/>
+                </a:solidFill>
+                <a:latin typeface="Cambria"/>
+                <a:ea typeface="Cambria"/>
+                <a:cs typeface="Cambria"/>
+              </a:defRPr>
+            </a:pPr>
+            <a:r>
+              <a:rPr sz="5300" b="1" i="0">
+                <a:solidFill>
+                  <a:srgbClr val="1F4D36"/>
+                </a:solidFill>
+                <a:latin typeface="Cambria"/>
+                <a:ea typeface="Cambria"/>
+                <a:cs typeface="Cambria"/>
+              </a:rPr>
+              <a:t>Outcomes and next steps</a:t>
             </a:r>
           </a:p>
         </p:txBody>
       </p:sp>
       <p:sp>
         <p:nvSpPr>
-          <p:cNvPr id="73" name="Section 4 title">
+          <p:cNvPr id="73" name="Outcome detail">
             <a:extLst xmlns:a="http://schemas.openxmlformats.org/drawingml/2006/main">
               <a:ext uri="{FF2B5EF4-FFF2-40B4-BE49-F238E27FC236}">
-                <a16:creationId xmlns:a16="http://schemas.microsoft.com/office/drawing/2014/main" id="{7C58809D-3E8B-4192-BAD6-15BD6076B042}"/>
+                <a16:creationId xmlns:a16="http://schemas.microsoft.com/office/drawing/2014/main" id="{5D319FEF-C9B1-4BFE-A8CF-178FD9C0FA8E}"/>
               </a:ext>
             </a:extLst>
           </p:cNvPr>
@@ -7100,8 +7100,8 @@
         </p:nvSpPr>
         <p:spPr>
           <a:xfrm xmlns:a="http://schemas.openxmlformats.org/drawingml/2006/main">
-            <a:off x="1836000" y="26694000"/>
-            <a:ext cx="19080000" cy="900000"/>
+            <a:off x="868680" y="27432000"/>
+            <a:ext cx="6408000" cy="1368000"/>
           </a:xfrm>
           <a:prstGeom xmlns:a="http://schemas.openxmlformats.org/drawingml/2006/main" prst="rect">
             <a:avLst/>
@@ -7117,13 +7117,13 @@
           </a:bodyPr>
           <a:lstStyle xmlns:a="http://schemas.openxmlformats.org/drawingml/2006/main">
             <a:defPPr algn="l">
-              <a:defRPr sz="5300" b="1" i="0">
-                <a:solidFill>
-                  <a:srgbClr val="1F4D36"/>
-                </a:solidFill>
-                <a:latin typeface="Cambria"/>
-                <a:ea typeface="Cambria"/>
-                <a:cs typeface="Cambria"/>
+              <a:defRPr sz="2150" b="0" i="0">
+                <a:solidFill>
+                  <a:srgbClr val="1F2A24"/>
+                </a:solidFill>
+                <a:latin typeface="Calibri"/>
+                <a:ea typeface="Calibri"/>
+                <a:cs typeface="Calibri"/>
               </a:defRPr>
             </a:defPPr>
           </a:lstStyle>
@@ -7133,35 +7133,46 @@
                 <a:spcPct val="108000"/>
               </a:lnSpc>
               <a:buNone/>
-              <a:defRPr sz="5300" b="1" i="0">
-                <a:solidFill>
-                  <a:srgbClr val="1F4D36"/>
-                </a:solidFill>
-                <a:latin typeface="Cambria"/>
-                <a:ea typeface="Cambria"/>
-                <a:cs typeface="Cambria"/>
-              </a:defRPr>
-            </a:pPr>
-            <a:r>
-              <a:rPr sz="5300" b="1" i="0">
-                <a:solidFill>
-                  <a:srgbClr val="1F4D36"/>
-                </a:solidFill>
-                <a:latin typeface="Cambria"/>
-                <a:ea typeface="Cambria"/>
-                <a:cs typeface="Cambria"/>
-              </a:rPr>
-              <a:t>Outcomes and next steps</a:t>
+              <a:defRPr sz="2150" b="0" i="0">
+                <a:solidFill>
+                  <a:srgbClr val="1F2A24"/>
+                </a:solidFill>
+                <a:latin typeface="Calibri"/>
+                <a:ea typeface="Calibri"/>
+                <a:cs typeface="Calibri"/>
+              </a:defRPr>
+            </a:pPr>
+            <a:r>
+              <a:rPr sz="2150" b="1" i="0">
+                <a:solidFill>
+                  <a:srgbClr val="1F2A24"/>
+                </a:solidFill>
+                <a:latin typeface="Calibri"/>
+                <a:ea typeface="Calibri"/>
+                <a:cs typeface="Calibri"/>
+              </a:rPr>
+              <a:t>Platform:</a:t>
+            </a:r>
+            <a:r>
+              <a:rPr sz="2150" b="0" i="0">
+                <a:solidFill>
+                  <a:srgbClr val="1F2A24"/>
+                </a:solidFill>
+                <a:latin typeface="Calibri"/>
+                <a:ea typeface="Calibri"/>
+                <a:cs typeface="Calibri"/>
+              </a:rPr>
+              <a:t> Private personas, hidden tactics and frozen settings support reproducible comparisons. Extra Hansard showed no consistent score gain in the baseline study.</a:t>
             </a:r>
           </a:p>
         </p:txBody>
       </p:sp>
       <p:sp>
         <p:nvSpPr>
-          <p:cNvPr id="74" name="Outcome detail">
+          <p:cNvPr id="74" name="Next work detail">
             <a:extLst xmlns:a="http://schemas.openxmlformats.org/drawingml/2006/main">
               <a:ext uri="{FF2B5EF4-FFF2-40B4-BE49-F238E27FC236}">
-                <a16:creationId xmlns:a16="http://schemas.microsoft.com/office/drawing/2014/main" id="{0789E644-5445-419C-99D5-3EBBFF0B1994}"/>
+                <a16:creationId xmlns:a16="http://schemas.microsoft.com/office/drawing/2014/main" id="{1BF58020-9565-4E77-ACBD-CF17AECE9890}"/>
               </a:ext>
             </a:extLst>
           </p:cNvPr>
@@ -7172,8 +7183,8 @@
         </p:nvSpPr>
         <p:spPr>
           <a:xfrm xmlns:a="http://schemas.openxmlformats.org/drawingml/2006/main">
-            <a:off x="868680" y="27702000"/>
-            <a:ext cx="6408000" cy="1368000"/>
+            <a:off x="7776000" y="27432000"/>
+            <a:ext cx="6300000" cy="1368000"/>
           </a:xfrm>
           <a:prstGeom xmlns:a="http://schemas.openxmlformats.org/drawingml/2006/main" prst="rect">
             <a:avLst/>
@@ -7223,7 +7234,7 @@
                 <a:ea typeface="Calibri"/>
                 <a:cs typeface="Calibri"/>
               </a:rPr>
-              <a:t>Platform:</a:t>
+              <a:t>Next:</a:t>
             </a:r>
             <a:r>
               <a:rPr sz="2150" b="0" i="0">
@@ -7234,17 +7245,17 @@
                 <a:ea typeface="Calibri"/>
                 <a:cs typeface="Calibri"/>
               </a:rPr>
-              <a:t> Private personas, hidden tactics and frozen settings support reproducible comparisons. Extra Hansard showed no consistent score gain in the baseline study.</a:t>
+              <a:t> Test each hidden tactic against cooperative baselines. Expand topics and repetitions, and use human reviewers to assess disruption, reasoning and concessions.</a:t>
             </a:r>
           </a:p>
         </p:txBody>
       </p:sp>
       <p:sp>
         <p:nvSpPr>
-          <p:cNvPr id="75" name="Next work detail">
+          <p:cNvPr id="75" name="Contributions detail">
             <a:extLst xmlns:a="http://schemas.openxmlformats.org/drawingml/2006/main">
               <a:ext uri="{FF2B5EF4-FFF2-40B4-BE49-F238E27FC236}">
-                <a16:creationId xmlns:a16="http://schemas.microsoft.com/office/drawing/2014/main" id="{9618485B-AF9F-4985-88C2-EC2ED549DB40}"/>
+                <a16:creationId xmlns:a16="http://schemas.microsoft.com/office/drawing/2014/main" id="{4932C4E2-E64C-4A9E-A604-6FED278C103D}"/>
               </a:ext>
             </a:extLst>
           </p:cNvPr>
@@ -7255,8 +7266,8 @@
         </p:nvSpPr>
         <p:spPr>
           <a:xfrm xmlns:a="http://schemas.openxmlformats.org/drawingml/2006/main">
-            <a:off x="7776000" y="27702000"/>
-            <a:ext cx="6300000" cy="1368000"/>
+            <a:off x="14580000" y="27432000"/>
+            <a:ext cx="6372000" cy="1368000"/>
           </a:xfrm>
           <a:prstGeom xmlns:a="http://schemas.openxmlformats.org/drawingml/2006/main" prst="rect">
             <a:avLst/>
@@ -7306,7 +7317,7 @@
                 <a:ea typeface="Calibri"/>
                 <a:cs typeface="Calibri"/>
               </a:rPr>
-              <a:t>Next:</a:t>
+              <a:t>Albert Sun:</a:t>
             </a:r>
             <a:r>
               <a:rPr sz="2150" b="0" i="0">
@@ -7317,17 +7328,109 @@
                 <a:ea typeface="Calibri"/>
                 <a:cs typeface="Calibri"/>
               </a:rPr>
-              <a:t> Test each hidden tactic against cooperative baselines. Expand topics and repetitions, and use human reviewers to assess disruption, reasoning and concessions.</a:t>
+              <a:t> frontend, live chamber,</a:t>
+            </a:r>
+          </a:p>
+          <a:p xmlns:a="http://schemas.openxmlformats.org/drawingml/2006/main">
+            <a:pPr algn="l">
+              <a:lnSpc>
+                <a:spcPct val="108000"/>
+              </a:lnSpc>
+              <a:buNone/>
+              <a:defRPr sz="2150" b="0" i="0">
+                <a:solidFill>
+                  <a:srgbClr val="1F2A24"/>
+                </a:solidFill>
+                <a:latin typeface="Calibri"/>
+                <a:ea typeface="Calibri"/>
+                <a:cs typeface="Calibri"/>
+              </a:defRPr>
+            </a:pPr>
+            <a:r>
+              <a:rPr sz="2150" b="0" i="0">
+                <a:solidFill>
+                  <a:srgbClr val="1F2A24"/>
+                </a:solidFill>
+                <a:latin typeface="Calibri"/>
+                <a:ea typeface="Calibri"/>
+                <a:cs typeface="Calibri"/>
+              </a:rPr>
+              <a:t>initial CLI and Hansard grounding.</a:t>
+            </a:r>
+          </a:p>
+          <a:p xmlns:a="http://schemas.openxmlformats.org/drawingml/2006/main">
+            <a:pPr algn="l">
+              <a:lnSpc>
+                <a:spcPct val="108000"/>
+              </a:lnSpc>
+              <a:buNone/>
+              <a:defRPr sz="2150" b="0" i="0">
+                <a:solidFill>
+                  <a:srgbClr val="1F2A24"/>
+                </a:solidFill>
+                <a:latin typeface="Calibri"/>
+                <a:ea typeface="Calibri"/>
+                <a:cs typeface="Calibri"/>
+              </a:defRPr>
+            </a:pPr>
+            <a:r>
+              <a:rPr sz="2150" b="1" i="0">
+                <a:solidFill>
+                  <a:srgbClr val="1F2A24"/>
+                </a:solidFill>
+                <a:latin typeface="Calibri"/>
+                <a:ea typeface="Calibri"/>
+                <a:cs typeface="Calibri"/>
+              </a:rPr>
+              <a:t>Kieran Joe:</a:t>
+            </a:r>
+            <a:r>
+              <a:rPr sz="2150" b="0" i="0">
+                <a:solidFill>
+                  <a:srgbClr val="1F2A24"/>
+                </a:solidFill>
+                <a:latin typeface="Calibri"/>
+                <a:ea typeface="Calibri"/>
+                <a:cs typeface="Calibri"/>
+              </a:rPr>
+              <a:t> architecture, agent engine</a:t>
+            </a:r>
+          </a:p>
+          <a:p xmlns:a="http://schemas.openxmlformats.org/drawingml/2006/main">
+            <a:pPr algn="l">
+              <a:lnSpc>
+                <a:spcPct val="108000"/>
+              </a:lnSpc>
+              <a:buNone/>
+              <a:defRPr sz="2150" b="0" i="0">
+                <a:solidFill>
+                  <a:srgbClr val="1F2A24"/>
+                </a:solidFill>
+                <a:latin typeface="Calibri"/>
+                <a:ea typeface="Calibri"/>
+                <a:cs typeface="Calibri"/>
+              </a:defRPr>
+            </a:pPr>
+            <a:r>
+              <a:rPr sz="2150" b="0" i="0">
+                <a:solidFill>
+                  <a:srgbClr val="1F2A24"/>
+                </a:solidFill>
+                <a:latin typeface="Calibri"/>
+                <a:ea typeface="Calibri"/>
+                <a:cs typeface="Calibri"/>
+              </a:rPr>
+              <a:t>and supervisor coordination.</a:t>
             </a:r>
           </a:p>
         </p:txBody>
       </p:sp>
       <p:sp>
         <p:nvSpPr>
-          <p:cNvPr id="76" name="Contributions detail">
+          <p:cNvPr id="76" name="Footer band">
             <a:extLst xmlns:a="http://schemas.openxmlformats.org/drawingml/2006/main">
               <a:ext uri="{FF2B5EF4-FFF2-40B4-BE49-F238E27FC236}">
-                <a16:creationId xmlns:a16="http://schemas.microsoft.com/office/drawing/2014/main" id="{B4867992-9A5F-43E3-9105-9A8CE227D15B}"/>
+                <a16:creationId xmlns:a16="http://schemas.microsoft.com/office/drawing/2014/main" id="{460408DA-9D7D-4A65-AA1D-C2B6870DE9F9}"/>
               </a:ext>
             </a:extLst>
           </p:cNvPr>
@@ -7338,171 +7441,27 @@
         </p:nvSpPr>
         <p:spPr>
           <a:xfrm xmlns:a="http://schemas.openxmlformats.org/drawingml/2006/main">
-            <a:off x="14580000" y="27702000"/>
-            <a:ext cx="6372000" cy="1368000"/>
+            <a:off x="0" y="29124000"/>
+            <a:ext cx="21816000" cy="1584000"/>
           </a:xfrm>
           <a:prstGeom xmlns:a="http://schemas.openxmlformats.org/drawingml/2006/main" prst="rect">
             <a:avLst/>
           </a:prstGeom>
-          <a:noFill xmlns:a="http://schemas.openxmlformats.org/drawingml/2006/main"/>
+          <a:solidFill xmlns:a="http://schemas.openxmlformats.org/drawingml/2006/main">
+            <a:srgbClr val="E8E2D4"/>
+          </a:solidFill>
           <a:ln xmlns:a="http://schemas.openxmlformats.org/drawingml/2006/main" w="0">
             <a:noFill/>
+            <a:prstDash val="solid"/>
           </a:ln>
         </p:spPr>
-        <p:txBody>
-          <a:bodyPr xmlns:a="http://schemas.openxmlformats.org/drawingml/2006/main" wrap="square" lIns="0" tIns="0" rIns="0" bIns="0" anchor="t">
-            <a:noAutofit/>
-          </a:bodyPr>
-          <a:lstStyle xmlns:a="http://schemas.openxmlformats.org/drawingml/2006/main">
-            <a:defPPr algn="l">
-              <a:defRPr sz="2150" b="0" i="0">
-                <a:solidFill>
-                  <a:srgbClr val="1F2A24"/>
-                </a:solidFill>
-                <a:latin typeface="Calibri"/>
-                <a:ea typeface="Calibri"/>
-                <a:cs typeface="Calibri"/>
-              </a:defRPr>
-            </a:defPPr>
-          </a:lstStyle>
-          <a:p xmlns:a="http://schemas.openxmlformats.org/drawingml/2006/main">
-            <a:pPr algn="l">
-              <a:lnSpc>
-                <a:spcPct val="108000"/>
-              </a:lnSpc>
-              <a:buNone/>
-              <a:defRPr sz="2150" b="0" i="0">
-                <a:solidFill>
-                  <a:srgbClr val="1F2A24"/>
-                </a:solidFill>
-                <a:latin typeface="Calibri"/>
-                <a:ea typeface="Calibri"/>
-                <a:cs typeface="Calibri"/>
-              </a:defRPr>
-            </a:pPr>
-            <a:r>
-              <a:rPr sz="2150" b="1" i="0">
-                <a:solidFill>
-                  <a:srgbClr val="1F2A24"/>
-                </a:solidFill>
-                <a:latin typeface="Calibri"/>
-                <a:ea typeface="Calibri"/>
-                <a:cs typeface="Calibri"/>
-              </a:rPr>
-              <a:t>Albert Sun:</a:t>
-            </a:r>
-            <a:r>
-              <a:rPr sz="2150" b="0" i="0">
-                <a:solidFill>
-                  <a:srgbClr val="1F2A24"/>
-                </a:solidFill>
-                <a:latin typeface="Calibri"/>
-                <a:ea typeface="Calibri"/>
-                <a:cs typeface="Calibri"/>
-              </a:rPr>
-              <a:t> frontend, live chamber,</a:t>
-            </a:r>
-          </a:p>
-          <a:p xmlns:a="http://schemas.openxmlformats.org/drawingml/2006/main">
-            <a:pPr algn="l">
-              <a:lnSpc>
-                <a:spcPct val="108000"/>
-              </a:lnSpc>
-              <a:buNone/>
-              <a:defRPr sz="2150" b="0" i="0">
-                <a:solidFill>
-                  <a:srgbClr val="1F2A24"/>
-                </a:solidFill>
-                <a:latin typeface="Calibri"/>
-                <a:ea typeface="Calibri"/>
-                <a:cs typeface="Calibri"/>
-              </a:defRPr>
-            </a:pPr>
-            <a:r>
-              <a:rPr sz="2150" b="0" i="0">
-                <a:solidFill>
-                  <a:srgbClr val="1F2A24"/>
-                </a:solidFill>
-                <a:latin typeface="Calibri"/>
-                <a:ea typeface="Calibri"/>
-                <a:cs typeface="Calibri"/>
-              </a:rPr>
-              <a:t>initial CLI and Hansard grounding.</a:t>
-            </a:r>
-          </a:p>
-          <a:p xmlns:a="http://schemas.openxmlformats.org/drawingml/2006/main">
-            <a:pPr algn="l">
-              <a:lnSpc>
-                <a:spcPct val="108000"/>
-              </a:lnSpc>
-              <a:buNone/>
-              <a:defRPr sz="2150" b="0" i="0">
-                <a:solidFill>
-                  <a:srgbClr val="1F2A24"/>
-                </a:solidFill>
-                <a:latin typeface="Calibri"/>
-                <a:ea typeface="Calibri"/>
-                <a:cs typeface="Calibri"/>
-              </a:defRPr>
-            </a:pPr>
-            <a:r>
-              <a:rPr sz="2150" b="1" i="0">
-                <a:solidFill>
-                  <a:srgbClr val="1F2A24"/>
-                </a:solidFill>
-                <a:latin typeface="Calibri"/>
-                <a:ea typeface="Calibri"/>
-                <a:cs typeface="Calibri"/>
-              </a:rPr>
-              <a:t>Kieran Joe:</a:t>
-            </a:r>
-            <a:r>
-              <a:rPr sz="2150" b="0" i="0">
-                <a:solidFill>
-                  <a:srgbClr val="1F2A24"/>
-                </a:solidFill>
-                <a:latin typeface="Calibri"/>
-                <a:ea typeface="Calibri"/>
-                <a:cs typeface="Calibri"/>
-              </a:rPr>
-              <a:t> architecture, agent engine</a:t>
-            </a:r>
-          </a:p>
-          <a:p xmlns:a="http://schemas.openxmlformats.org/drawingml/2006/main">
-            <a:pPr algn="l">
-              <a:lnSpc>
-                <a:spcPct val="108000"/>
-              </a:lnSpc>
-              <a:buNone/>
-              <a:defRPr sz="2150" b="0" i="0">
-                <a:solidFill>
-                  <a:srgbClr val="1F2A24"/>
-                </a:solidFill>
-                <a:latin typeface="Calibri"/>
-                <a:ea typeface="Calibri"/>
-                <a:cs typeface="Calibri"/>
-              </a:defRPr>
-            </a:pPr>
-            <a:r>
-              <a:rPr sz="2150" b="0" i="0">
-                <a:solidFill>
-                  <a:srgbClr val="1F2A24"/>
-                </a:solidFill>
-                <a:latin typeface="Calibri"/>
-                <a:ea typeface="Calibri"/>
-                <a:cs typeface="Calibri"/>
-              </a:rPr>
-              <a:t>and supervisor coordination.</a:t>
-            </a:r>
-          </a:p>
-        </p:txBody>
       </p:sp>
       <p:sp>
         <p:nvSpPr>
-          <p:cNvPr id="77" name="Footer band">
+          <p:cNvPr id="77" name="References heading">
             <a:extLst xmlns:a="http://schemas.openxmlformats.org/drawingml/2006/main">
               <a:ext uri="{FF2B5EF4-FFF2-40B4-BE49-F238E27FC236}">
-                <a16:creationId xmlns:a16="http://schemas.microsoft.com/office/drawing/2014/main" id="{3A0D5A9B-70A6-4B75-AEAA-DE6078C8264E}"/>
+                <a16:creationId xmlns:a16="http://schemas.microsoft.com/office/drawing/2014/main" id="{80DE88A3-DA94-45F4-BA33-F74FBC7A1CF3}"/>
               </a:ext>
             </a:extLst>
           </p:cNvPr>
@@ -7513,27 +7472,68 @@
         </p:nvSpPr>
         <p:spPr>
           <a:xfrm xmlns:a="http://schemas.openxmlformats.org/drawingml/2006/main">
-            <a:off x="0" y="29124000"/>
-            <a:ext cx="21816000" cy="1584000"/>
+            <a:off x="868680" y="29412000"/>
+            <a:ext cx="8424000" cy="360000"/>
           </a:xfrm>
           <a:prstGeom xmlns:a="http://schemas.openxmlformats.org/drawingml/2006/main" prst="rect">
             <a:avLst/>
           </a:prstGeom>
-          <a:solidFill xmlns:a="http://schemas.openxmlformats.org/drawingml/2006/main">
-            <a:srgbClr val="E8E2D4"/>
-          </a:solidFill>
+          <a:noFill xmlns:a="http://schemas.openxmlformats.org/drawingml/2006/main"/>
           <a:ln xmlns:a="http://schemas.openxmlformats.org/drawingml/2006/main" w="0">
             <a:noFill/>
-            <a:prstDash val="solid"/>
           </a:ln>
         </p:spPr>
+        <p:txBody>
+          <a:bodyPr xmlns:a="http://schemas.openxmlformats.org/drawingml/2006/main" wrap="square" lIns="0" tIns="0" rIns="0" bIns="0" anchor="t">
+            <a:noAutofit/>
+          </a:bodyPr>
+          <a:lstStyle xmlns:a="http://schemas.openxmlformats.org/drawingml/2006/main">
+            <a:defPPr algn="l">
+              <a:defRPr sz="2200" b="1" i="0">
+                <a:solidFill>
+                  <a:srgbClr val="1F4D36"/>
+                </a:solidFill>
+                <a:latin typeface="Calibri"/>
+                <a:ea typeface="Calibri"/>
+                <a:cs typeface="Calibri"/>
+              </a:defRPr>
+            </a:defPPr>
+          </a:lstStyle>
+          <a:p xmlns:a="http://schemas.openxmlformats.org/drawingml/2006/main">
+            <a:pPr algn="l">
+              <a:lnSpc>
+                <a:spcPct val="108000"/>
+              </a:lnSpc>
+              <a:buNone/>
+              <a:defRPr sz="2200" b="1" i="0">
+                <a:solidFill>
+                  <a:srgbClr val="1F4D36"/>
+                </a:solidFill>
+                <a:latin typeface="Calibri"/>
+                <a:ea typeface="Calibri"/>
+                <a:cs typeface="Calibri"/>
+              </a:defRPr>
+            </a:pPr>
+            <a:r>
+              <a:rPr sz="2200" b="1" i="0">
+                <a:solidFill>
+                  <a:srgbClr val="1F4D36"/>
+                </a:solidFill>
+                <a:latin typeface="Calibri"/>
+                <a:ea typeface="Calibri"/>
+                <a:cs typeface="Calibri"/>
+              </a:rPr>
+              <a:t>References</a:t>
+            </a:r>
+          </a:p>
+        </p:txBody>
       </p:sp>
       <p:sp>
         <p:nvSpPr>
-          <p:cNvPr id="78" name="References heading">
+          <p:cNvPr id="78" name="References detail">
             <a:extLst xmlns:a="http://schemas.openxmlformats.org/drawingml/2006/main">
               <a:ext uri="{FF2B5EF4-FFF2-40B4-BE49-F238E27FC236}">
-                <a16:creationId xmlns:a16="http://schemas.microsoft.com/office/drawing/2014/main" id="{6AE62420-C6B4-414C-B8B1-A9C6DB525531}"/>
+                <a16:creationId xmlns:a16="http://schemas.microsoft.com/office/drawing/2014/main" id="{FAF6418A-7FDF-4F88-A891-ADCED6CBBBEA}"/>
               </a:ext>
             </a:extLst>
           </p:cNvPr>
@@ -7544,8 +7544,8 @@
         </p:nvSpPr>
         <p:spPr>
           <a:xfrm xmlns:a="http://schemas.openxmlformats.org/drawingml/2006/main">
-            <a:off x="868680" y="29412000"/>
-            <a:ext cx="8424000" cy="360000"/>
+            <a:off x="868680" y="29844000"/>
+            <a:ext cx="8424000" cy="612000"/>
           </a:xfrm>
           <a:prstGeom xmlns:a="http://schemas.openxmlformats.org/drawingml/2006/main" prst="rect">
             <a:avLst/>
@@ -7561,9 +7561,9 @@
           </a:bodyPr>
           <a:lstStyle xmlns:a="http://schemas.openxmlformats.org/drawingml/2006/main">
             <a:defPPr algn="l">
-              <a:defRPr sz="2200" b="1" i="0">
-                <a:solidFill>
-                  <a:srgbClr val="1F4D36"/>
+              <a:defRPr sz="2000" b="0" i="0">
+                <a:solidFill>
+                  <a:srgbClr val="1F2A24"/>
                 </a:solidFill>
                 <a:latin typeface="Calibri"/>
                 <a:ea typeface="Calibri"/>
@@ -7577,35 +7577,62 @@
                 <a:spcPct val="108000"/>
               </a:lnSpc>
               <a:buNone/>
-              <a:defRPr sz="2200" b="1" i="0">
-                <a:solidFill>
-                  <a:srgbClr val="1F4D36"/>
-                </a:solidFill>
-                <a:latin typeface="Calibri"/>
-                <a:ea typeface="Calibri"/>
-                <a:cs typeface="Calibri"/>
-              </a:defRPr>
-            </a:pPr>
-            <a:r>
-              <a:rPr sz="2200" b="1" i="0">
-                <a:solidFill>
-                  <a:srgbClr val="1F4D36"/>
-                </a:solidFill>
-                <a:latin typeface="Calibri"/>
-                <a:ea typeface="Calibri"/>
-                <a:cs typeface="Calibri"/>
-              </a:rPr>
-              <a:t>References</a:t>
+              <a:defRPr sz="2000" b="0" i="0">
+                <a:solidFill>
+                  <a:srgbClr val="1F2A24"/>
+                </a:solidFill>
+                <a:latin typeface="Calibri"/>
+                <a:ea typeface="Calibri"/>
+                <a:cs typeface="Calibri"/>
+              </a:defRPr>
+            </a:pPr>
+            <a:r>
+              <a:rPr sz="2000" b="0" i="0">
+                <a:solidFill>
+                  <a:srgbClr val="1F2A24"/>
+                </a:solidFill>
+                <a:latin typeface="Calibri"/>
+                <a:ea typeface="Calibri"/>
+                <a:cs typeface="Calibri"/>
+              </a:rPr>
+              <a:t>[1] Rauh &amp; Schwalbach (2020). ParlSpeech V2.</a:t>
+            </a:r>
+          </a:p>
+          <a:p xmlns:a="http://schemas.openxmlformats.org/drawingml/2006/main">
+            <a:pPr algn="l">
+              <a:lnSpc>
+                <a:spcPct val="108000"/>
+              </a:lnSpc>
+              <a:buNone/>
+              <a:defRPr sz="2000" b="0" i="0">
+                <a:solidFill>
+                  <a:srgbClr val="1F2A24"/>
+                </a:solidFill>
+                <a:latin typeface="Calibri"/>
+                <a:ea typeface="Calibri"/>
+                <a:cs typeface="Calibri"/>
+              </a:defRPr>
+            </a:pPr>
+            <a:r>
+              <a:rPr sz="2000" b="0" i="0">
+                <a:solidFill>
+                  <a:srgbClr val="1F2A24"/>
+                </a:solidFill>
+                <a:latin typeface="Calibri"/>
+                <a:ea typeface="Calibri"/>
+                <a:cs typeface="Calibri"/>
+              </a:rPr>
+              <a:t>[2] Project 123 debate evaluation study, October 2026.</a:t>
             </a:r>
           </a:p>
         </p:txBody>
       </p:sp>
       <p:sp>
         <p:nvSpPr>
-          <p:cNvPr id="79" name="References detail">
+          <p:cNvPr id="79" name="Acknowledgements heading">
             <a:extLst xmlns:a="http://schemas.openxmlformats.org/drawingml/2006/main">
               <a:ext uri="{FF2B5EF4-FFF2-40B4-BE49-F238E27FC236}">
-                <a16:creationId xmlns:a16="http://schemas.microsoft.com/office/drawing/2014/main" id="{0CE9E03F-C8AA-4E0B-9BB2-95B387C5247F}"/>
+                <a16:creationId xmlns:a16="http://schemas.microsoft.com/office/drawing/2014/main" id="{B5D991CC-E766-4A53-B848-A22EE8251278}"/>
               </a:ext>
             </a:extLst>
           </p:cNvPr>
@@ -7616,8 +7643,8 @@
         </p:nvSpPr>
         <p:spPr>
           <a:xfrm xmlns:a="http://schemas.openxmlformats.org/drawingml/2006/main">
-            <a:off x="868680" y="29844000"/>
-            <a:ext cx="8424000" cy="612000"/>
+            <a:off x="9828000" y="29412000"/>
+            <a:ext cx="6840000" cy="360000"/>
           </a:xfrm>
           <a:prstGeom xmlns:a="http://schemas.openxmlformats.org/drawingml/2006/main" prst="rect">
             <a:avLst/>
@@ -7633,9 +7660,9 @@
           </a:bodyPr>
           <a:lstStyle xmlns:a="http://schemas.openxmlformats.org/drawingml/2006/main">
             <a:defPPr algn="l">
-              <a:defRPr sz="2000" b="0" i="0">
-                <a:solidFill>
-                  <a:srgbClr val="1F2A24"/>
+              <a:defRPr sz="2200" b="1" i="0">
+                <a:solidFill>
+                  <a:srgbClr val="1F4D36"/>
                 </a:solidFill>
                 <a:latin typeface="Calibri"/>
                 <a:ea typeface="Calibri"/>
@@ -7649,62 +7676,35 @@
                 <a:spcPct val="108000"/>
               </a:lnSpc>
               <a:buNone/>
-              <a:defRPr sz="2000" b="0" i="0">
-                <a:solidFill>
-                  <a:srgbClr val="1F2A24"/>
-                </a:solidFill>
-                <a:latin typeface="Calibri"/>
-                <a:ea typeface="Calibri"/>
-                <a:cs typeface="Calibri"/>
-              </a:defRPr>
-            </a:pPr>
-            <a:r>
-              <a:rPr sz="2000" b="0" i="0">
-                <a:solidFill>
-                  <a:srgbClr val="1F2A24"/>
-                </a:solidFill>
-                <a:latin typeface="Calibri"/>
-                <a:ea typeface="Calibri"/>
-                <a:cs typeface="Calibri"/>
-              </a:rPr>
-              <a:t>[1] Rauh &amp; Schwalbach (2020). ParlSpeech V2.</a:t>
-            </a:r>
-          </a:p>
-          <a:p xmlns:a="http://schemas.openxmlformats.org/drawingml/2006/main">
-            <a:pPr algn="l">
-              <a:lnSpc>
-                <a:spcPct val="108000"/>
-              </a:lnSpc>
-              <a:buNone/>
-              <a:defRPr sz="2000" b="0" i="0">
-                <a:solidFill>
-                  <a:srgbClr val="1F2A24"/>
-                </a:solidFill>
-                <a:latin typeface="Calibri"/>
-                <a:ea typeface="Calibri"/>
-                <a:cs typeface="Calibri"/>
-              </a:defRPr>
-            </a:pPr>
-            <a:r>
-              <a:rPr sz="2000" b="0" i="0">
-                <a:solidFill>
-                  <a:srgbClr val="1F2A24"/>
-                </a:solidFill>
-                <a:latin typeface="Calibri"/>
-                <a:ea typeface="Calibri"/>
-                <a:cs typeface="Calibri"/>
-              </a:rPr>
-              <a:t>[2] Project 123 debate evaluation study, October 2026.</a:t>
+              <a:defRPr sz="2200" b="1" i="0">
+                <a:solidFill>
+                  <a:srgbClr val="1F4D36"/>
+                </a:solidFill>
+                <a:latin typeface="Calibri"/>
+                <a:ea typeface="Calibri"/>
+                <a:cs typeface="Calibri"/>
+              </a:defRPr>
+            </a:pPr>
+            <a:r>
+              <a:rPr sz="2200" b="1" i="0">
+                <a:solidFill>
+                  <a:srgbClr val="1F4D36"/>
+                </a:solidFill>
+                <a:latin typeface="Calibri"/>
+                <a:ea typeface="Calibri"/>
+                <a:cs typeface="Calibri"/>
+              </a:rPr>
+              <a:t>Acknowledgements</a:t>
             </a:r>
           </a:p>
         </p:txBody>
       </p:sp>
       <p:sp>
         <p:nvSpPr>
-          <p:cNvPr id="80" name="Acknowledgements heading">
+          <p:cNvPr id="80" name="Acknowledgements detail">
             <a:extLst xmlns:a="http://schemas.openxmlformats.org/drawingml/2006/main">
               <a:ext uri="{FF2B5EF4-FFF2-40B4-BE49-F238E27FC236}">
-                <a16:creationId xmlns:a16="http://schemas.microsoft.com/office/drawing/2014/main" id="{5CA85A20-7C9A-4A3E-A47E-9A0658007FA0}"/>
+                <a16:creationId xmlns:a16="http://schemas.microsoft.com/office/drawing/2014/main" id="{967B8CFD-4CBC-4A14-9F9A-10FECF49BC8D}"/>
               </a:ext>
             </a:extLst>
           </p:cNvPr>
@@ -7715,8 +7715,8 @@
         </p:nvSpPr>
         <p:spPr>
           <a:xfrm xmlns:a="http://schemas.openxmlformats.org/drawingml/2006/main">
-            <a:off x="9828000" y="29412000"/>
-            <a:ext cx="6840000" cy="360000"/>
+            <a:off x="9828000" y="29844000"/>
+            <a:ext cx="6840000" cy="612000"/>
           </a:xfrm>
           <a:prstGeom xmlns:a="http://schemas.openxmlformats.org/drawingml/2006/main" prst="rect">
             <a:avLst/>
@@ -7732,9 +7732,9 @@
           </a:bodyPr>
           <a:lstStyle xmlns:a="http://schemas.openxmlformats.org/drawingml/2006/main">
             <a:defPPr algn="l">
-              <a:defRPr sz="2200" b="1" i="0">
-                <a:solidFill>
-                  <a:srgbClr val="1F4D36"/>
+              <a:defRPr sz="2000" b="0" i="0">
+                <a:solidFill>
+                  <a:srgbClr val="1F2A24"/>
                 </a:solidFill>
                 <a:latin typeface="Calibri"/>
                 <a:ea typeface="Calibri"/>
@@ -7748,35 +7748,62 @@
                 <a:spcPct val="108000"/>
               </a:lnSpc>
               <a:buNone/>
-              <a:defRPr sz="2200" b="1" i="0">
-                <a:solidFill>
-                  <a:srgbClr val="1F4D36"/>
-                </a:solidFill>
-                <a:latin typeface="Calibri"/>
-                <a:ea typeface="Calibri"/>
-                <a:cs typeface="Calibri"/>
-              </a:defRPr>
-            </a:pPr>
-            <a:r>
-              <a:rPr sz="2200" b="1" i="0">
-                <a:solidFill>
-                  <a:srgbClr val="1F4D36"/>
-                </a:solidFill>
-                <a:latin typeface="Calibri"/>
-                <a:ea typeface="Calibri"/>
-                <a:cs typeface="Calibri"/>
-              </a:rPr>
-              <a:t>Acknowledgements</a:t>
+              <a:defRPr sz="2000" b="0" i="0">
+                <a:solidFill>
+                  <a:srgbClr val="1F2A24"/>
+                </a:solidFill>
+                <a:latin typeface="Calibri"/>
+                <a:ea typeface="Calibri"/>
+                <a:cs typeface="Calibri"/>
+              </a:defRPr>
+            </a:pPr>
+            <a:r>
+              <a:rPr sz="2000" b="0" i="0">
+                <a:solidFill>
+                  <a:srgbClr val="1F2A24"/>
+                </a:solidFill>
+                <a:latin typeface="Calibri"/>
+                <a:ea typeface="Calibri"/>
+                <a:cs typeface="Calibri"/>
+              </a:rPr>
+              <a:t>Political science collaborators, Georgetown University.</a:t>
+            </a:r>
+          </a:p>
+          <a:p xmlns:a="http://schemas.openxmlformats.org/drawingml/2006/main">
+            <a:pPr algn="l">
+              <a:lnSpc>
+                <a:spcPct val="108000"/>
+              </a:lnSpc>
+              <a:buNone/>
+              <a:defRPr sz="2000" b="0" i="0">
+                <a:solidFill>
+                  <a:srgbClr val="1F2A24"/>
+                </a:solidFill>
+                <a:latin typeface="Calibri"/>
+                <a:ea typeface="Calibri"/>
+                <a:cs typeface="Calibri"/>
+              </a:defRPr>
+            </a:pPr>
+            <a:r>
+              <a:rPr sz="2000" b="0" i="0">
+                <a:solidFill>
+                  <a:srgbClr val="1F2A24"/>
+                </a:solidFill>
+                <a:latin typeface="Calibri"/>
+                <a:ea typeface="Calibri"/>
+                <a:cs typeface="Calibri"/>
+              </a:rPr>
+              <a:t>Members are AI archetypes, not real MPs.</a:t>
             </a:r>
           </a:p>
         </p:txBody>
       </p:sp>
       <p:sp>
         <p:nvSpPr>
-          <p:cNvPr id="81" name="Acknowledgements detail">
+          <p:cNvPr id="81" name="Contact heading">
             <a:extLst xmlns:a="http://schemas.openxmlformats.org/drawingml/2006/main">
               <a:ext uri="{FF2B5EF4-FFF2-40B4-BE49-F238E27FC236}">
-                <a16:creationId xmlns:a16="http://schemas.microsoft.com/office/drawing/2014/main" id="{450C5C31-C1B7-4A9A-A545-1DDC123C6C09}"/>
+                <a16:creationId xmlns:a16="http://schemas.microsoft.com/office/drawing/2014/main" id="{B4F6B225-DE50-4203-8A08-E56A0D59C943}"/>
               </a:ext>
             </a:extLst>
           </p:cNvPr>
@@ -7787,8 +7814,8 @@
         </p:nvSpPr>
         <p:spPr>
           <a:xfrm xmlns:a="http://schemas.openxmlformats.org/drawingml/2006/main">
-            <a:off x="9828000" y="29844000"/>
-            <a:ext cx="6840000" cy="612000"/>
+            <a:off x="17064000" y="29412000"/>
+            <a:ext cx="3888000" cy="360000"/>
           </a:xfrm>
           <a:prstGeom xmlns:a="http://schemas.openxmlformats.org/drawingml/2006/main" prst="rect">
             <a:avLst/>
@@ -7804,9 +7831,9 @@
           </a:bodyPr>
           <a:lstStyle xmlns:a="http://schemas.openxmlformats.org/drawingml/2006/main">
             <a:defPPr algn="l">
-              <a:defRPr sz="2000" b="0" i="0">
-                <a:solidFill>
-                  <a:srgbClr val="1F2A24"/>
+              <a:defRPr sz="2200" b="1" i="0">
+                <a:solidFill>
+                  <a:srgbClr val="1F4D36"/>
                 </a:solidFill>
                 <a:latin typeface="Calibri"/>
                 <a:ea typeface="Calibri"/>
@@ -7820,62 +7847,35 @@
                 <a:spcPct val="108000"/>
               </a:lnSpc>
               <a:buNone/>
-              <a:defRPr sz="2000" b="0" i="0">
-                <a:solidFill>
-                  <a:srgbClr val="1F2A24"/>
-                </a:solidFill>
-                <a:latin typeface="Calibri"/>
-                <a:ea typeface="Calibri"/>
-                <a:cs typeface="Calibri"/>
-              </a:defRPr>
-            </a:pPr>
-            <a:r>
-              <a:rPr sz="2000" b="0" i="0">
-                <a:solidFill>
-                  <a:srgbClr val="1F2A24"/>
-                </a:solidFill>
-                <a:latin typeface="Calibri"/>
-                <a:ea typeface="Calibri"/>
-                <a:cs typeface="Calibri"/>
-              </a:rPr>
-              <a:t>Political science collaborators, Georgetown University.</a:t>
-            </a:r>
-          </a:p>
-          <a:p xmlns:a="http://schemas.openxmlformats.org/drawingml/2006/main">
-            <a:pPr algn="l">
-              <a:lnSpc>
-                <a:spcPct val="108000"/>
-              </a:lnSpc>
-              <a:buNone/>
-              <a:defRPr sz="2000" b="0" i="0">
-                <a:solidFill>
-                  <a:srgbClr val="1F2A24"/>
-                </a:solidFill>
-                <a:latin typeface="Calibri"/>
-                <a:ea typeface="Calibri"/>
-                <a:cs typeface="Calibri"/>
-              </a:defRPr>
-            </a:pPr>
-            <a:r>
-              <a:rPr sz="2000" b="0" i="0">
-                <a:solidFill>
-                  <a:srgbClr val="1F2A24"/>
-                </a:solidFill>
-                <a:latin typeface="Calibri"/>
-                <a:ea typeface="Calibri"/>
-                <a:cs typeface="Calibri"/>
-              </a:rPr>
-              <a:t>Members are AI archetypes, not real MPs.</a:t>
+              <a:defRPr sz="2200" b="1" i="0">
+                <a:solidFill>
+                  <a:srgbClr val="1F4D36"/>
+                </a:solidFill>
+                <a:latin typeface="Calibri"/>
+                <a:ea typeface="Calibri"/>
+                <a:cs typeface="Calibri"/>
+              </a:defRPr>
+            </a:pPr>
+            <a:r>
+              <a:rPr sz="2200" b="1" i="0">
+                <a:solidFill>
+                  <a:srgbClr val="1F4D36"/>
+                </a:solidFill>
+                <a:latin typeface="Calibri"/>
+                <a:ea typeface="Calibri"/>
+                <a:cs typeface="Calibri"/>
+              </a:rPr>
+              <a:t>Contact</a:t>
             </a:r>
           </a:p>
         </p:txBody>
       </p:sp>
       <p:sp>
         <p:nvSpPr>
-          <p:cNvPr id="82" name="Contact heading">
+          <p:cNvPr id="82" name="Contact detail">
             <a:extLst xmlns:a="http://schemas.openxmlformats.org/drawingml/2006/main">
               <a:ext uri="{FF2B5EF4-FFF2-40B4-BE49-F238E27FC236}">
-                <a16:creationId xmlns:a16="http://schemas.microsoft.com/office/drawing/2014/main" id="{828A6346-A416-4F0E-9272-4E038144FBCC}"/>
+                <a16:creationId xmlns:a16="http://schemas.microsoft.com/office/drawing/2014/main" id="{7956CB2A-50ED-419A-A4A4-5BCF7DC80C4D}"/>
               </a:ext>
             </a:extLst>
           </p:cNvPr>
@@ -7886,78 +7886,6 @@
         </p:nvSpPr>
         <p:spPr>
           <a:xfrm xmlns:a="http://schemas.openxmlformats.org/drawingml/2006/main">
-            <a:off x="17064000" y="29412000"/>
-            <a:ext cx="3888000" cy="360000"/>
-          </a:xfrm>
-          <a:prstGeom xmlns:a="http://schemas.openxmlformats.org/drawingml/2006/main" prst="rect">
-            <a:avLst/>
-          </a:prstGeom>
-          <a:noFill xmlns:a="http://schemas.openxmlformats.org/drawingml/2006/main"/>
-          <a:ln xmlns:a="http://schemas.openxmlformats.org/drawingml/2006/main" w="0">
-            <a:noFill/>
-          </a:ln>
-        </p:spPr>
-        <p:txBody>
-          <a:bodyPr xmlns:a="http://schemas.openxmlformats.org/drawingml/2006/main" wrap="square" lIns="0" tIns="0" rIns="0" bIns="0" anchor="t">
-            <a:noAutofit/>
-          </a:bodyPr>
-          <a:lstStyle xmlns:a="http://schemas.openxmlformats.org/drawingml/2006/main">
-            <a:defPPr algn="l">
-              <a:defRPr sz="2200" b="1" i="0">
-                <a:solidFill>
-                  <a:srgbClr val="1F4D36"/>
-                </a:solidFill>
-                <a:latin typeface="Calibri"/>
-                <a:ea typeface="Calibri"/>
-                <a:cs typeface="Calibri"/>
-              </a:defRPr>
-            </a:defPPr>
-          </a:lstStyle>
-          <a:p xmlns:a="http://schemas.openxmlformats.org/drawingml/2006/main">
-            <a:pPr algn="l">
-              <a:lnSpc>
-                <a:spcPct val="108000"/>
-              </a:lnSpc>
-              <a:buNone/>
-              <a:defRPr sz="2200" b="1" i="0">
-                <a:solidFill>
-                  <a:srgbClr val="1F4D36"/>
-                </a:solidFill>
-                <a:latin typeface="Calibri"/>
-                <a:ea typeface="Calibri"/>
-                <a:cs typeface="Calibri"/>
-              </a:defRPr>
-            </a:pPr>
-            <a:r>
-              <a:rPr sz="2200" b="1" i="0">
-                <a:solidFill>
-                  <a:srgbClr val="1F4D36"/>
-                </a:solidFill>
-                <a:latin typeface="Calibri"/>
-                <a:ea typeface="Calibri"/>
-                <a:cs typeface="Calibri"/>
-              </a:rPr>
-              <a:t>Contact</a:t>
-            </a:r>
-          </a:p>
-        </p:txBody>
-      </p:sp>
-      <p:sp>
-        <p:nvSpPr>
-          <p:cNvPr id="83" name="Contact detail">
-            <a:extLst xmlns:a="http://schemas.openxmlformats.org/drawingml/2006/main">
-              <a:ext uri="{FF2B5EF4-FFF2-40B4-BE49-F238E27FC236}">
-                <a16:creationId xmlns:a16="http://schemas.microsoft.com/office/drawing/2014/main" id="{E8A17DCB-269E-4CD8-81FA-0F0146D51030}"/>
-              </a:ext>
-            </a:extLst>
-          </p:cNvPr>
-          <p:cNvSpPr>
-            <a:spLocks xmlns:a="http://schemas.openxmlformats.org/drawingml/2006/main" noGrp="1"/>
-          </p:cNvSpPr>
-          <p:nvPr/>
-        </p:nvSpPr>
-        <p:spPr>
-          <a:xfrm xmlns:a="http://schemas.openxmlformats.org/drawingml/2006/main">
             <a:off x="17064000" y="29844000"/>
             <a:ext cx="3888000" cy="612000"/>
           </a:xfrm>
@@ -8044,7 +7972,7 @@
     </p:spTree>
     <p:extLst>
       <p:ext uri="{BB962C8B-B14F-4D97-AF65-F5344CB8AC3E}">
-        <p14:creationId xmlns:p14="http://schemas.microsoft.com/office/powerpoint/2010/main" val="774377587"/>
+        <p14:creationId xmlns:p14="http://schemas.microsoft.com/office/powerpoint/2010/main" val="47629251"/>
       </p:ext>
     </p:extLst>
   </p:cSld>

</xml_diff>